<commit_message>
Finalize authentic demo media and video draft
</commit_message>
<xml_diff>
--- a/docs/MEACompass_Competition_Deck.pptx
+++ b/docs/MEACompass_Competition_Deck.pptx
@@ -2,24 +2,24 @@
 <file path=ppt/presentation.xml><?xml version="1.0" encoding="utf-8"?>
 <p:presentation xmlns:p="http://schemas.openxmlformats.org/presentationml/2006/main">
   <p:sldMasterIdLst>
-    <p:sldMasterId xmlns:r="http://schemas.openxmlformats.org/officeDocument/2006/relationships" id="2147483648" r:id="Ra7c56639b18f4f3e"/>
+    <p:sldMasterId xmlns:r="http://schemas.openxmlformats.org/officeDocument/2006/relationships" id="2147483648" r:id="R6a44e003961d4257"/>
   </p:sldMasterIdLst>
   <p:notesMasterIdLst>
-    <p:notesMasterId xmlns:r="http://schemas.openxmlformats.org/officeDocument/2006/relationships" r:id="Rccf6a55e61914aed"/>
+    <p:notesMasterId xmlns:r="http://schemas.openxmlformats.org/officeDocument/2006/relationships" r:id="Rbafd9005dd394aa3"/>
   </p:notesMasterIdLst>
   <p:sldIdLst>
-    <p:sldId xmlns:r="http://schemas.openxmlformats.org/officeDocument/2006/relationships" id="256" r:id="R0b69fb44b725426f"/>
-    <p:sldId xmlns:r="http://schemas.openxmlformats.org/officeDocument/2006/relationships" id="257" r:id="R580c6355d2304e0d"/>
-    <p:sldId xmlns:r="http://schemas.openxmlformats.org/officeDocument/2006/relationships" id="258" r:id="Re29aa1ce60cd4b9e"/>
-    <p:sldId xmlns:r="http://schemas.openxmlformats.org/officeDocument/2006/relationships" id="259" r:id="Ra0d9b05d9c484c83"/>
-    <p:sldId xmlns:r="http://schemas.openxmlformats.org/officeDocument/2006/relationships" id="260" r:id="R022d530202aa4bb2"/>
-    <p:sldId xmlns:r="http://schemas.openxmlformats.org/officeDocument/2006/relationships" id="261" r:id="Rc12b877ffc214c6f"/>
-    <p:sldId xmlns:r="http://schemas.openxmlformats.org/officeDocument/2006/relationships" id="262" r:id="R021beab6f2054e2c"/>
-    <p:sldId xmlns:r="http://schemas.openxmlformats.org/officeDocument/2006/relationships" id="263" r:id="Rf013b8e00cb54ae7"/>
-    <p:sldId xmlns:r="http://schemas.openxmlformats.org/officeDocument/2006/relationships" id="264" r:id="R70bf5f2687e94591"/>
-    <p:sldId xmlns:r="http://schemas.openxmlformats.org/officeDocument/2006/relationships" id="265" r:id="Rc2d53566aa5e4ea0"/>
-    <p:sldId xmlns:r="http://schemas.openxmlformats.org/officeDocument/2006/relationships" id="266" r:id="Rbb4dc3df67c349bd"/>
-    <p:sldId xmlns:r="http://schemas.openxmlformats.org/officeDocument/2006/relationships" id="267" r:id="Radfa495f8b4d4f60"/>
+    <p:sldId xmlns:r="http://schemas.openxmlformats.org/officeDocument/2006/relationships" id="256" r:id="R8c0c34e6c93d4169"/>
+    <p:sldId xmlns:r="http://schemas.openxmlformats.org/officeDocument/2006/relationships" id="257" r:id="R61a8e7d5903a4806"/>
+    <p:sldId xmlns:r="http://schemas.openxmlformats.org/officeDocument/2006/relationships" id="258" r:id="Rfce4852b9b3d4658"/>
+    <p:sldId xmlns:r="http://schemas.openxmlformats.org/officeDocument/2006/relationships" id="259" r:id="Rbfe0d0b83af24af5"/>
+    <p:sldId xmlns:r="http://schemas.openxmlformats.org/officeDocument/2006/relationships" id="260" r:id="R46dd66fad02149a2"/>
+    <p:sldId xmlns:r="http://schemas.openxmlformats.org/officeDocument/2006/relationships" id="261" r:id="R83ef66e3c71146e9"/>
+    <p:sldId xmlns:r="http://schemas.openxmlformats.org/officeDocument/2006/relationships" id="262" r:id="R06b4ee4d70b344a2"/>
+    <p:sldId xmlns:r="http://schemas.openxmlformats.org/officeDocument/2006/relationships" id="263" r:id="R24d073bc68a94457"/>
+    <p:sldId xmlns:r="http://schemas.openxmlformats.org/officeDocument/2006/relationships" id="264" r:id="R25265ad27a934a88"/>
+    <p:sldId xmlns:r="http://schemas.openxmlformats.org/officeDocument/2006/relationships" id="265" r:id="Rba78e0c84e4643c7"/>
+    <p:sldId xmlns:r="http://schemas.openxmlformats.org/officeDocument/2006/relationships" id="266" r:id="R3e0060b04c454844"/>
+    <p:sldId xmlns:r="http://schemas.openxmlformats.org/officeDocument/2006/relationships" id="267" r:id="R46d1b70d78094fc7"/>
   </p:sldIdLst>
   <p:sldSz cx="12192000" cy="6858000"/>
   <p:notesSz cx="6858000" cy="9144000"/>
@@ -1292,7 +1292,7 @@
   </p:cSld>
   <p:clrMap bg1="lt1" tx1="dk1" bg2="lt2" tx2="dk2" accent1="accent1" accent2="accent2" accent3="accent3" accent4="accent4" accent5="accent5" accent6="accent6" hlink="hlink" folHlink="folHlink"/>
   <p:sldLayoutIdLst>
-    <p:sldLayoutId xmlns:r="http://schemas.openxmlformats.org/officeDocument/2006/relationships" id="2147483649" r:id="Rbb5dfde6686d414d"/>
+    <p:sldLayoutId xmlns:r="http://schemas.openxmlformats.org/officeDocument/2006/relationships" id="2147483649" r:id="Rdcb081adac644083"/>
   </p:sldLayoutIdLst>
   <p:txStyles>
     <p:titleStyle>
@@ -1598,7 +1598,7 @@
           <p:cNvPr id="1" name="kicker-marker">
             <a:extLst xmlns:a="http://schemas.openxmlformats.org/drawingml/2006/main">
               <a:ext uri="{FF2B5EF4-FFF2-40B4-BE49-F238E27FC236}">
-                <a16:creationId xmlns:a16="http://schemas.microsoft.com/office/drawing/2014/main" id="{784025B0-2406-4436-948C-07A044BAC816}"/>
+                <a16:creationId xmlns:a16="http://schemas.microsoft.com/office/drawing/2014/main" id="{8C796266-853E-49A0-B13D-207D844F30B5}"/>
               </a:ext>
             </a:extLst>
           </p:cNvPr>
@@ -1633,7 +1633,7 @@
           <p:cNvPr id="2" name="kicker-label">
             <a:extLst xmlns:a="http://schemas.openxmlformats.org/drawingml/2006/main">
               <a:ext uri="{FF2B5EF4-FFF2-40B4-BE49-F238E27FC236}">
-                <a16:creationId xmlns:a16="http://schemas.microsoft.com/office/drawing/2014/main" id="{0F58A607-2200-4E59-BC87-572C04026817}"/>
+                <a16:creationId xmlns:a16="http://schemas.microsoft.com/office/drawing/2014/main" id="{E63D25CA-3B29-46C4-9530-CAE045AB56E7}"/>
               </a:ext>
             </a:extLst>
           </p:cNvPr>
@@ -1690,7 +1690,7 @@
           <p:cNvPr id="3" name="">
             <a:extLst xmlns:a="http://schemas.openxmlformats.org/drawingml/2006/main">
               <a:ext uri="{FF2B5EF4-FFF2-40B4-BE49-F238E27FC236}">
-                <a16:creationId xmlns:a16="http://schemas.microsoft.com/office/drawing/2014/main" id="{1172ED2F-AE50-47C7-A9B9-4DAD0D596A95}"/>
+                <a16:creationId xmlns:a16="http://schemas.microsoft.com/office/drawing/2014/main" id="{787656A3-F586-4011-AFAD-AD27E687FFEC}"/>
               </a:ext>
             </a:extLst>
           </p:cNvPr>
@@ -1747,7 +1747,7 @@
           <p:cNvPr id="4" name="">
             <a:extLst xmlns:a="http://schemas.openxmlformats.org/drawingml/2006/main">
               <a:ext uri="{FF2B5EF4-FFF2-40B4-BE49-F238E27FC236}">
-                <a16:creationId xmlns:a16="http://schemas.microsoft.com/office/drawing/2014/main" id="{EF44CA94-BE09-4983-A45C-050641541CF8}"/>
+                <a16:creationId xmlns:a16="http://schemas.microsoft.com/office/drawing/2014/main" id="{74A23FAC-F7A4-4F1F-B113-060B1D9A2B05}"/>
               </a:ext>
             </a:extLst>
           </p:cNvPr>
@@ -1804,7 +1804,7 @@
           <p:cNvPr id="5" name="">
             <a:extLst xmlns:a="http://schemas.openxmlformats.org/drawingml/2006/main">
               <a:ext uri="{FF2B5EF4-FFF2-40B4-BE49-F238E27FC236}">
-                <a16:creationId xmlns:a16="http://schemas.microsoft.com/office/drawing/2014/main" id="{878F2B70-1CDB-4F00-8538-6C491F181170}"/>
+                <a16:creationId xmlns:a16="http://schemas.microsoft.com/office/drawing/2014/main" id="{976AA9D8-744B-4EE2-A630-1DFF7CCB54CB}"/>
               </a:ext>
             </a:extLst>
           </p:cNvPr>
@@ -1839,7 +1839,7 @@
           <p:cNvPr id="6" name="">
             <a:extLst xmlns:a="http://schemas.openxmlformats.org/drawingml/2006/main">
               <a:ext uri="{FF2B5EF4-FFF2-40B4-BE49-F238E27FC236}">
-                <a16:creationId xmlns:a16="http://schemas.microsoft.com/office/drawing/2014/main" id="{7AB87D2E-E444-4006-AD34-DA1330714413}"/>
+                <a16:creationId xmlns:a16="http://schemas.microsoft.com/office/drawing/2014/main" id="{7A7F4E34-DDB5-472A-9E7A-44F95DF1EECF}"/>
               </a:ext>
             </a:extLst>
           </p:cNvPr>
@@ -1896,7 +1896,7 @@
           <p:cNvPr id="7" name="">
             <a:extLst xmlns:a="http://schemas.openxmlformats.org/drawingml/2006/main">
               <a:ext uri="{FF2B5EF4-FFF2-40B4-BE49-F238E27FC236}">
-                <a16:creationId xmlns:a16="http://schemas.microsoft.com/office/drawing/2014/main" id="{1D0D93D1-E0EE-42B1-A535-766179C88161}"/>
+                <a16:creationId xmlns:a16="http://schemas.microsoft.com/office/drawing/2014/main" id="{654E337A-7277-4809-B10A-7FCDA249E7FD}"/>
               </a:ext>
             </a:extLst>
           </p:cNvPr>
@@ -1953,7 +1953,7 @@
           <p:cNvPr id="8" name="">
             <a:extLst xmlns:a="http://schemas.openxmlformats.org/drawingml/2006/main">
               <a:ext uri="{FF2B5EF4-FFF2-40B4-BE49-F238E27FC236}">
-                <a16:creationId xmlns:a16="http://schemas.microsoft.com/office/drawing/2014/main" id="{4EAA02A1-B82B-4080-9CAF-8802FE507786}"/>
+                <a16:creationId xmlns:a16="http://schemas.microsoft.com/office/drawing/2014/main" id="{DFA74248-110E-48A9-9A25-86307DCB42FB}"/>
               </a:ext>
             </a:extLst>
           </p:cNvPr>
@@ -2010,7 +2010,7 @@
           <p:cNvPr id="9" name="">
             <a:extLst xmlns:a="http://schemas.openxmlformats.org/drawingml/2006/main">
               <a:ext uri="{FF2B5EF4-FFF2-40B4-BE49-F238E27FC236}">
-                <a16:creationId xmlns:a16="http://schemas.microsoft.com/office/drawing/2014/main" id="{652076C8-7D39-4E29-BEF5-C476E1C50964}"/>
+                <a16:creationId xmlns:a16="http://schemas.microsoft.com/office/drawing/2014/main" id="{55ABC2D0-260B-42B1-9F0B-055A6165CB0F}"/>
               </a:ext>
             </a:extLst>
           </p:cNvPr>
@@ -2045,7 +2045,7 @@
           <p:cNvPr id="10" name="">
             <a:extLst xmlns:a="http://schemas.openxmlformats.org/drawingml/2006/main">
               <a:ext uri="{FF2B5EF4-FFF2-40B4-BE49-F238E27FC236}">
-                <a16:creationId xmlns:a16="http://schemas.microsoft.com/office/drawing/2014/main" id="{AC2EF137-D6F7-4D2E-AEBD-798F37ACB6D4}"/>
+                <a16:creationId xmlns:a16="http://schemas.microsoft.com/office/drawing/2014/main" id="{6AD864F7-2002-42ED-A243-FF42B7E792E3}"/>
               </a:ext>
             </a:extLst>
           </p:cNvPr>
@@ -2080,7 +2080,7 @@
           <p:cNvPr id="11" name="">
             <a:extLst xmlns:a="http://schemas.openxmlformats.org/drawingml/2006/main">
               <a:ext uri="{FF2B5EF4-FFF2-40B4-BE49-F238E27FC236}">
-                <a16:creationId xmlns:a16="http://schemas.microsoft.com/office/drawing/2014/main" id="{ED3E1FB5-B492-4BD1-8A3B-D6E9EAB21D37}"/>
+                <a16:creationId xmlns:a16="http://schemas.microsoft.com/office/drawing/2014/main" id="{9847312D-EC59-4095-AAE9-EB99F199934B}"/>
               </a:ext>
             </a:extLst>
           </p:cNvPr>
@@ -2137,7 +2137,7 @@
           <p:cNvPr id="12" name="">
             <a:extLst xmlns:a="http://schemas.openxmlformats.org/drawingml/2006/main">
               <a:ext uri="{FF2B5EF4-FFF2-40B4-BE49-F238E27FC236}">
-                <a16:creationId xmlns:a16="http://schemas.microsoft.com/office/drawing/2014/main" id="{604CD673-C561-4898-8BA0-6D9750136337}"/>
+                <a16:creationId xmlns:a16="http://schemas.microsoft.com/office/drawing/2014/main" id="{54A30356-9D82-4793-B896-9F730720A5E9}"/>
               </a:ext>
             </a:extLst>
           </p:cNvPr>
@@ -2172,7 +2172,7 @@
           <p:cNvPr id="13" name="">
             <a:extLst xmlns:a="http://schemas.openxmlformats.org/drawingml/2006/main">
               <a:ext uri="{FF2B5EF4-FFF2-40B4-BE49-F238E27FC236}">
-                <a16:creationId xmlns:a16="http://schemas.microsoft.com/office/drawing/2014/main" id="{2AD7132B-2610-454D-909C-7311B49275E6}"/>
+                <a16:creationId xmlns:a16="http://schemas.microsoft.com/office/drawing/2014/main" id="{AB4C2220-BE18-4A37-BC53-7ACE4BC23CD8}"/>
               </a:ext>
             </a:extLst>
           </p:cNvPr>
@@ -2207,7 +2207,7 @@
           <p:cNvPr id="14" name="">
             <a:extLst xmlns:a="http://schemas.openxmlformats.org/drawingml/2006/main">
               <a:ext uri="{FF2B5EF4-FFF2-40B4-BE49-F238E27FC236}">
-                <a16:creationId xmlns:a16="http://schemas.microsoft.com/office/drawing/2014/main" id="{3EB7BC88-C0E9-4354-934E-50867E0DAC8A}"/>
+                <a16:creationId xmlns:a16="http://schemas.microsoft.com/office/drawing/2014/main" id="{CB2FBAA1-33E3-4375-9F3B-D1835A0316AF}"/>
               </a:ext>
             </a:extLst>
           </p:cNvPr>
@@ -2264,7 +2264,7 @@
           <p:cNvPr id="15" name="">
             <a:extLst xmlns:a="http://schemas.openxmlformats.org/drawingml/2006/main">
               <a:ext uri="{FF2B5EF4-FFF2-40B4-BE49-F238E27FC236}">
-                <a16:creationId xmlns:a16="http://schemas.microsoft.com/office/drawing/2014/main" id="{4D897C00-B42D-4182-B7CC-D4FB6F03A6B3}"/>
+                <a16:creationId xmlns:a16="http://schemas.microsoft.com/office/drawing/2014/main" id="{78304881-2D86-43F1-9C80-7C8836285875}"/>
               </a:ext>
             </a:extLst>
           </p:cNvPr>
@@ -2299,7 +2299,7 @@
           <p:cNvPr id="16" name="">
             <a:extLst xmlns:a="http://schemas.openxmlformats.org/drawingml/2006/main">
               <a:ext uri="{FF2B5EF4-FFF2-40B4-BE49-F238E27FC236}">
-                <a16:creationId xmlns:a16="http://schemas.microsoft.com/office/drawing/2014/main" id="{49F9B804-8152-4912-8E68-B1A0C8542FC5}"/>
+                <a16:creationId xmlns:a16="http://schemas.microsoft.com/office/drawing/2014/main" id="{B380352E-41B9-4DAE-A7EB-1CA952333B79}"/>
               </a:ext>
             </a:extLst>
           </p:cNvPr>
@@ -2334,7 +2334,7 @@
           <p:cNvPr id="17" name="">
             <a:extLst xmlns:a="http://schemas.openxmlformats.org/drawingml/2006/main">
               <a:ext uri="{FF2B5EF4-FFF2-40B4-BE49-F238E27FC236}">
-                <a16:creationId xmlns:a16="http://schemas.microsoft.com/office/drawing/2014/main" id="{73A3819C-990D-4BD8-9E4D-6DB8019F74C4}"/>
+                <a16:creationId xmlns:a16="http://schemas.microsoft.com/office/drawing/2014/main" id="{5932EAE1-9430-4EC5-92C4-2E200C4C8782}"/>
               </a:ext>
             </a:extLst>
           </p:cNvPr>
@@ -2391,7 +2391,7 @@
           <p:cNvPr id="18" name="">
             <a:extLst xmlns:a="http://schemas.openxmlformats.org/drawingml/2006/main">
               <a:ext uri="{FF2B5EF4-FFF2-40B4-BE49-F238E27FC236}">
-                <a16:creationId xmlns:a16="http://schemas.microsoft.com/office/drawing/2014/main" id="{FE180F7E-7EF4-4283-83A3-123DF977EFA1}"/>
+                <a16:creationId xmlns:a16="http://schemas.microsoft.com/office/drawing/2014/main" id="{872BBBD8-BDC9-4769-B047-A48A4A54A8AB}"/>
               </a:ext>
             </a:extLst>
           </p:cNvPr>
@@ -2426,7 +2426,7 @@
           <p:cNvPr id="19" name="">
             <a:extLst xmlns:a="http://schemas.openxmlformats.org/drawingml/2006/main">
               <a:ext uri="{FF2B5EF4-FFF2-40B4-BE49-F238E27FC236}">
-                <a16:creationId xmlns:a16="http://schemas.microsoft.com/office/drawing/2014/main" id="{36936016-6E8C-44BF-8713-2C9BD97E8FF6}"/>
+                <a16:creationId xmlns:a16="http://schemas.microsoft.com/office/drawing/2014/main" id="{07DBBAF4-4E2A-474B-8A0F-B1243C2DE725}"/>
               </a:ext>
             </a:extLst>
           </p:cNvPr>
@@ -2483,7 +2483,7 @@
           <p:cNvPr id="20" name="">
             <a:extLst xmlns:a="http://schemas.openxmlformats.org/drawingml/2006/main">
               <a:ext uri="{FF2B5EF4-FFF2-40B4-BE49-F238E27FC236}">
-                <a16:creationId xmlns:a16="http://schemas.microsoft.com/office/drawing/2014/main" id="{5319B3E2-F734-46F5-9A78-B91F416F8E6A}"/>
+                <a16:creationId xmlns:a16="http://schemas.microsoft.com/office/drawing/2014/main" id="{F910AA5A-6AF0-48E0-AE98-28B6CDEC9213}"/>
               </a:ext>
             </a:extLst>
           </p:cNvPr>
@@ -2540,7 +2540,7 @@
           <p:cNvPr id="21" name="">
             <a:extLst xmlns:a="http://schemas.openxmlformats.org/drawingml/2006/main">
               <a:ext uri="{FF2B5EF4-FFF2-40B4-BE49-F238E27FC236}">
-                <a16:creationId xmlns:a16="http://schemas.microsoft.com/office/drawing/2014/main" id="{915C09DE-26B1-4399-8CC4-BE7D0DA3F931}"/>
+                <a16:creationId xmlns:a16="http://schemas.microsoft.com/office/drawing/2014/main" id="{F36C6EFB-11D5-45E1-BFE3-60984820E34A}"/>
               </a:ext>
             </a:extLst>
           </p:cNvPr>
@@ -2597,7 +2597,7 @@
           <p:cNvPr id="22" name="">
             <a:extLst xmlns:a="http://schemas.openxmlformats.org/drawingml/2006/main">
               <a:ext uri="{FF2B5EF4-FFF2-40B4-BE49-F238E27FC236}">
-                <a16:creationId xmlns:a16="http://schemas.microsoft.com/office/drawing/2014/main" id="{EE834BFC-3759-44C3-9073-2F52FC88F76D}"/>
+                <a16:creationId xmlns:a16="http://schemas.microsoft.com/office/drawing/2014/main" id="{DFA451B2-6A81-4AF2-BF9E-4CC1ED4DB5F4}"/>
               </a:ext>
             </a:extLst>
           </p:cNvPr>
@@ -2652,7 +2652,7 @@
     </p:spTree>
     <p:extLst>
       <p:ext uri="{BB962C8B-B14F-4D97-AF65-F5344CB8AC3E}">
-        <p14:creationId xmlns:p14="http://schemas.microsoft.com/office/powerpoint/2010/main" val="1794267242"/>
+        <p14:creationId xmlns:p14="http://schemas.microsoft.com/office/powerpoint/2010/main" val="1522709101"/>
       </p:ext>
     </p:extLst>
   </p:cSld>
@@ -2683,7 +2683,7 @@
           <p:cNvPr id="1" name="kicker-marker">
             <a:extLst xmlns:a="http://schemas.openxmlformats.org/drawingml/2006/main">
               <a:ext uri="{FF2B5EF4-FFF2-40B4-BE49-F238E27FC236}">
-                <a16:creationId xmlns:a16="http://schemas.microsoft.com/office/drawing/2014/main" id="{30E71C84-90E2-4180-A188-78D254609402}"/>
+                <a16:creationId xmlns:a16="http://schemas.microsoft.com/office/drawing/2014/main" id="{AF61F3F3-042D-440A-83C5-371853B5864C}"/>
               </a:ext>
             </a:extLst>
           </p:cNvPr>
@@ -2718,7 +2718,7 @@
           <p:cNvPr id="2" name="kicker-label">
             <a:extLst xmlns:a="http://schemas.openxmlformats.org/drawingml/2006/main">
               <a:ext uri="{FF2B5EF4-FFF2-40B4-BE49-F238E27FC236}">
-                <a16:creationId xmlns:a16="http://schemas.microsoft.com/office/drawing/2014/main" id="{F6D9ED39-7EF2-4181-907C-769ECC4CDFEF}"/>
+                <a16:creationId xmlns:a16="http://schemas.microsoft.com/office/drawing/2014/main" id="{503006A2-364A-4EBE-9BCD-77C3C743AAB7}"/>
               </a:ext>
             </a:extLst>
           </p:cNvPr>
@@ -2765,7 +2765,7 @@
                 <a:ea typeface="Aptos"/>
                 <a:cs typeface="Aptos"/>
               </a:rPr>
-              <a:t>WORKING INTERFACE</a:t>
+              <a:t>REAL PUBLIC DEMO</a:t>
             </a:r>
           </a:p>
         </p:txBody>
@@ -2775,7 +2775,7 @@
           <p:cNvPr id="3" name="">
             <a:extLst xmlns:a="http://schemas.openxmlformats.org/drawingml/2006/main">
               <a:ext uri="{FF2B5EF4-FFF2-40B4-BE49-F238E27FC236}">
-                <a16:creationId xmlns:a16="http://schemas.microsoft.com/office/drawing/2014/main" id="{412EF5BE-9BF1-4AAB-A66C-9960D3A7F339}"/>
+                <a16:creationId xmlns:a16="http://schemas.microsoft.com/office/drawing/2014/main" id="{68B6582D-06D9-435F-B68B-6B7AB33BD998}"/>
               </a:ext>
             </a:extLst>
           </p:cNvPr>
@@ -2832,7 +2832,7 @@
           <p:cNvPr id="4" name="">
             <a:extLst xmlns:a="http://schemas.openxmlformats.org/drawingml/2006/main">
               <a:ext uri="{FF2B5EF4-FFF2-40B4-BE49-F238E27FC236}">
-                <a16:creationId xmlns:a16="http://schemas.microsoft.com/office/drawing/2014/main" id="{7F34CBE1-08E9-4A8A-8C6D-C2B38B5F649D}"/>
+                <a16:creationId xmlns:a16="http://schemas.microsoft.com/office/drawing/2014/main" id="{FEF65446-3D74-4B04-978E-25679C0C3448}"/>
               </a:ext>
             </a:extLst>
           </p:cNvPr>
@@ -2867,7 +2867,7 @@
           <p:cNvPr id="5" name="">
             <a:extLst xmlns:a="http://schemas.openxmlformats.org/drawingml/2006/main">
               <a:ext uri="{FF2B5EF4-FFF2-40B4-BE49-F238E27FC236}">
-                <a16:creationId xmlns:a16="http://schemas.microsoft.com/office/drawing/2014/main" id="{696AD1B2-CA31-4C8A-8FA0-E33854AAB872}"/>
+                <a16:creationId xmlns:a16="http://schemas.microsoft.com/office/drawing/2014/main" id="{4659CC1F-933B-4F3C-85E1-CF7AA59337EA}"/>
               </a:ext>
             </a:extLst>
           </p:cNvPr>
@@ -2924,7 +2924,7 @@
           <p:cNvPr id="6" name="">
             <a:extLst xmlns:a="http://schemas.openxmlformats.org/drawingml/2006/main">
               <a:ext uri="{FF2B5EF4-FFF2-40B4-BE49-F238E27FC236}">
-                <a16:creationId xmlns:a16="http://schemas.microsoft.com/office/drawing/2014/main" id="{3D588B89-99F3-4AF4-A434-4BBE8AC062B5}"/>
+                <a16:creationId xmlns:a16="http://schemas.microsoft.com/office/drawing/2014/main" id="{7DB1BD83-D298-4D37-B727-44C5A1F6429F}"/>
               </a:ext>
             </a:extLst>
           </p:cNvPr>
@@ -2981,19 +2981,19 @@
           <p:cNvPr id="7" name="">
             <a:extLst xmlns:a="http://schemas.openxmlformats.org/drawingml/2006/main">
               <a:ext uri="{FF2B5EF4-FFF2-40B4-BE49-F238E27FC236}">
-                <a16:creationId xmlns:a16="http://schemas.microsoft.com/office/drawing/2014/main" id="{3535163B-00D2-4661-A96E-B45EBEFE168A}"/>
-              </a:ext>
-            </a:extLst>
-          </p:cNvPr>
-          <p:cNvSpPr>
-            <a:spLocks xmlns:a="http://schemas.openxmlformats.org/drawingml/2006/main" noGrp="1"/>
-          </p:cNvSpPr>
-          <p:nvPr/>
-        </p:nvSpPr>
-        <p:spPr>
-          <a:xfrm xmlns:a="http://schemas.openxmlformats.org/drawingml/2006/main">
-            <a:off x="685800" y="1866900"/>
-            <a:ext cx="10858500" cy="3714750"/>
+                <a16:creationId xmlns:a16="http://schemas.microsoft.com/office/drawing/2014/main" id="{A4DB546A-43B5-41FF-9EB2-51A6C705529D}"/>
+              </a:ext>
+            </a:extLst>
+          </p:cNvPr>
+          <p:cNvSpPr>
+            <a:spLocks xmlns:a="http://schemas.openxmlformats.org/drawingml/2006/main" noGrp="1"/>
+          </p:cNvSpPr>
+          <p:nvPr/>
+        </p:nvSpPr>
+        <p:spPr>
+          <a:xfrm xmlns:a="http://schemas.openxmlformats.org/drawingml/2006/main">
+            <a:off x="571500" y="1714500"/>
+            <a:ext cx="7962900" cy="4552950"/>
           </a:xfrm>
           <a:prstGeom xmlns:a="http://schemas.openxmlformats.org/drawingml/2006/main" prst="rect">
             <a:avLst/>
@@ -3009,24 +3009,49 @@
           </a:ln>
         </p:spPr>
       </p:sp>
-      <p:sp>
-        <p:nvSpPr>
-          <p:cNvPr id="8" name="">
-            <a:extLst xmlns:a="http://schemas.openxmlformats.org/drawingml/2006/main">
-              <a:ext uri="{FF2B5EF4-FFF2-40B4-BE49-F238E27FC236}">
-                <a16:creationId xmlns:a16="http://schemas.microsoft.com/office/drawing/2014/main" id="{8CE641FA-3995-4B1A-92DC-BCD2BE9F1485}"/>
-              </a:ext>
-            </a:extLst>
-          </p:cNvPr>
-          <p:cNvSpPr>
-            <a:spLocks xmlns:a="http://schemas.openxmlformats.org/drawingml/2006/main" noGrp="1"/>
-          </p:cNvSpPr>
-          <p:nvPr/>
-        </p:nvSpPr>
-        <p:spPr>
-          <a:xfrm xmlns:a="http://schemas.openxmlformats.org/drawingml/2006/main">
-            <a:off x="3333750" y="2905125"/>
-            <a:ext cx="5524500" cy="438150"/>
+      <p:pic>
+        <p:nvPicPr>
+          <p:cNvPr id="8" name="public-demo-capture"/>
+          <p:cNvPicPr>
+            <a:picLocks xmlns:a="http://schemas.openxmlformats.org/drawingml/2006/main" noChangeAspect="1"/>
+          </p:cNvPicPr>
+          <p:nvPr/>
+        </p:nvPicPr>
+        <p:blipFill>
+          <a:blip xmlns:r="http://schemas.openxmlformats.org/officeDocument/2006/relationships" xmlns:a="http://schemas.openxmlformats.org/drawingml/2006/main" r:embed="R0eb21e0640724af2"/>
+          <a:srcRect xmlns:a="http://schemas.openxmlformats.org/drawingml/2006/main" l="0" t="27" r="0" b="27"/>
+          <a:stretch xmlns:a="http://schemas.openxmlformats.org/drawingml/2006/main">
+            <a:fillRect l="0" t="0" r="0" b="0"/>
+          </a:stretch>
+        </p:blipFill>
+        <p:spPr>
+          <a:xfrm xmlns:a="http://schemas.openxmlformats.org/drawingml/2006/main">
+            <a:off x="628650" y="1771650"/>
+            <a:ext cx="7810500" cy="4391025"/>
+          </a:xfrm>
+          <a:prstGeom xmlns:a="http://schemas.openxmlformats.org/drawingml/2006/main" prst="rect">
+            <a:avLst/>
+          </a:prstGeom>
+        </p:spPr>
+      </p:pic>
+      <p:sp>
+        <p:nvSpPr>
+          <p:cNvPr id="9" name="">
+            <a:extLst xmlns:a="http://schemas.openxmlformats.org/drawingml/2006/main">
+              <a:ext uri="{FF2B5EF4-FFF2-40B4-BE49-F238E27FC236}">
+                <a16:creationId xmlns:a16="http://schemas.microsoft.com/office/drawing/2014/main" id="{CF343B1E-3371-4F64-9F42-B69A90433210}"/>
+              </a:ext>
+            </a:extLst>
+          </p:cNvPr>
+          <p:cNvSpPr>
+            <a:spLocks xmlns:a="http://schemas.openxmlformats.org/drawingml/2006/main" noGrp="1"/>
+          </p:cNvSpPr>
+          <p:nvPr/>
+        </p:nvSpPr>
+        <p:spPr>
+          <a:xfrm xmlns:a="http://schemas.openxmlformats.org/drawingml/2006/main">
+            <a:off x="8858250" y="1781175"/>
+            <a:ext cx="2667000" cy="228600"/>
           </a:xfrm>
           <a:prstGeom xmlns:a="http://schemas.openxmlformats.org/drawingml/2006/main" prst="rect">
             <a:avLst/>
@@ -3038,52 +3063,87 @@
           </a:bodyPr>
           <a:lstStyle xmlns:a="http://schemas.openxmlformats.org/drawingml/2006/main"/>
           <a:p xmlns:a="http://schemas.openxmlformats.org/drawingml/2006/main">
-            <a:pPr algn="ctr">
-              <a:lnSpc>
-                <a:spcPct val="100000"/>
-              </a:lnSpc>
-              <a:buNone/>
-              <a:defRPr sz="2100" b="1">
-                <a:solidFill>
-                  <a:srgbClr val="EF715E"/>
-                </a:solidFill>
-                <a:latin typeface="Georgia"/>
-                <a:ea typeface="Georgia"/>
-                <a:cs typeface="Georgia"/>
-              </a:defRPr>
-            </a:pPr>
-            <a:r>
-              <a:rPr sz="2100" b="1">
-                <a:solidFill>
-                  <a:srgbClr val="EF715E"/>
-                </a:solidFill>
-                <a:latin typeface="Georgia"/>
-                <a:ea typeface="Georgia"/>
-                <a:cs typeface="Georgia"/>
-              </a:rPr>
-              <a:t>REAL DEMO CAPTURE REQUIRED</a:t>
-            </a:r>
-          </a:p>
-        </p:txBody>
-      </p:sp>
-      <p:sp>
-        <p:nvSpPr>
-          <p:cNvPr id="9" name="">
-            <a:extLst xmlns:a="http://schemas.openxmlformats.org/drawingml/2006/main">
-              <a:ext uri="{FF2B5EF4-FFF2-40B4-BE49-F238E27FC236}">
-                <a16:creationId xmlns:a16="http://schemas.microsoft.com/office/drawing/2014/main" id="{9393C77F-B7A5-4F77-91D4-53A1F5C41284}"/>
-              </a:ext>
-            </a:extLst>
-          </p:cNvPr>
-          <p:cNvSpPr>
-            <a:spLocks xmlns:a="http://schemas.openxmlformats.org/drawingml/2006/main" noGrp="1"/>
-          </p:cNvSpPr>
-          <p:nvPr/>
-        </p:nvSpPr>
-        <p:spPr>
-          <a:xfrm xmlns:a="http://schemas.openxmlformats.org/drawingml/2006/main">
-            <a:off x="2476500" y="3571875"/>
-            <a:ext cx="7239000" cy="781050"/>
+            <a:pPr algn="r">
+              <a:lnSpc>
+                <a:spcPct val="100000"/>
+              </a:lnSpc>
+              <a:buNone/>
+              <a:defRPr sz="750" b="1">
+                <a:solidFill>
+                  <a:srgbClr val="49B8A8"/>
+                </a:solidFill>
+                <a:latin typeface="Aptos"/>
+                <a:ea typeface="Aptos"/>
+                <a:cs typeface="Aptos"/>
+              </a:defRPr>
+            </a:pPr>
+            <a:r>
+              <a:rPr sz="750" b="1">
+                <a:solidFill>
+                  <a:srgbClr val="49B8A8"/>
+                </a:solidFill>
+                <a:latin typeface="Aptos"/>
+                <a:ea typeface="Aptos"/>
+                <a:cs typeface="Aptos"/>
+              </a:rPr>
+              <a:t>LIVE • LOGGED OUT</a:t>
+            </a:r>
+          </a:p>
+        </p:txBody>
+      </p:sp>
+      <p:sp>
+        <p:nvSpPr>
+          <p:cNvPr id="10" name="">
+            <a:extLst xmlns:a="http://schemas.openxmlformats.org/drawingml/2006/main">
+              <a:ext uri="{FF2B5EF4-FFF2-40B4-BE49-F238E27FC236}">
+                <a16:creationId xmlns:a16="http://schemas.microsoft.com/office/drawing/2014/main" id="{CAFB3730-93FF-443D-B793-DFA9CB7896A1}"/>
+              </a:ext>
+            </a:extLst>
+          </p:cNvPr>
+          <p:cNvSpPr>
+            <a:spLocks xmlns:a="http://schemas.openxmlformats.org/drawingml/2006/main" noGrp="1"/>
+          </p:cNvSpPr>
+          <p:nvPr/>
+        </p:nvSpPr>
+        <p:spPr>
+          <a:xfrm xmlns:a="http://schemas.openxmlformats.org/drawingml/2006/main">
+            <a:off x="8877300" y="2133600"/>
+            <a:ext cx="2667000" cy="9525"/>
+          </a:xfrm>
+          <a:prstGeom xmlns:a="http://schemas.openxmlformats.org/drawingml/2006/main" prst="rect">
+            <a:avLst/>
+          </a:prstGeom>
+          <a:solidFill xmlns:a="http://schemas.openxmlformats.org/drawingml/2006/main">
+            <a:srgbClr val="30434D"/>
+          </a:solidFill>
+          <a:ln xmlns:a="http://schemas.openxmlformats.org/drawingml/2006/main" w="0">
+            <a:solidFill>
+              <a:srgbClr val="000000">
+                <a:alpha val="0"/>
+              </a:srgbClr>
+            </a:solidFill>
+            <a:prstDash val="solid"/>
+          </a:ln>
+        </p:spPr>
+      </p:sp>
+      <p:sp>
+        <p:nvSpPr>
+          <p:cNvPr id="11" name="">
+            <a:extLst xmlns:a="http://schemas.openxmlformats.org/drawingml/2006/main">
+              <a:ext uri="{FF2B5EF4-FFF2-40B4-BE49-F238E27FC236}">
+                <a16:creationId xmlns:a16="http://schemas.microsoft.com/office/drawing/2014/main" id="{2E78470A-2029-4317-9803-5F100B204526}"/>
+              </a:ext>
+            </a:extLst>
+          </p:cNvPr>
+          <p:cNvSpPr>
+            <a:spLocks xmlns:a="http://schemas.openxmlformats.org/drawingml/2006/main" noGrp="1"/>
+          </p:cNvSpPr>
+          <p:nvPr/>
+        </p:nvSpPr>
+        <p:spPr>
+          <a:xfrm xmlns:a="http://schemas.openxmlformats.org/drawingml/2006/main">
+            <a:off x="8858250" y="2371725"/>
+            <a:ext cx="2667000" cy="228600"/>
           </a:xfrm>
           <a:prstGeom xmlns:a="http://schemas.openxmlformats.org/drawingml/2006/main" prst="rect">
             <a:avLst/>
@@ -3095,52 +3155,52 @@
           </a:bodyPr>
           <a:lstStyle xmlns:a="http://schemas.openxmlformats.org/drawingml/2006/main"/>
           <a:p xmlns:a="http://schemas.openxmlformats.org/drawingml/2006/main">
-            <a:pPr algn="ctr">
-              <a:lnSpc>
-                <a:spcPct val="100000"/>
-              </a:lnSpc>
-              <a:buNone/>
-              <a:defRPr sz="1200" b="0">
-                <a:solidFill>
-                  <a:srgbClr val="52616A"/>
-                </a:solidFill>
-                <a:latin typeface="Aptos"/>
-                <a:ea typeface="Aptos"/>
-                <a:cs typeface="Aptos"/>
-              </a:defRPr>
-            </a:pPr>
-            <a:r>
-              <a:rPr sz="1200" b="0">
-                <a:solidFill>
-                  <a:srgbClr val="52616A"/>
-                </a:solidFill>
-                <a:latin typeface="Aptos"/>
-                <a:ea typeface="Aptos"/>
-                <a:cs typeface="Aptos"/>
-              </a:rPr>
-              <a:t>The local static demo is complete, but the mandated in-app browser connection was unavailable in this session. No fake screenshot has been substituted.</a:t>
-            </a:r>
-          </a:p>
-        </p:txBody>
-      </p:sp>
-      <p:sp>
-        <p:nvSpPr>
-          <p:cNvPr id="10" name="">
-            <a:extLst xmlns:a="http://schemas.openxmlformats.org/drawingml/2006/main">
-              <a:ext uri="{FF2B5EF4-FFF2-40B4-BE49-F238E27FC236}">
-                <a16:creationId xmlns:a16="http://schemas.microsoft.com/office/drawing/2014/main" id="{1B995D57-3A4E-4DEC-82B3-F14A5A6660FA}"/>
-              </a:ext>
-            </a:extLst>
-          </p:cNvPr>
-          <p:cNvSpPr>
-            <a:spLocks xmlns:a="http://schemas.openxmlformats.org/drawingml/2006/main" noGrp="1"/>
-          </p:cNvSpPr>
-          <p:nvPr/>
-        </p:nvSpPr>
-        <p:spPr>
-          <a:xfrm xmlns:a="http://schemas.openxmlformats.org/drawingml/2006/main">
-            <a:off x="2667000" y="4762500"/>
-            <a:ext cx="6858000" cy="285750"/>
+            <a:pPr algn="l">
+              <a:lnSpc>
+                <a:spcPct val="100000"/>
+              </a:lnSpc>
+              <a:buNone/>
+              <a:defRPr sz="900" b="1">
+                <a:solidFill>
+                  <a:srgbClr val="356EE6"/>
+                </a:solidFill>
+                <a:latin typeface="Aptos"/>
+                <a:ea typeface="Aptos"/>
+                <a:cs typeface="Aptos"/>
+              </a:defRPr>
+            </a:pPr>
+            <a:r>
+              <a:rPr sz="900" b="1">
+                <a:solidFill>
+                  <a:srgbClr val="356EE6"/>
+                </a:solidFill>
+                <a:latin typeface="Aptos"/>
+                <a:ea typeface="Aptos"/>
+                <a:cs typeface="Aptos"/>
+              </a:rPr>
+              <a:t>OBSERVED</a:t>
+            </a:r>
+          </a:p>
+        </p:txBody>
+      </p:sp>
+      <p:sp>
+        <p:nvSpPr>
+          <p:cNvPr id="12" name="">
+            <a:extLst xmlns:a="http://schemas.openxmlformats.org/drawingml/2006/main">
+              <a:ext uri="{FF2B5EF4-FFF2-40B4-BE49-F238E27FC236}">
+                <a16:creationId xmlns:a16="http://schemas.microsoft.com/office/drawing/2014/main" id="{5C8F7FF2-575D-407E-BE9B-EB740BE1024C}"/>
+              </a:ext>
+            </a:extLst>
+          </p:cNvPr>
+          <p:cNvSpPr>
+            <a:spLocks xmlns:a="http://schemas.openxmlformats.org/drawingml/2006/main" noGrp="1"/>
+          </p:cNvSpPr>
+          <p:nvPr/>
+        </p:nvSpPr>
+        <p:spPr>
+          <a:xfrm xmlns:a="http://schemas.openxmlformats.org/drawingml/2006/main">
+            <a:off x="8858250" y="2647950"/>
+            <a:ext cx="2667000" cy="285750"/>
           </a:xfrm>
           <a:prstGeom xmlns:a="http://schemas.openxmlformats.org/drawingml/2006/main" prst="rect">
             <a:avLst/>
@@ -3152,7 +3212,99 @@
           </a:bodyPr>
           <a:lstStyle xmlns:a="http://schemas.openxmlformats.org/drawingml/2006/main"/>
           <a:p xmlns:a="http://schemas.openxmlformats.org/drawingml/2006/main">
-            <a:pPr algn="ctr">
+            <a:pPr algn="l">
+              <a:lnSpc>
+                <a:spcPct val="100000"/>
+              </a:lnSpc>
+              <a:buNone/>
+              <a:defRPr sz="975" b="0">
+                <a:solidFill>
+                  <a:srgbClr val="FFFFFF"/>
+                </a:solidFill>
+                <a:latin typeface="Aptos"/>
+                <a:ea typeface="Aptos"/>
+                <a:cs typeface="Aptos"/>
+              </a:defRPr>
+            </a:pPr>
+            <a:r>
+              <a:rPr sz="975" b="0">
+                <a:solidFill>
+                  <a:srgbClr val="FFFFFF"/>
+                </a:solidFill>
+                <a:latin typeface="Aptos"/>
+                <a:ea typeface="Aptos"/>
+                <a:cs typeface="Aptos"/>
+              </a:rPr>
+              <a:t>early DIV5 + DIV7 evidence</a:t>
+            </a:r>
+          </a:p>
+        </p:txBody>
+      </p:sp>
+      <p:sp>
+        <p:nvSpPr>
+          <p:cNvPr id="13" name="">
+            <a:extLst xmlns:a="http://schemas.openxmlformats.org/drawingml/2006/main">
+              <a:ext uri="{FF2B5EF4-FFF2-40B4-BE49-F238E27FC236}">
+                <a16:creationId xmlns:a16="http://schemas.microsoft.com/office/drawing/2014/main" id="{E08C7F79-3DA8-486B-AFC2-AE5B90D0B9A0}"/>
+              </a:ext>
+            </a:extLst>
+          </p:cNvPr>
+          <p:cNvSpPr>
+            <a:spLocks xmlns:a="http://schemas.openxmlformats.org/drawingml/2006/main" noGrp="1"/>
+          </p:cNvSpPr>
+          <p:nvPr/>
+        </p:nvSpPr>
+        <p:spPr>
+          <a:xfrm xmlns:a="http://schemas.openxmlformats.org/drawingml/2006/main">
+            <a:off x="8877300" y="3124200"/>
+            <a:ext cx="2667000" cy="9525"/>
+          </a:xfrm>
+          <a:prstGeom xmlns:a="http://schemas.openxmlformats.org/drawingml/2006/main" prst="rect">
+            <a:avLst/>
+          </a:prstGeom>
+          <a:solidFill xmlns:a="http://schemas.openxmlformats.org/drawingml/2006/main">
+            <a:srgbClr val="30434D"/>
+          </a:solidFill>
+          <a:ln xmlns:a="http://schemas.openxmlformats.org/drawingml/2006/main" w="0">
+            <a:solidFill>
+              <a:srgbClr val="000000">
+                <a:alpha val="0"/>
+              </a:srgbClr>
+            </a:solidFill>
+            <a:prstDash val="solid"/>
+          </a:ln>
+        </p:spPr>
+      </p:sp>
+      <p:sp>
+        <p:nvSpPr>
+          <p:cNvPr id="14" name="">
+            <a:extLst xmlns:a="http://schemas.openxmlformats.org/drawingml/2006/main">
+              <a:ext uri="{FF2B5EF4-FFF2-40B4-BE49-F238E27FC236}">
+                <a16:creationId xmlns:a16="http://schemas.microsoft.com/office/drawing/2014/main" id="{F66E41B7-7F8A-460C-B375-4CC595350A7C}"/>
+              </a:ext>
+            </a:extLst>
+          </p:cNvPr>
+          <p:cNvSpPr>
+            <a:spLocks xmlns:a="http://schemas.openxmlformats.org/drawingml/2006/main" noGrp="1"/>
+          </p:cNvSpPr>
+          <p:nvPr/>
+        </p:nvSpPr>
+        <p:spPr>
+          <a:xfrm xmlns:a="http://schemas.openxmlformats.org/drawingml/2006/main">
+            <a:off x="8858250" y="3333750"/>
+            <a:ext cx="2667000" cy="228600"/>
+          </a:xfrm>
+          <a:prstGeom xmlns:a="http://schemas.openxmlformats.org/drawingml/2006/main" prst="rect">
+            <a:avLst/>
+          </a:prstGeom>
+        </p:spPr>
+        <p:txBody>
+          <a:bodyPr xmlns:a="http://schemas.openxmlformats.org/drawingml/2006/main" wrap="square" lIns="0" tIns="0" rIns="0" bIns="0" anchor="t">
+            <a:normAutofit fontScale="100000"/>
+          </a:bodyPr>
+          <a:lstStyle xmlns:a="http://schemas.openxmlformats.org/drawingml/2006/main"/>
+          <a:p xmlns:a="http://schemas.openxmlformats.org/drawingml/2006/main">
+            <a:pPr algn="l">
               <a:lnSpc>
                 <a:spcPct val="100000"/>
               </a:lnSpc>
@@ -3175,7 +3327,270 @@
                 <a:ea typeface="Aptos"/>
                 <a:cs typeface="Aptos"/>
               </a:rPr>
-              <a:t>docs/demo/index.html  •  precomputed held-out predictions  •  no external requests</a:t>
+              <a:t>PREDICTED</a:t>
+            </a:r>
+          </a:p>
+        </p:txBody>
+      </p:sp>
+      <p:sp>
+        <p:nvSpPr>
+          <p:cNvPr id="15" name="">
+            <a:extLst xmlns:a="http://schemas.openxmlformats.org/drawingml/2006/main">
+              <a:ext uri="{FF2B5EF4-FFF2-40B4-BE49-F238E27FC236}">
+                <a16:creationId xmlns:a16="http://schemas.microsoft.com/office/drawing/2014/main" id="{175C3B57-F79A-4218-A430-ED357DFDA1B5}"/>
+              </a:ext>
+            </a:extLst>
+          </p:cNvPr>
+          <p:cNvSpPr>
+            <a:spLocks xmlns:a="http://schemas.openxmlformats.org/drawingml/2006/main" noGrp="1"/>
+          </p:cNvSpPr>
+          <p:nvPr/>
+        </p:nvSpPr>
+        <p:spPr>
+          <a:xfrm xmlns:a="http://schemas.openxmlformats.org/drawingml/2006/main">
+            <a:off x="8858250" y="3609975"/>
+            <a:ext cx="2667000" cy="457200"/>
+          </a:xfrm>
+          <a:prstGeom xmlns:a="http://schemas.openxmlformats.org/drawingml/2006/main" prst="rect">
+            <a:avLst/>
+          </a:prstGeom>
+        </p:spPr>
+        <p:txBody>
+          <a:bodyPr xmlns:a="http://schemas.openxmlformats.org/drawingml/2006/main" wrap="square" lIns="0" tIns="0" rIns="0" bIns="0" anchor="t">
+            <a:normAutofit fontScale="100000"/>
+          </a:bodyPr>
+          <a:lstStyle xmlns:a="http://schemas.openxmlformats.org/drawingml/2006/main"/>
+          <a:p xmlns:a="http://schemas.openxmlformats.org/drawingml/2006/main">
+            <a:pPr algn="l">
+              <a:lnSpc>
+                <a:spcPct val="100000"/>
+              </a:lnSpc>
+              <a:buNone/>
+              <a:defRPr sz="975" b="0">
+                <a:solidFill>
+                  <a:srgbClr val="FFFFFF"/>
+                </a:solidFill>
+                <a:latin typeface="Aptos"/>
+                <a:ea typeface="Aptos"/>
+                <a:cs typeface="Aptos"/>
+              </a:defRPr>
+            </a:pPr>
+            <a:r>
+              <a:rPr sz="975" b="0">
+                <a:solidFill>
+                  <a:srgbClr val="FFFFFF"/>
+                </a:solidFill>
+                <a:latin typeface="Aptos"/>
+                <a:ea typeface="Aptos"/>
+                <a:cs typeface="Aptos"/>
+              </a:rPr>
+              <a:t>DIV12 forecast + nominal 90% interval</a:t>
+            </a:r>
+          </a:p>
+        </p:txBody>
+      </p:sp>
+      <p:sp>
+        <p:nvSpPr>
+          <p:cNvPr id="16" name="">
+            <a:extLst xmlns:a="http://schemas.openxmlformats.org/drawingml/2006/main">
+              <a:ext uri="{FF2B5EF4-FFF2-40B4-BE49-F238E27FC236}">
+                <a16:creationId xmlns:a16="http://schemas.microsoft.com/office/drawing/2014/main" id="{A1656302-5BAD-4AFE-B44F-078849FC4E3D}"/>
+              </a:ext>
+            </a:extLst>
+          </p:cNvPr>
+          <p:cNvSpPr>
+            <a:spLocks xmlns:a="http://schemas.openxmlformats.org/drawingml/2006/main" noGrp="1"/>
+          </p:cNvSpPr>
+          <p:nvPr/>
+        </p:nvSpPr>
+        <p:spPr>
+          <a:xfrm xmlns:a="http://schemas.openxmlformats.org/drawingml/2006/main">
+            <a:off x="8877300" y="4229100"/>
+            <a:ext cx="2667000" cy="9525"/>
+          </a:xfrm>
+          <a:prstGeom xmlns:a="http://schemas.openxmlformats.org/drawingml/2006/main" prst="rect">
+            <a:avLst/>
+          </a:prstGeom>
+          <a:solidFill xmlns:a="http://schemas.openxmlformats.org/drawingml/2006/main">
+            <a:srgbClr val="30434D"/>
+          </a:solidFill>
+          <a:ln xmlns:a="http://schemas.openxmlformats.org/drawingml/2006/main" w="0">
+            <a:solidFill>
+              <a:srgbClr val="000000">
+                <a:alpha val="0"/>
+              </a:srgbClr>
+            </a:solidFill>
+            <a:prstDash val="solid"/>
+          </a:ln>
+        </p:spPr>
+      </p:sp>
+      <p:sp>
+        <p:nvSpPr>
+          <p:cNvPr id="17" name="">
+            <a:extLst xmlns:a="http://schemas.openxmlformats.org/drawingml/2006/main">
+              <a:ext uri="{FF2B5EF4-FFF2-40B4-BE49-F238E27FC236}">
+                <a16:creationId xmlns:a16="http://schemas.microsoft.com/office/drawing/2014/main" id="{DCB0E698-83F3-469F-8E92-0C2196779FA8}"/>
+              </a:ext>
+            </a:extLst>
+          </p:cNvPr>
+          <p:cNvSpPr>
+            <a:spLocks xmlns:a="http://schemas.openxmlformats.org/drawingml/2006/main" noGrp="1"/>
+          </p:cNvSpPr>
+          <p:nvPr/>
+        </p:nvSpPr>
+        <p:spPr>
+          <a:xfrm xmlns:a="http://schemas.openxmlformats.org/drawingml/2006/main">
+            <a:off x="8858250" y="4467225"/>
+            <a:ext cx="2667000" cy="228600"/>
+          </a:xfrm>
+          <a:prstGeom xmlns:a="http://schemas.openxmlformats.org/drawingml/2006/main" prst="rect">
+            <a:avLst/>
+          </a:prstGeom>
+        </p:spPr>
+        <p:txBody>
+          <a:bodyPr xmlns:a="http://schemas.openxmlformats.org/drawingml/2006/main" wrap="square" lIns="0" tIns="0" rIns="0" bIns="0" anchor="t">
+            <a:normAutofit fontScale="100000"/>
+          </a:bodyPr>
+          <a:lstStyle xmlns:a="http://schemas.openxmlformats.org/drawingml/2006/main"/>
+          <a:p xmlns:a="http://schemas.openxmlformats.org/drawingml/2006/main">
+            <a:pPr algn="l">
+              <a:lnSpc>
+                <a:spcPct val="100000"/>
+              </a:lnSpc>
+              <a:buNone/>
+              <a:defRPr sz="900" b="1">
+                <a:solidFill>
+                  <a:srgbClr val="D9A431"/>
+                </a:solidFill>
+                <a:latin typeface="Aptos"/>
+                <a:ea typeface="Aptos"/>
+                <a:cs typeface="Aptos"/>
+              </a:defRPr>
+            </a:pPr>
+            <a:r>
+              <a:rPr sz="900" b="1">
+                <a:solidFill>
+                  <a:srgbClr val="D9A431"/>
+                </a:solidFill>
+                <a:latin typeface="Aptos"/>
+                <a:ea typeface="Aptos"/>
+                <a:cs typeface="Aptos"/>
+              </a:rPr>
+              <a:t>HYPOTHESIS</a:t>
+            </a:r>
+          </a:p>
+        </p:txBody>
+      </p:sp>
+      <p:sp>
+        <p:nvSpPr>
+          <p:cNvPr id="18" name="">
+            <a:extLst xmlns:a="http://schemas.openxmlformats.org/drawingml/2006/main">
+              <a:ext uri="{FF2B5EF4-FFF2-40B4-BE49-F238E27FC236}">
+                <a16:creationId xmlns:a16="http://schemas.microsoft.com/office/drawing/2014/main" id="{062ADBCD-BD99-4705-9855-47A1DF3A7540}"/>
+              </a:ext>
+            </a:extLst>
+          </p:cNvPr>
+          <p:cNvSpPr>
+            <a:spLocks xmlns:a="http://schemas.openxmlformats.org/drawingml/2006/main" noGrp="1"/>
+          </p:cNvSpPr>
+          <p:nvPr/>
+        </p:nvSpPr>
+        <p:spPr>
+          <a:xfrm xmlns:a="http://schemas.openxmlformats.org/drawingml/2006/main">
+            <a:off x="8858250" y="4743450"/>
+            <a:ext cx="2667000" cy="457200"/>
+          </a:xfrm>
+          <a:prstGeom xmlns:a="http://schemas.openxmlformats.org/drawingml/2006/main" prst="rect">
+            <a:avLst/>
+          </a:prstGeom>
+        </p:spPr>
+        <p:txBody>
+          <a:bodyPr xmlns:a="http://schemas.openxmlformats.org/drawingml/2006/main" wrap="square" lIns="0" tIns="0" rIns="0" bIns="0" anchor="t">
+            <a:normAutofit fontScale="100000"/>
+          </a:bodyPr>
+          <a:lstStyle xmlns:a="http://schemas.openxmlformats.org/drawingml/2006/main"/>
+          <a:p xmlns:a="http://schemas.openxmlformats.org/drawingml/2006/main">
+            <a:pPr algn="l">
+              <a:lnSpc>
+                <a:spcPct val="100000"/>
+              </a:lnSpc>
+              <a:buNone/>
+              <a:defRPr sz="975" b="0">
+                <a:solidFill>
+                  <a:srgbClr val="FFFFFF"/>
+                </a:solidFill>
+                <a:latin typeface="Aptos"/>
+                <a:ea typeface="Aptos"/>
+                <a:cs typeface="Aptos"/>
+              </a:defRPr>
+            </a:pPr>
+            <a:r>
+              <a:rPr sz="975" b="0">
+                <a:solidFill>
+                  <a:srgbClr val="FFFFFF"/>
+                </a:solidFill>
+                <a:latin typeface="Aptos"/>
+                <a:ea typeface="Aptos"/>
+                <a:cs typeface="Aptos"/>
+              </a:rPr>
+              <a:t>future OoC transfer remains unvalidated</a:t>
+            </a:r>
+          </a:p>
+        </p:txBody>
+      </p:sp>
+      <p:sp>
+        <p:nvSpPr>
+          <p:cNvPr id="19" name="">
+            <a:extLst xmlns:a="http://schemas.openxmlformats.org/drawingml/2006/main">
+              <a:ext uri="{FF2B5EF4-FFF2-40B4-BE49-F238E27FC236}">
+                <a16:creationId xmlns:a16="http://schemas.microsoft.com/office/drawing/2014/main" id="{99EB03DF-A60A-4158-940C-5C08F67E657C}"/>
+              </a:ext>
+            </a:extLst>
+          </p:cNvPr>
+          <p:cNvSpPr>
+            <a:spLocks xmlns:a="http://schemas.openxmlformats.org/drawingml/2006/main" noGrp="1"/>
+          </p:cNvSpPr>
+          <p:nvPr/>
+        </p:nvSpPr>
+        <p:spPr>
+          <a:xfrm xmlns:a="http://schemas.openxmlformats.org/drawingml/2006/main">
+            <a:off x="8858250" y="5572125"/>
+            <a:ext cx="2667000" cy="400050"/>
+          </a:xfrm>
+          <a:prstGeom xmlns:a="http://schemas.openxmlformats.org/drawingml/2006/main" prst="rect">
+            <a:avLst/>
+          </a:prstGeom>
+        </p:spPr>
+        <p:txBody>
+          <a:bodyPr xmlns:a="http://schemas.openxmlformats.org/drawingml/2006/main" wrap="square" lIns="0" tIns="0" rIns="0" bIns="0" anchor="t">
+            <a:normAutofit fontScale="100000"/>
+          </a:bodyPr>
+          <a:lstStyle xmlns:a="http://schemas.openxmlformats.org/drawingml/2006/main"/>
+          <a:p xmlns:a="http://schemas.openxmlformats.org/drawingml/2006/main">
+            <a:pPr algn="l">
+              <a:lnSpc>
+                <a:spcPct val="100000"/>
+              </a:lnSpc>
+              <a:buNone/>
+              <a:defRPr sz="750" b="0">
+                <a:solidFill>
+                  <a:srgbClr val="AEBBC2"/>
+                </a:solidFill>
+                <a:latin typeface="Aptos"/>
+                <a:ea typeface="Aptos"/>
+                <a:cs typeface="Aptos"/>
+              </a:defRPr>
+            </a:pPr>
+            <a:r>
+              <a:rPr sz="750" b="0">
+                <a:solidFill>
+                  <a:srgbClr val="AEBBC2"/>
+                </a:solidFill>
+                <a:latin typeface="Aptos"/>
+                <a:ea typeface="Aptos"/>
+                <a:cs typeface="Aptos"/>
+              </a:rPr>
+              <a:t>Precomputed held-out predictions • no training • no external requests</a:t>
             </a:r>
           </a:p>
         </p:txBody>
@@ -3183,7 +3598,7 @@
     </p:spTree>
     <p:extLst>
       <p:ext uri="{BB962C8B-B14F-4D97-AF65-F5344CB8AC3E}">
-        <p14:creationId xmlns:p14="http://schemas.microsoft.com/office/powerpoint/2010/main" val="1283608826"/>
+        <p14:creationId xmlns:p14="http://schemas.microsoft.com/office/powerpoint/2010/main" val="654862514"/>
       </p:ext>
     </p:extLst>
   </p:cSld>
@@ -3214,7 +3629,7 @@
           <p:cNvPr id="1" name="kicker-marker">
             <a:extLst xmlns:a="http://schemas.openxmlformats.org/drawingml/2006/main">
               <a:ext uri="{FF2B5EF4-FFF2-40B4-BE49-F238E27FC236}">
-                <a16:creationId xmlns:a16="http://schemas.microsoft.com/office/drawing/2014/main" id="{388FBB5A-C3DD-4E30-9FB4-878AC2221FD8}"/>
+                <a16:creationId xmlns:a16="http://schemas.microsoft.com/office/drawing/2014/main" id="{D9DBB136-F866-48E4-B08D-1763A346CA21}"/>
               </a:ext>
             </a:extLst>
           </p:cNvPr>
@@ -3249,7 +3664,7 @@
           <p:cNvPr id="2" name="kicker-label">
             <a:extLst xmlns:a="http://schemas.openxmlformats.org/drawingml/2006/main">
               <a:ext uri="{FF2B5EF4-FFF2-40B4-BE49-F238E27FC236}">
-                <a16:creationId xmlns:a16="http://schemas.microsoft.com/office/drawing/2014/main" id="{66A01CD5-1E9F-4CDF-99FF-564B9F616F6F}"/>
+                <a16:creationId xmlns:a16="http://schemas.microsoft.com/office/drawing/2014/main" id="{683E8055-A348-4680-94DC-EA778FB1BA23}"/>
               </a:ext>
             </a:extLst>
           </p:cNvPr>
@@ -3306,7 +3721,7 @@
           <p:cNvPr id="3" name="">
             <a:extLst xmlns:a="http://schemas.openxmlformats.org/drawingml/2006/main">
               <a:ext uri="{FF2B5EF4-FFF2-40B4-BE49-F238E27FC236}">
-                <a16:creationId xmlns:a16="http://schemas.microsoft.com/office/drawing/2014/main" id="{793F1B90-E067-41AE-9CF5-365010AEFC8A}"/>
+                <a16:creationId xmlns:a16="http://schemas.microsoft.com/office/drawing/2014/main" id="{993224A7-6798-4B49-8E53-67C5C3C4973C}"/>
               </a:ext>
             </a:extLst>
           </p:cNvPr>
@@ -3363,7 +3778,7 @@
           <p:cNvPr id="4" name="">
             <a:extLst xmlns:a="http://schemas.openxmlformats.org/drawingml/2006/main">
               <a:ext uri="{FF2B5EF4-FFF2-40B4-BE49-F238E27FC236}">
-                <a16:creationId xmlns:a16="http://schemas.microsoft.com/office/drawing/2014/main" id="{77705CA0-077A-4A98-92F2-48B7928B4F63}"/>
+                <a16:creationId xmlns:a16="http://schemas.microsoft.com/office/drawing/2014/main" id="{A295C48C-D50C-4E79-9B93-F0CA5C7C27B9}"/>
               </a:ext>
             </a:extLst>
           </p:cNvPr>
@@ -3398,7 +3813,7 @@
           <p:cNvPr id="5" name="">
             <a:extLst xmlns:a="http://schemas.openxmlformats.org/drawingml/2006/main">
               <a:ext uri="{FF2B5EF4-FFF2-40B4-BE49-F238E27FC236}">
-                <a16:creationId xmlns:a16="http://schemas.microsoft.com/office/drawing/2014/main" id="{875FCB99-0CD0-474D-84B3-8E09BB62B75B}"/>
+                <a16:creationId xmlns:a16="http://schemas.microsoft.com/office/drawing/2014/main" id="{16A6A38B-8BA7-4891-948F-9F57F3AC9759}"/>
               </a:ext>
             </a:extLst>
           </p:cNvPr>
@@ -3455,7 +3870,7 @@
           <p:cNvPr id="6" name="">
             <a:extLst xmlns:a="http://schemas.openxmlformats.org/drawingml/2006/main">
               <a:ext uri="{FF2B5EF4-FFF2-40B4-BE49-F238E27FC236}">
-                <a16:creationId xmlns:a16="http://schemas.microsoft.com/office/drawing/2014/main" id="{0A336433-54DF-49B9-9BB2-C7E86BFDFFBC}"/>
+                <a16:creationId xmlns:a16="http://schemas.microsoft.com/office/drawing/2014/main" id="{FADBB44C-866B-49D1-BC5B-043F28989B76}"/>
               </a:ext>
             </a:extLst>
           </p:cNvPr>
@@ -3512,7 +3927,7 @@
           <p:cNvPr id="7" name="">
             <a:extLst xmlns:a="http://schemas.openxmlformats.org/drawingml/2006/main">
               <a:ext uri="{FF2B5EF4-FFF2-40B4-BE49-F238E27FC236}">
-                <a16:creationId xmlns:a16="http://schemas.microsoft.com/office/drawing/2014/main" id="{F6D66E3D-F61C-42CA-A91B-2194B8E4AC9D}"/>
+                <a16:creationId xmlns:a16="http://schemas.microsoft.com/office/drawing/2014/main" id="{28DE2057-2BE7-48C8-A492-DE168F3A2E14}"/>
               </a:ext>
             </a:extLst>
           </p:cNvPr>
@@ -3547,7 +3962,7 @@
           <p:cNvPr id="8" name="">
             <a:extLst xmlns:a="http://schemas.openxmlformats.org/drawingml/2006/main">
               <a:ext uri="{FF2B5EF4-FFF2-40B4-BE49-F238E27FC236}">
-                <a16:creationId xmlns:a16="http://schemas.microsoft.com/office/drawing/2014/main" id="{22C51958-3FBC-4A29-AAD2-A613A9B8E8BE}"/>
+                <a16:creationId xmlns:a16="http://schemas.microsoft.com/office/drawing/2014/main" id="{6C858C9F-719C-4848-8D3F-00FAEEA07172}"/>
               </a:ext>
             </a:extLst>
           </p:cNvPr>
@@ -3604,7 +4019,7 @@
           <p:cNvPr id="9" name="">
             <a:extLst xmlns:a="http://schemas.openxmlformats.org/drawingml/2006/main">
               <a:ext uri="{FF2B5EF4-FFF2-40B4-BE49-F238E27FC236}">
-                <a16:creationId xmlns:a16="http://schemas.microsoft.com/office/drawing/2014/main" id="{1C67ADF6-0DFA-4751-92C8-D776B03856AA}"/>
+                <a16:creationId xmlns:a16="http://schemas.microsoft.com/office/drawing/2014/main" id="{18365412-4DA0-4628-BBD1-9EB83A97F3D1}"/>
               </a:ext>
             </a:extLst>
           </p:cNvPr>
@@ -3661,7 +4076,7 @@
           <p:cNvPr id="10" name="">
             <a:extLst xmlns:a="http://schemas.openxmlformats.org/drawingml/2006/main">
               <a:ext uri="{FF2B5EF4-FFF2-40B4-BE49-F238E27FC236}">
-                <a16:creationId xmlns:a16="http://schemas.microsoft.com/office/drawing/2014/main" id="{CC9CBA86-ABEF-46EB-A153-FE2B1AFD2ABE}"/>
+                <a16:creationId xmlns:a16="http://schemas.microsoft.com/office/drawing/2014/main" id="{B269EE13-CC46-4F75-BA15-681674A4BA4D}"/>
               </a:ext>
             </a:extLst>
           </p:cNvPr>
@@ -3718,7 +4133,7 @@
           <p:cNvPr id="11" name="">
             <a:extLst xmlns:a="http://schemas.openxmlformats.org/drawingml/2006/main">
               <a:ext uri="{FF2B5EF4-FFF2-40B4-BE49-F238E27FC236}">
-                <a16:creationId xmlns:a16="http://schemas.microsoft.com/office/drawing/2014/main" id="{B13A2216-71FD-4813-837B-23A9816EB670}"/>
+                <a16:creationId xmlns:a16="http://schemas.microsoft.com/office/drawing/2014/main" id="{ED9A87C0-1C02-4673-AFE8-FA440C90A6B5}"/>
               </a:ext>
             </a:extLst>
           </p:cNvPr>
@@ -3775,7 +4190,7 @@
           <p:cNvPr id="12" name="">
             <a:extLst xmlns:a="http://schemas.openxmlformats.org/drawingml/2006/main">
               <a:ext uri="{FF2B5EF4-FFF2-40B4-BE49-F238E27FC236}">
-                <a16:creationId xmlns:a16="http://schemas.microsoft.com/office/drawing/2014/main" id="{5FAC2A56-717F-4336-9B93-4ED99371DE0A}"/>
+                <a16:creationId xmlns:a16="http://schemas.microsoft.com/office/drawing/2014/main" id="{C65B788A-4DB5-49CA-9950-8B0F744C7060}"/>
               </a:ext>
             </a:extLst>
           </p:cNvPr>
@@ -3832,7 +4247,7 @@
           <p:cNvPr id="13" name="">
             <a:extLst xmlns:a="http://schemas.openxmlformats.org/drawingml/2006/main">
               <a:ext uri="{FF2B5EF4-FFF2-40B4-BE49-F238E27FC236}">
-                <a16:creationId xmlns:a16="http://schemas.microsoft.com/office/drawing/2014/main" id="{20841291-96CA-4E1A-87B4-D83973602BD2}"/>
+                <a16:creationId xmlns:a16="http://schemas.microsoft.com/office/drawing/2014/main" id="{1CF261DB-6F08-4A89-B2A5-5A393F419C95}"/>
               </a:ext>
             </a:extLst>
           </p:cNvPr>
@@ -3889,7 +4304,7 @@
           <p:cNvPr id="14" name="">
             <a:extLst xmlns:a="http://schemas.openxmlformats.org/drawingml/2006/main">
               <a:ext uri="{FF2B5EF4-FFF2-40B4-BE49-F238E27FC236}">
-                <a16:creationId xmlns:a16="http://schemas.microsoft.com/office/drawing/2014/main" id="{0F4CA6F5-5D54-48E1-A994-2A78FCFCD32C}"/>
+                <a16:creationId xmlns:a16="http://schemas.microsoft.com/office/drawing/2014/main" id="{46491276-B825-4152-A3C4-1CD6814A94C4}"/>
               </a:ext>
             </a:extLst>
           </p:cNvPr>
@@ -3946,7 +4361,7 @@
           <p:cNvPr id="15" name="">
             <a:extLst xmlns:a="http://schemas.openxmlformats.org/drawingml/2006/main">
               <a:ext uri="{FF2B5EF4-FFF2-40B4-BE49-F238E27FC236}">
-                <a16:creationId xmlns:a16="http://schemas.microsoft.com/office/drawing/2014/main" id="{D417CD5D-E035-4607-A156-84391DD7C14D}"/>
+                <a16:creationId xmlns:a16="http://schemas.microsoft.com/office/drawing/2014/main" id="{B117A981-B9DF-4DD0-9DFF-335B00ED26E7}"/>
               </a:ext>
             </a:extLst>
           </p:cNvPr>
@@ -4003,7 +4418,7 @@
           <p:cNvPr id="16" name="">
             <a:extLst xmlns:a="http://schemas.openxmlformats.org/drawingml/2006/main">
               <a:ext uri="{FF2B5EF4-FFF2-40B4-BE49-F238E27FC236}">
-                <a16:creationId xmlns:a16="http://schemas.microsoft.com/office/drawing/2014/main" id="{C67D4889-354A-4C45-99B0-11D2FB19F40E}"/>
+                <a16:creationId xmlns:a16="http://schemas.microsoft.com/office/drawing/2014/main" id="{3B67E229-8DB0-41C5-BD45-B5EB9E7743D8}"/>
               </a:ext>
             </a:extLst>
           </p:cNvPr>
@@ -4036,7 +4451,7 @@
           <p:cNvPr id="17" name="">
             <a:extLst xmlns:a="http://schemas.openxmlformats.org/drawingml/2006/main">
               <a:ext uri="{FF2B5EF4-FFF2-40B4-BE49-F238E27FC236}">
-                <a16:creationId xmlns:a16="http://schemas.microsoft.com/office/drawing/2014/main" id="{48A22D2C-10AF-401C-AED2-982CE6253107}"/>
+                <a16:creationId xmlns:a16="http://schemas.microsoft.com/office/drawing/2014/main" id="{F73E863A-8A19-4FB8-A391-6559AB510A1D}"/>
               </a:ext>
             </a:extLst>
           </p:cNvPr>
@@ -4093,7 +4508,7 @@
           <p:cNvPr id="18" name="">
             <a:extLst xmlns:a="http://schemas.openxmlformats.org/drawingml/2006/main">
               <a:ext uri="{FF2B5EF4-FFF2-40B4-BE49-F238E27FC236}">
-                <a16:creationId xmlns:a16="http://schemas.microsoft.com/office/drawing/2014/main" id="{EFCB9CA7-C86A-4E8D-9893-6DFB6F9F31A1}"/>
+                <a16:creationId xmlns:a16="http://schemas.microsoft.com/office/drawing/2014/main" id="{0F8D165A-D72B-4140-AAD7-646071EB458A}"/>
               </a:ext>
             </a:extLst>
           </p:cNvPr>
@@ -4150,7 +4565,7 @@
           <p:cNvPr id="19" name="">
             <a:extLst xmlns:a="http://schemas.openxmlformats.org/drawingml/2006/main">
               <a:ext uri="{FF2B5EF4-FFF2-40B4-BE49-F238E27FC236}">
-                <a16:creationId xmlns:a16="http://schemas.microsoft.com/office/drawing/2014/main" id="{BE79A1D5-6854-44C2-B01D-F087BB254401}"/>
+                <a16:creationId xmlns:a16="http://schemas.microsoft.com/office/drawing/2014/main" id="{6020F522-2CD7-4892-88FF-29AEAA34292F}"/>
               </a:ext>
             </a:extLst>
           </p:cNvPr>
@@ -4183,7 +4598,7 @@
           <p:cNvPr id="20" name="">
             <a:extLst xmlns:a="http://schemas.openxmlformats.org/drawingml/2006/main">
               <a:ext uri="{FF2B5EF4-FFF2-40B4-BE49-F238E27FC236}">
-                <a16:creationId xmlns:a16="http://schemas.microsoft.com/office/drawing/2014/main" id="{D11936DA-62B1-488D-97AC-8686202152F5}"/>
+                <a16:creationId xmlns:a16="http://schemas.microsoft.com/office/drawing/2014/main" id="{08C6AAB9-E358-4692-A052-FA3A9BEA8CC1}"/>
               </a:ext>
             </a:extLst>
           </p:cNvPr>
@@ -4240,7 +4655,7 @@
           <p:cNvPr id="21" name="">
             <a:extLst xmlns:a="http://schemas.openxmlformats.org/drawingml/2006/main">
               <a:ext uri="{FF2B5EF4-FFF2-40B4-BE49-F238E27FC236}">
-                <a16:creationId xmlns:a16="http://schemas.microsoft.com/office/drawing/2014/main" id="{F1195B42-A3DC-4EF6-BE94-8C55D3D3A1A5}"/>
+                <a16:creationId xmlns:a16="http://schemas.microsoft.com/office/drawing/2014/main" id="{3264363F-FACC-419B-AA73-9651B9744E07}"/>
               </a:ext>
             </a:extLst>
           </p:cNvPr>
@@ -4297,7 +4712,7 @@
           <p:cNvPr id="22" name="">
             <a:extLst xmlns:a="http://schemas.openxmlformats.org/drawingml/2006/main">
               <a:ext uri="{FF2B5EF4-FFF2-40B4-BE49-F238E27FC236}">
-                <a16:creationId xmlns:a16="http://schemas.microsoft.com/office/drawing/2014/main" id="{5177D7C6-93DD-4CE9-AC49-D406C2942468}"/>
+                <a16:creationId xmlns:a16="http://schemas.microsoft.com/office/drawing/2014/main" id="{EE13FCFE-846B-4F0B-887E-047AC0B6C60D}"/>
               </a:ext>
             </a:extLst>
           </p:cNvPr>
@@ -4330,7 +4745,7 @@
           <p:cNvPr id="23" name="">
             <a:extLst xmlns:a="http://schemas.openxmlformats.org/drawingml/2006/main">
               <a:ext uri="{FF2B5EF4-FFF2-40B4-BE49-F238E27FC236}">
-                <a16:creationId xmlns:a16="http://schemas.microsoft.com/office/drawing/2014/main" id="{33CEB882-247D-403A-AD6C-9D76DF37AF9A}"/>
+                <a16:creationId xmlns:a16="http://schemas.microsoft.com/office/drawing/2014/main" id="{CE709D7E-1829-4C4B-9804-337BE92463C1}"/>
               </a:ext>
             </a:extLst>
           </p:cNvPr>
@@ -4387,7 +4802,7 @@
           <p:cNvPr id="24" name="">
             <a:extLst xmlns:a="http://schemas.openxmlformats.org/drawingml/2006/main">
               <a:ext uri="{FF2B5EF4-FFF2-40B4-BE49-F238E27FC236}">
-                <a16:creationId xmlns:a16="http://schemas.microsoft.com/office/drawing/2014/main" id="{CA78DC5C-BA21-405A-8507-60E43ED8F7DF}"/>
+                <a16:creationId xmlns:a16="http://schemas.microsoft.com/office/drawing/2014/main" id="{5344FD8A-699C-4217-81EB-9E04448AD6C4}"/>
               </a:ext>
             </a:extLst>
           </p:cNvPr>
@@ -4444,7 +4859,7 @@
           <p:cNvPr id="25" name="">
             <a:extLst xmlns:a="http://schemas.openxmlformats.org/drawingml/2006/main">
               <a:ext uri="{FF2B5EF4-FFF2-40B4-BE49-F238E27FC236}">
-                <a16:creationId xmlns:a16="http://schemas.microsoft.com/office/drawing/2014/main" id="{188C1E4A-2830-4F52-A0BA-55C549495DD4}"/>
+                <a16:creationId xmlns:a16="http://schemas.microsoft.com/office/drawing/2014/main" id="{4971253F-E991-476F-85F7-923440319074}"/>
               </a:ext>
             </a:extLst>
           </p:cNvPr>
@@ -4477,7 +4892,7 @@
           <p:cNvPr id="26" name="">
             <a:extLst xmlns:a="http://schemas.openxmlformats.org/drawingml/2006/main">
               <a:ext uri="{FF2B5EF4-FFF2-40B4-BE49-F238E27FC236}">
-                <a16:creationId xmlns:a16="http://schemas.microsoft.com/office/drawing/2014/main" id="{F6156B72-A8DB-4A75-B753-1FFAB8FF9BD8}"/>
+                <a16:creationId xmlns:a16="http://schemas.microsoft.com/office/drawing/2014/main" id="{98B591E6-522F-4CAB-A4F4-11CEEA7BC474}"/>
               </a:ext>
             </a:extLst>
           </p:cNvPr>
@@ -4534,7 +4949,7 @@
           <p:cNvPr id="27" name="">
             <a:extLst xmlns:a="http://schemas.openxmlformats.org/drawingml/2006/main">
               <a:ext uri="{FF2B5EF4-FFF2-40B4-BE49-F238E27FC236}">
-                <a16:creationId xmlns:a16="http://schemas.microsoft.com/office/drawing/2014/main" id="{31533387-F918-42DD-9DF9-25FAED1C4C5D}"/>
+                <a16:creationId xmlns:a16="http://schemas.microsoft.com/office/drawing/2014/main" id="{65120775-F762-47F1-8D1F-824F82D2F699}"/>
               </a:ext>
             </a:extLst>
           </p:cNvPr>
@@ -4591,7 +5006,7 @@
           <p:cNvPr id="28" name="">
             <a:extLst xmlns:a="http://schemas.openxmlformats.org/drawingml/2006/main">
               <a:ext uri="{FF2B5EF4-FFF2-40B4-BE49-F238E27FC236}">
-                <a16:creationId xmlns:a16="http://schemas.microsoft.com/office/drawing/2014/main" id="{BE3175AC-2932-4CED-A47D-D36F30CD1F2E}"/>
+                <a16:creationId xmlns:a16="http://schemas.microsoft.com/office/drawing/2014/main" id="{3BE38170-7AB4-4015-A1F3-E7215E7AC556}"/>
               </a:ext>
             </a:extLst>
           </p:cNvPr>
@@ -4646,7 +5061,7 @@
     </p:spTree>
     <p:extLst>
       <p:ext uri="{BB962C8B-B14F-4D97-AF65-F5344CB8AC3E}">
-        <p14:creationId xmlns:p14="http://schemas.microsoft.com/office/powerpoint/2010/main" val="1856312264"/>
+        <p14:creationId xmlns:p14="http://schemas.microsoft.com/office/powerpoint/2010/main" val="1873569641"/>
       </p:ext>
     </p:extLst>
   </p:cSld>
@@ -4677,7 +5092,7 @@
           <p:cNvPr id="1" name="kicker-marker">
             <a:extLst xmlns:a="http://schemas.openxmlformats.org/drawingml/2006/main">
               <a:ext uri="{FF2B5EF4-FFF2-40B4-BE49-F238E27FC236}">
-                <a16:creationId xmlns:a16="http://schemas.microsoft.com/office/drawing/2014/main" id="{A8C83C49-F6BF-4611-9F81-7552A426E81F}"/>
+                <a16:creationId xmlns:a16="http://schemas.microsoft.com/office/drawing/2014/main" id="{74D337CB-D749-4B93-8F8D-1D96C79A0E88}"/>
               </a:ext>
             </a:extLst>
           </p:cNvPr>
@@ -4712,7 +5127,7 @@
           <p:cNvPr id="2" name="kicker-label">
             <a:extLst xmlns:a="http://schemas.openxmlformats.org/drawingml/2006/main">
               <a:ext uri="{FF2B5EF4-FFF2-40B4-BE49-F238E27FC236}">
-                <a16:creationId xmlns:a16="http://schemas.microsoft.com/office/drawing/2014/main" id="{F669F1DF-CBF1-4C4D-86ED-C859D8BBDD38}"/>
+                <a16:creationId xmlns:a16="http://schemas.microsoft.com/office/drawing/2014/main" id="{F89D8121-1AA4-49A0-BFCE-BDCCF006BA91}"/>
               </a:ext>
             </a:extLst>
           </p:cNvPr>
@@ -4769,7 +5184,7 @@
           <p:cNvPr id="3" name="">
             <a:extLst xmlns:a="http://schemas.openxmlformats.org/drawingml/2006/main">
               <a:ext uri="{FF2B5EF4-FFF2-40B4-BE49-F238E27FC236}">
-                <a16:creationId xmlns:a16="http://schemas.microsoft.com/office/drawing/2014/main" id="{866EB1B1-3BB1-4B69-8D9D-30542634DD02}"/>
+                <a16:creationId xmlns:a16="http://schemas.microsoft.com/office/drawing/2014/main" id="{1175266F-C248-4FF1-89D7-E8E01F9994C1}"/>
               </a:ext>
             </a:extLst>
           </p:cNvPr>
@@ -4826,7 +5241,7 @@
           <p:cNvPr id="4" name="">
             <a:extLst xmlns:a="http://schemas.openxmlformats.org/drawingml/2006/main">
               <a:ext uri="{FF2B5EF4-FFF2-40B4-BE49-F238E27FC236}">
-                <a16:creationId xmlns:a16="http://schemas.microsoft.com/office/drawing/2014/main" id="{198E657A-4FD6-4A21-A92E-12C904DB55F2}"/>
+                <a16:creationId xmlns:a16="http://schemas.microsoft.com/office/drawing/2014/main" id="{252992C0-8EA7-4973-954D-234FFBFF54C6}"/>
               </a:ext>
             </a:extLst>
           </p:cNvPr>
@@ -4861,7 +5276,7 @@
           <p:cNvPr id="5" name="">
             <a:extLst xmlns:a="http://schemas.openxmlformats.org/drawingml/2006/main">
               <a:ext uri="{FF2B5EF4-FFF2-40B4-BE49-F238E27FC236}">
-                <a16:creationId xmlns:a16="http://schemas.microsoft.com/office/drawing/2014/main" id="{31197417-A0F6-4C00-BB13-574FF8234584}"/>
+                <a16:creationId xmlns:a16="http://schemas.microsoft.com/office/drawing/2014/main" id="{D6C38247-6F44-4092-84D7-E1DD2CDC4956}"/>
               </a:ext>
             </a:extLst>
           </p:cNvPr>
@@ -4918,7 +5333,7 @@
           <p:cNvPr id="6" name="">
             <a:extLst xmlns:a="http://schemas.openxmlformats.org/drawingml/2006/main">
               <a:ext uri="{FF2B5EF4-FFF2-40B4-BE49-F238E27FC236}">
-                <a16:creationId xmlns:a16="http://schemas.microsoft.com/office/drawing/2014/main" id="{2E75B748-A695-472B-89E8-2D708F920BFD}"/>
+                <a16:creationId xmlns:a16="http://schemas.microsoft.com/office/drawing/2014/main" id="{E7AC7264-37AC-4A48-884F-9596166E0FB8}"/>
               </a:ext>
             </a:extLst>
           </p:cNvPr>
@@ -4975,7 +5390,7 @@
           <p:cNvPr id="7" name="">
             <a:extLst xmlns:a="http://schemas.openxmlformats.org/drawingml/2006/main">
               <a:ext uri="{FF2B5EF4-FFF2-40B4-BE49-F238E27FC236}">
-                <a16:creationId xmlns:a16="http://schemas.microsoft.com/office/drawing/2014/main" id="{D3E59326-12A5-444E-A230-AA0128B83E51}"/>
+                <a16:creationId xmlns:a16="http://schemas.microsoft.com/office/drawing/2014/main" id="{2E40685D-120F-48F1-80CD-1E8BC674582A}"/>
               </a:ext>
             </a:extLst>
           </p:cNvPr>
@@ -5010,7 +5425,7 @@
           <p:cNvPr id="8" name="">
             <a:extLst xmlns:a="http://schemas.openxmlformats.org/drawingml/2006/main">
               <a:ext uri="{FF2B5EF4-FFF2-40B4-BE49-F238E27FC236}">
-                <a16:creationId xmlns:a16="http://schemas.microsoft.com/office/drawing/2014/main" id="{393D30A6-054A-4C45-949C-7255276CE0C9}"/>
+                <a16:creationId xmlns:a16="http://schemas.microsoft.com/office/drawing/2014/main" id="{ECA6480E-11BF-485C-A792-5F6169E2AB28}"/>
               </a:ext>
             </a:extLst>
           </p:cNvPr>
@@ -5067,7 +5482,7 @@
           <p:cNvPr id="9" name="">
             <a:extLst xmlns:a="http://schemas.openxmlformats.org/drawingml/2006/main">
               <a:ext uri="{FF2B5EF4-FFF2-40B4-BE49-F238E27FC236}">
-                <a16:creationId xmlns:a16="http://schemas.microsoft.com/office/drawing/2014/main" id="{213B0AB9-6838-4D24-86AF-6A3586226292}"/>
+                <a16:creationId xmlns:a16="http://schemas.microsoft.com/office/drawing/2014/main" id="{29D78C9A-A822-4B34-A97D-864670A33100}"/>
               </a:ext>
             </a:extLst>
           </p:cNvPr>
@@ -5124,7 +5539,7 @@
           <p:cNvPr id="10" name="">
             <a:extLst xmlns:a="http://schemas.openxmlformats.org/drawingml/2006/main">
               <a:ext uri="{FF2B5EF4-FFF2-40B4-BE49-F238E27FC236}">
-                <a16:creationId xmlns:a16="http://schemas.microsoft.com/office/drawing/2014/main" id="{FC842F41-73E2-4838-818A-351C9C9F79A6}"/>
+                <a16:creationId xmlns:a16="http://schemas.microsoft.com/office/drawing/2014/main" id="{24F97A06-65E1-4FB6-99D3-2E1825145DD8}"/>
               </a:ext>
             </a:extLst>
           </p:cNvPr>
@@ -5181,7 +5596,7 @@
           <p:cNvPr id="11" name="">
             <a:extLst xmlns:a="http://schemas.openxmlformats.org/drawingml/2006/main">
               <a:ext uri="{FF2B5EF4-FFF2-40B4-BE49-F238E27FC236}">
-                <a16:creationId xmlns:a16="http://schemas.microsoft.com/office/drawing/2014/main" id="{A5491E45-DCEF-4AB6-B2BE-138F1639CA02}"/>
+                <a16:creationId xmlns:a16="http://schemas.microsoft.com/office/drawing/2014/main" id="{C2E22672-B1E0-4F31-B816-4FE85B402E5D}"/>
               </a:ext>
             </a:extLst>
           </p:cNvPr>
@@ -5238,7 +5653,7 @@
           <p:cNvPr id="12" name="">
             <a:extLst xmlns:a="http://schemas.openxmlformats.org/drawingml/2006/main">
               <a:ext uri="{FF2B5EF4-FFF2-40B4-BE49-F238E27FC236}">
-                <a16:creationId xmlns:a16="http://schemas.microsoft.com/office/drawing/2014/main" id="{20E29287-21DD-4C9B-8FA5-0490DE01D8D8}"/>
+                <a16:creationId xmlns:a16="http://schemas.microsoft.com/office/drawing/2014/main" id="{0E799260-EDAD-480A-ADCD-610DCCCBB963}"/>
               </a:ext>
             </a:extLst>
           </p:cNvPr>
@@ -5295,7 +5710,7 @@
           <p:cNvPr id="13" name="">
             <a:extLst xmlns:a="http://schemas.openxmlformats.org/drawingml/2006/main">
               <a:ext uri="{FF2B5EF4-FFF2-40B4-BE49-F238E27FC236}">
-                <a16:creationId xmlns:a16="http://schemas.microsoft.com/office/drawing/2014/main" id="{917E29E4-42C2-42F6-9837-DB8B1E08CD7A}"/>
+                <a16:creationId xmlns:a16="http://schemas.microsoft.com/office/drawing/2014/main" id="{15919B0D-9EE8-4B04-BADA-6F87D2A26892}"/>
               </a:ext>
             </a:extLst>
           </p:cNvPr>
@@ -5352,7 +5767,7 @@
           <p:cNvPr id="14" name="">
             <a:extLst xmlns:a="http://schemas.openxmlformats.org/drawingml/2006/main">
               <a:ext uri="{FF2B5EF4-FFF2-40B4-BE49-F238E27FC236}">
-                <a16:creationId xmlns:a16="http://schemas.microsoft.com/office/drawing/2014/main" id="{8B417AD4-923A-4510-A52A-8D3B8AF00AB8}"/>
+                <a16:creationId xmlns:a16="http://schemas.microsoft.com/office/drawing/2014/main" id="{D258445E-4315-4418-8C9B-BCC0A97AE602}"/>
               </a:ext>
             </a:extLst>
           </p:cNvPr>
@@ -5473,7 +5888,7 @@
           <p:cNvPr id="15" name="">
             <a:extLst xmlns:a="http://schemas.openxmlformats.org/drawingml/2006/main">
               <a:ext uri="{FF2B5EF4-FFF2-40B4-BE49-F238E27FC236}">
-                <a16:creationId xmlns:a16="http://schemas.microsoft.com/office/drawing/2014/main" id="{0ABF2E99-D3C0-4180-AB5F-8C393D7B556A}"/>
+                <a16:creationId xmlns:a16="http://schemas.microsoft.com/office/drawing/2014/main" id="{47B63FF3-4913-430F-A9CE-3198C88D05E9}"/>
               </a:ext>
             </a:extLst>
           </p:cNvPr>
@@ -5528,7 +5943,7 @@
     </p:spTree>
     <p:extLst>
       <p:ext uri="{BB962C8B-B14F-4D97-AF65-F5344CB8AC3E}">
-        <p14:creationId xmlns:p14="http://schemas.microsoft.com/office/powerpoint/2010/main" val="1105551815"/>
+        <p14:creationId xmlns:p14="http://schemas.microsoft.com/office/powerpoint/2010/main" val="1891935855"/>
       </p:ext>
     </p:extLst>
   </p:cSld>
@@ -5559,7 +5974,7 @@
           <p:cNvPr id="1" name="kicker-marker">
             <a:extLst xmlns:a="http://schemas.openxmlformats.org/drawingml/2006/main">
               <a:ext uri="{FF2B5EF4-FFF2-40B4-BE49-F238E27FC236}">
-                <a16:creationId xmlns:a16="http://schemas.microsoft.com/office/drawing/2014/main" id="{DBE1055A-EC4C-4899-8B3C-54FEBAB87325}"/>
+                <a16:creationId xmlns:a16="http://schemas.microsoft.com/office/drawing/2014/main" id="{226C0B0F-4675-4727-A619-D9CD70044CAF}"/>
               </a:ext>
             </a:extLst>
           </p:cNvPr>
@@ -5594,7 +6009,7 @@
           <p:cNvPr id="2" name="kicker-label">
             <a:extLst xmlns:a="http://schemas.openxmlformats.org/drawingml/2006/main">
               <a:ext uri="{FF2B5EF4-FFF2-40B4-BE49-F238E27FC236}">
-                <a16:creationId xmlns:a16="http://schemas.microsoft.com/office/drawing/2014/main" id="{590A3907-2769-418D-A1E7-F0BD680F30B2}"/>
+                <a16:creationId xmlns:a16="http://schemas.microsoft.com/office/drawing/2014/main" id="{7020C04F-E425-411D-B292-9646998486ED}"/>
               </a:ext>
             </a:extLst>
           </p:cNvPr>
@@ -5651,7 +6066,7 @@
           <p:cNvPr id="3" name="">
             <a:extLst xmlns:a="http://schemas.openxmlformats.org/drawingml/2006/main">
               <a:ext uri="{FF2B5EF4-FFF2-40B4-BE49-F238E27FC236}">
-                <a16:creationId xmlns:a16="http://schemas.microsoft.com/office/drawing/2014/main" id="{5EB6B5CE-A0A8-4C3D-97A0-5FA0AB1A3707}"/>
+                <a16:creationId xmlns:a16="http://schemas.microsoft.com/office/drawing/2014/main" id="{CD7162C2-3302-4EDE-B86E-AE63626110FA}"/>
               </a:ext>
             </a:extLst>
           </p:cNvPr>
@@ -5708,7 +6123,7 @@
           <p:cNvPr id="4" name="">
             <a:extLst xmlns:a="http://schemas.openxmlformats.org/drawingml/2006/main">
               <a:ext uri="{FF2B5EF4-FFF2-40B4-BE49-F238E27FC236}">
-                <a16:creationId xmlns:a16="http://schemas.microsoft.com/office/drawing/2014/main" id="{3282F0F3-007E-47A1-9C01-67439F42886B}"/>
+                <a16:creationId xmlns:a16="http://schemas.microsoft.com/office/drawing/2014/main" id="{595146C7-7236-4341-BA73-D00A305742AE}"/>
               </a:ext>
             </a:extLst>
           </p:cNvPr>
@@ -5765,7 +6180,7 @@
           <p:cNvPr id="5" name="">
             <a:extLst xmlns:a="http://schemas.openxmlformats.org/drawingml/2006/main">
               <a:ext uri="{FF2B5EF4-FFF2-40B4-BE49-F238E27FC236}">
-                <a16:creationId xmlns:a16="http://schemas.microsoft.com/office/drawing/2014/main" id="{528AA731-479B-4126-AC1A-21C7B64E57AB}"/>
+                <a16:creationId xmlns:a16="http://schemas.microsoft.com/office/drawing/2014/main" id="{FA41582A-3468-4D1E-BC01-415EB9BE5663}"/>
               </a:ext>
             </a:extLst>
           </p:cNvPr>
@@ -5800,7 +6215,7 @@
           <p:cNvPr id="6" name="">
             <a:extLst xmlns:a="http://schemas.openxmlformats.org/drawingml/2006/main">
               <a:ext uri="{FF2B5EF4-FFF2-40B4-BE49-F238E27FC236}">
-                <a16:creationId xmlns:a16="http://schemas.microsoft.com/office/drawing/2014/main" id="{0379AAED-CD7A-4D2C-BBBF-64D4BE991360}"/>
+                <a16:creationId xmlns:a16="http://schemas.microsoft.com/office/drawing/2014/main" id="{B90B7E0C-519F-4CE7-8BB1-BDE7A1FEF38C}"/>
               </a:ext>
             </a:extLst>
           </p:cNvPr>
@@ -5857,7 +6272,7 @@
           <p:cNvPr id="7" name="">
             <a:extLst xmlns:a="http://schemas.openxmlformats.org/drawingml/2006/main">
               <a:ext uri="{FF2B5EF4-FFF2-40B4-BE49-F238E27FC236}">
-                <a16:creationId xmlns:a16="http://schemas.microsoft.com/office/drawing/2014/main" id="{02E928DD-4FA3-4A2D-B23B-9D1C3640B748}"/>
+                <a16:creationId xmlns:a16="http://schemas.microsoft.com/office/drawing/2014/main" id="{5EEF4BE5-D1C3-457B-8AF1-D9BD13FB0AD7}"/>
               </a:ext>
             </a:extLst>
           </p:cNvPr>
@@ -5914,7 +6329,7 @@
           <p:cNvPr id="8" name="">
             <a:extLst xmlns:a="http://schemas.openxmlformats.org/drawingml/2006/main">
               <a:ext uri="{FF2B5EF4-FFF2-40B4-BE49-F238E27FC236}">
-                <a16:creationId xmlns:a16="http://schemas.microsoft.com/office/drawing/2014/main" id="{88CD8286-4164-4383-A50A-006573C6167F}"/>
+                <a16:creationId xmlns:a16="http://schemas.microsoft.com/office/drawing/2014/main" id="{5FB731F0-1764-46BB-A16C-5CAD7499AF12}"/>
               </a:ext>
             </a:extLst>
           </p:cNvPr>
@@ -5949,7 +6364,7 @@
           <p:cNvPr id="9" name="">
             <a:extLst xmlns:a="http://schemas.openxmlformats.org/drawingml/2006/main">
               <a:ext uri="{FF2B5EF4-FFF2-40B4-BE49-F238E27FC236}">
-                <a16:creationId xmlns:a16="http://schemas.microsoft.com/office/drawing/2014/main" id="{22E0FCE2-7C1D-4B56-8F71-24830A0B24F6}"/>
+                <a16:creationId xmlns:a16="http://schemas.microsoft.com/office/drawing/2014/main" id="{25C9F4FA-7388-45BA-AA38-9481908D09E4}"/>
               </a:ext>
             </a:extLst>
           </p:cNvPr>
@@ -5982,7 +6397,7 @@
           <p:cNvPr id="10" name="">
             <a:extLst xmlns:a="http://schemas.openxmlformats.org/drawingml/2006/main">
               <a:ext uri="{FF2B5EF4-FFF2-40B4-BE49-F238E27FC236}">
-                <a16:creationId xmlns:a16="http://schemas.microsoft.com/office/drawing/2014/main" id="{715AB14C-7166-4FB3-95E7-A7BAE319DE44}"/>
+                <a16:creationId xmlns:a16="http://schemas.microsoft.com/office/drawing/2014/main" id="{DC0AACBB-554E-4D3B-A520-FFEB1E740476}"/>
               </a:ext>
             </a:extLst>
           </p:cNvPr>
@@ -6017,7 +6432,7 @@
           <p:cNvPr id="11" name="">
             <a:extLst xmlns:a="http://schemas.openxmlformats.org/drawingml/2006/main">
               <a:ext uri="{FF2B5EF4-FFF2-40B4-BE49-F238E27FC236}">
-                <a16:creationId xmlns:a16="http://schemas.microsoft.com/office/drawing/2014/main" id="{83656044-3050-4518-B36D-113EA9E9FB99}"/>
+                <a16:creationId xmlns:a16="http://schemas.microsoft.com/office/drawing/2014/main" id="{84FCF21F-AD4D-48E5-847E-75BD7BDD2AA9}"/>
               </a:ext>
             </a:extLst>
           </p:cNvPr>
@@ -6074,7 +6489,7 @@
           <p:cNvPr id="12" name="">
             <a:extLst xmlns:a="http://schemas.openxmlformats.org/drawingml/2006/main">
               <a:ext uri="{FF2B5EF4-FFF2-40B4-BE49-F238E27FC236}">
-                <a16:creationId xmlns:a16="http://schemas.microsoft.com/office/drawing/2014/main" id="{8DFCAA08-529B-42BE-806B-477AC84318E8}"/>
+                <a16:creationId xmlns:a16="http://schemas.microsoft.com/office/drawing/2014/main" id="{CF95FC4B-11E4-4F1D-BC17-39816E626C4A}"/>
               </a:ext>
             </a:extLst>
           </p:cNvPr>
@@ -6131,7 +6546,7 @@
           <p:cNvPr id="13" name="">
             <a:extLst xmlns:a="http://schemas.openxmlformats.org/drawingml/2006/main">
               <a:ext uri="{FF2B5EF4-FFF2-40B4-BE49-F238E27FC236}">
-                <a16:creationId xmlns:a16="http://schemas.microsoft.com/office/drawing/2014/main" id="{7C60D1BA-F98E-42A8-A417-98E6B377473D}"/>
+                <a16:creationId xmlns:a16="http://schemas.microsoft.com/office/drawing/2014/main" id="{27EAAF8B-D477-417C-A7FC-3FBD8565950D}"/>
               </a:ext>
             </a:extLst>
           </p:cNvPr>
@@ -6166,7 +6581,7 @@
           <p:cNvPr id="14" name="">
             <a:extLst xmlns:a="http://schemas.openxmlformats.org/drawingml/2006/main">
               <a:ext uri="{FF2B5EF4-FFF2-40B4-BE49-F238E27FC236}">
-                <a16:creationId xmlns:a16="http://schemas.microsoft.com/office/drawing/2014/main" id="{61E895AB-5A79-42AE-AED2-C68358955228}"/>
+                <a16:creationId xmlns:a16="http://schemas.microsoft.com/office/drawing/2014/main" id="{8101FE57-5DAA-44FF-8EC3-528C840D6D77}"/>
               </a:ext>
             </a:extLst>
           </p:cNvPr>
@@ -6199,7 +6614,7 @@
           <p:cNvPr id="15" name="">
             <a:extLst xmlns:a="http://schemas.openxmlformats.org/drawingml/2006/main">
               <a:ext uri="{FF2B5EF4-FFF2-40B4-BE49-F238E27FC236}">
-                <a16:creationId xmlns:a16="http://schemas.microsoft.com/office/drawing/2014/main" id="{6C5BAB95-9340-4A07-8CBF-CC0DF51604F5}"/>
+                <a16:creationId xmlns:a16="http://schemas.microsoft.com/office/drawing/2014/main" id="{09122801-DB34-452C-98F7-3417BC42CB56}"/>
               </a:ext>
             </a:extLst>
           </p:cNvPr>
@@ -6234,7 +6649,7 @@
           <p:cNvPr id="16" name="">
             <a:extLst xmlns:a="http://schemas.openxmlformats.org/drawingml/2006/main">
               <a:ext uri="{FF2B5EF4-FFF2-40B4-BE49-F238E27FC236}">
-                <a16:creationId xmlns:a16="http://schemas.microsoft.com/office/drawing/2014/main" id="{343C41CA-980B-4BA9-A43D-7B93348361DC}"/>
+                <a16:creationId xmlns:a16="http://schemas.microsoft.com/office/drawing/2014/main" id="{F9A5C184-45F4-4332-A69F-C5AFFEE9B027}"/>
               </a:ext>
             </a:extLst>
           </p:cNvPr>
@@ -6291,7 +6706,7 @@
           <p:cNvPr id="17" name="">
             <a:extLst xmlns:a="http://schemas.openxmlformats.org/drawingml/2006/main">
               <a:ext uri="{FF2B5EF4-FFF2-40B4-BE49-F238E27FC236}">
-                <a16:creationId xmlns:a16="http://schemas.microsoft.com/office/drawing/2014/main" id="{4ECC76D0-0EBF-4BC1-8778-4D0C3F7DB58A}"/>
+                <a16:creationId xmlns:a16="http://schemas.microsoft.com/office/drawing/2014/main" id="{9D375818-9404-446C-9222-8E5899E8CAA7}"/>
               </a:ext>
             </a:extLst>
           </p:cNvPr>
@@ -6348,7 +6763,7 @@
           <p:cNvPr id="18" name="">
             <a:extLst xmlns:a="http://schemas.openxmlformats.org/drawingml/2006/main">
               <a:ext uri="{FF2B5EF4-FFF2-40B4-BE49-F238E27FC236}">
-                <a16:creationId xmlns:a16="http://schemas.microsoft.com/office/drawing/2014/main" id="{8B87BBB3-EF80-403A-8785-3F4104D261C1}"/>
+                <a16:creationId xmlns:a16="http://schemas.microsoft.com/office/drawing/2014/main" id="{E8BE9B5B-8998-42C8-B57F-92E517B07DBB}"/>
               </a:ext>
             </a:extLst>
           </p:cNvPr>
@@ -6383,7 +6798,7 @@
           <p:cNvPr id="19" name="">
             <a:extLst xmlns:a="http://schemas.openxmlformats.org/drawingml/2006/main">
               <a:ext uri="{FF2B5EF4-FFF2-40B4-BE49-F238E27FC236}">
-                <a16:creationId xmlns:a16="http://schemas.microsoft.com/office/drawing/2014/main" id="{FB1F0420-241E-4ACC-9CA8-8ADDF2871BE2}"/>
+                <a16:creationId xmlns:a16="http://schemas.microsoft.com/office/drawing/2014/main" id="{67DF6E90-FED9-4B21-AE84-B920130A7023}"/>
               </a:ext>
             </a:extLst>
           </p:cNvPr>
@@ -6416,7 +6831,7 @@
           <p:cNvPr id="20" name="">
             <a:extLst xmlns:a="http://schemas.openxmlformats.org/drawingml/2006/main">
               <a:ext uri="{FF2B5EF4-FFF2-40B4-BE49-F238E27FC236}">
-                <a16:creationId xmlns:a16="http://schemas.microsoft.com/office/drawing/2014/main" id="{226C0D0D-8C93-4CF4-A7E5-4951FA226B83}"/>
+                <a16:creationId xmlns:a16="http://schemas.microsoft.com/office/drawing/2014/main" id="{6307E8EF-35A5-443B-BE69-2D6945C9C1FE}"/>
               </a:ext>
             </a:extLst>
           </p:cNvPr>
@@ -6451,7 +6866,7 @@
           <p:cNvPr id="21" name="">
             <a:extLst xmlns:a="http://schemas.openxmlformats.org/drawingml/2006/main">
               <a:ext uri="{FF2B5EF4-FFF2-40B4-BE49-F238E27FC236}">
-                <a16:creationId xmlns:a16="http://schemas.microsoft.com/office/drawing/2014/main" id="{029A0BAC-E2E9-4CAF-95C7-F8685765BDB6}"/>
+                <a16:creationId xmlns:a16="http://schemas.microsoft.com/office/drawing/2014/main" id="{B2197226-CF35-42E1-B5E8-4E2AEA1697B0}"/>
               </a:ext>
             </a:extLst>
           </p:cNvPr>
@@ -6508,7 +6923,7 @@
           <p:cNvPr id="22" name="">
             <a:extLst xmlns:a="http://schemas.openxmlformats.org/drawingml/2006/main">
               <a:ext uri="{FF2B5EF4-FFF2-40B4-BE49-F238E27FC236}">
-                <a16:creationId xmlns:a16="http://schemas.microsoft.com/office/drawing/2014/main" id="{3741C18D-621E-426F-B6A7-C1466123C935}"/>
+                <a16:creationId xmlns:a16="http://schemas.microsoft.com/office/drawing/2014/main" id="{2D4F96C8-913B-46DC-874A-D7493DFA58CD}"/>
               </a:ext>
             </a:extLst>
           </p:cNvPr>
@@ -6565,7 +6980,7 @@
           <p:cNvPr id="23" name="">
             <a:extLst xmlns:a="http://schemas.openxmlformats.org/drawingml/2006/main">
               <a:ext uri="{FF2B5EF4-FFF2-40B4-BE49-F238E27FC236}">
-                <a16:creationId xmlns:a16="http://schemas.microsoft.com/office/drawing/2014/main" id="{1D9304CE-570A-41BD-BF3C-4E4F37912CF6}"/>
+                <a16:creationId xmlns:a16="http://schemas.microsoft.com/office/drawing/2014/main" id="{145A39B1-25C3-4445-91C2-E29FC271EFD2}"/>
               </a:ext>
             </a:extLst>
           </p:cNvPr>
@@ -6598,7 +7013,7 @@
           <p:cNvPr id="24" name="">
             <a:extLst xmlns:a="http://schemas.openxmlformats.org/drawingml/2006/main">
               <a:ext uri="{FF2B5EF4-FFF2-40B4-BE49-F238E27FC236}">
-                <a16:creationId xmlns:a16="http://schemas.microsoft.com/office/drawing/2014/main" id="{CC18AA19-907E-4174-BDBD-89458041D0FB}"/>
+                <a16:creationId xmlns:a16="http://schemas.microsoft.com/office/drawing/2014/main" id="{D95F9197-70C4-4DEE-8386-A9B53EADEBDF}"/>
               </a:ext>
             </a:extLst>
           </p:cNvPr>
@@ -6633,7 +7048,7 @@
           <p:cNvPr id="25" name="">
             <a:extLst xmlns:a="http://schemas.openxmlformats.org/drawingml/2006/main">
               <a:ext uri="{FF2B5EF4-FFF2-40B4-BE49-F238E27FC236}">
-                <a16:creationId xmlns:a16="http://schemas.microsoft.com/office/drawing/2014/main" id="{2C145E95-E32E-42F6-8E35-6DB5D4A06666}"/>
+                <a16:creationId xmlns:a16="http://schemas.microsoft.com/office/drawing/2014/main" id="{A5A33555-2588-4A8C-8D13-DAA7E7608573}"/>
               </a:ext>
             </a:extLst>
           </p:cNvPr>
@@ -6690,7 +7105,7 @@
           <p:cNvPr id="26" name="">
             <a:extLst xmlns:a="http://schemas.openxmlformats.org/drawingml/2006/main">
               <a:ext uri="{FF2B5EF4-FFF2-40B4-BE49-F238E27FC236}">
-                <a16:creationId xmlns:a16="http://schemas.microsoft.com/office/drawing/2014/main" id="{275CA181-F345-4DC7-AAB7-7DD38CC48D14}"/>
+                <a16:creationId xmlns:a16="http://schemas.microsoft.com/office/drawing/2014/main" id="{01EC7067-A44A-487D-98C4-561E9976ED3E}"/>
               </a:ext>
             </a:extLst>
           </p:cNvPr>
@@ -6747,7 +7162,7 @@
           <p:cNvPr id="27" name="">
             <a:extLst xmlns:a="http://schemas.openxmlformats.org/drawingml/2006/main">
               <a:ext uri="{FF2B5EF4-FFF2-40B4-BE49-F238E27FC236}">
-                <a16:creationId xmlns:a16="http://schemas.microsoft.com/office/drawing/2014/main" id="{AC5E81D5-C3C3-44D3-9478-6B5A898E7A00}"/>
+                <a16:creationId xmlns:a16="http://schemas.microsoft.com/office/drawing/2014/main" id="{F24EA75A-BA50-4906-924B-FBEBC15669E3}"/>
               </a:ext>
             </a:extLst>
           </p:cNvPr>
@@ -6802,7 +7217,7 @@
     </p:spTree>
     <p:extLst>
       <p:ext uri="{BB962C8B-B14F-4D97-AF65-F5344CB8AC3E}">
-        <p14:creationId xmlns:p14="http://schemas.microsoft.com/office/powerpoint/2010/main" val="1643016787"/>
+        <p14:creationId xmlns:p14="http://schemas.microsoft.com/office/powerpoint/2010/main" val="1597290803"/>
       </p:ext>
     </p:extLst>
   </p:cSld>
@@ -6833,7 +7248,7 @@
           <p:cNvPr id="1" name="kicker-marker">
             <a:extLst xmlns:a="http://schemas.openxmlformats.org/drawingml/2006/main">
               <a:ext uri="{FF2B5EF4-FFF2-40B4-BE49-F238E27FC236}">
-                <a16:creationId xmlns:a16="http://schemas.microsoft.com/office/drawing/2014/main" id="{239C9E52-0A93-4EDE-904E-1019D8A7EF01}"/>
+                <a16:creationId xmlns:a16="http://schemas.microsoft.com/office/drawing/2014/main" id="{A477BC46-50CF-43CA-81E4-222CAED38085}"/>
               </a:ext>
             </a:extLst>
           </p:cNvPr>
@@ -6868,7 +7283,7 @@
           <p:cNvPr id="2" name="kicker-label">
             <a:extLst xmlns:a="http://schemas.openxmlformats.org/drawingml/2006/main">
               <a:ext uri="{FF2B5EF4-FFF2-40B4-BE49-F238E27FC236}">
-                <a16:creationId xmlns:a16="http://schemas.microsoft.com/office/drawing/2014/main" id="{99473798-C931-43B9-832A-C0446D3881D9}"/>
+                <a16:creationId xmlns:a16="http://schemas.microsoft.com/office/drawing/2014/main" id="{5F41E10B-5D62-449F-8715-DEF918D3D31D}"/>
               </a:ext>
             </a:extLst>
           </p:cNvPr>
@@ -6925,7 +7340,7 @@
           <p:cNvPr id="3" name="">
             <a:extLst xmlns:a="http://schemas.openxmlformats.org/drawingml/2006/main">
               <a:ext uri="{FF2B5EF4-FFF2-40B4-BE49-F238E27FC236}">
-                <a16:creationId xmlns:a16="http://schemas.microsoft.com/office/drawing/2014/main" id="{D976CD98-EF94-4F8F-94B2-A5762D2B1EE2}"/>
+                <a16:creationId xmlns:a16="http://schemas.microsoft.com/office/drawing/2014/main" id="{B6A86241-FAC9-42BE-ABB8-1132D0E1216C}"/>
               </a:ext>
             </a:extLst>
           </p:cNvPr>
@@ -6982,7 +7397,7 @@
           <p:cNvPr id="4" name="">
             <a:extLst xmlns:a="http://schemas.openxmlformats.org/drawingml/2006/main">
               <a:ext uri="{FF2B5EF4-FFF2-40B4-BE49-F238E27FC236}">
-                <a16:creationId xmlns:a16="http://schemas.microsoft.com/office/drawing/2014/main" id="{75D4E399-2346-4978-9C28-558E189426FB}"/>
+                <a16:creationId xmlns:a16="http://schemas.microsoft.com/office/drawing/2014/main" id="{66A7FEF2-8826-46B5-B083-A2C131019930}"/>
               </a:ext>
             </a:extLst>
           </p:cNvPr>
@@ -7017,7 +7432,7 @@
           <p:cNvPr id="5" name="">
             <a:extLst xmlns:a="http://schemas.openxmlformats.org/drawingml/2006/main">
               <a:ext uri="{FF2B5EF4-FFF2-40B4-BE49-F238E27FC236}">
-                <a16:creationId xmlns:a16="http://schemas.microsoft.com/office/drawing/2014/main" id="{7BD61647-7A4F-47E0-BB84-3969CE3FC712}"/>
+                <a16:creationId xmlns:a16="http://schemas.microsoft.com/office/drawing/2014/main" id="{365B4FE6-7032-4DF9-B39F-5D974758D4A3}"/>
               </a:ext>
             </a:extLst>
           </p:cNvPr>
@@ -7074,7 +7489,7 @@
           <p:cNvPr id="6" name="">
             <a:extLst xmlns:a="http://schemas.openxmlformats.org/drawingml/2006/main">
               <a:ext uri="{FF2B5EF4-FFF2-40B4-BE49-F238E27FC236}">
-                <a16:creationId xmlns:a16="http://schemas.microsoft.com/office/drawing/2014/main" id="{A6E080C8-0E41-426B-96E9-D356976618E2}"/>
+                <a16:creationId xmlns:a16="http://schemas.microsoft.com/office/drawing/2014/main" id="{02047498-D1F2-4FB4-8676-E97C1BE87EDF}"/>
               </a:ext>
             </a:extLst>
           </p:cNvPr>
@@ -7131,7 +7546,7 @@
           <p:cNvPr id="7" name="">
             <a:extLst xmlns:a="http://schemas.openxmlformats.org/drawingml/2006/main">
               <a:ext uri="{FF2B5EF4-FFF2-40B4-BE49-F238E27FC236}">
-                <a16:creationId xmlns:a16="http://schemas.microsoft.com/office/drawing/2014/main" id="{A3799448-61B2-4BC5-AEBA-C3FEA37E2BCA}"/>
+                <a16:creationId xmlns:a16="http://schemas.microsoft.com/office/drawing/2014/main" id="{1C9560C2-E61B-4DC4-B35F-F7BFF5C28BF9}"/>
               </a:ext>
             </a:extLst>
           </p:cNvPr>
@@ -7164,7 +7579,7 @@
           <p:cNvPr id="8" name="">
             <a:extLst xmlns:a="http://schemas.openxmlformats.org/drawingml/2006/main">
               <a:ext uri="{FF2B5EF4-FFF2-40B4-BE49-F238E27FC236}">
-                <a16:creationId xmlns:a16="http://schemas.microsoft.com/office/drawing/2014/main" id="{09CE6B10-C822-4CBE-9950-9D5A8F22AD66}"/>
+                <a16:creationId xmlns:a16="http://schemas.microsoft.com/office/drawing/2014/main" id="{5839FC8A-2223-42AB-8AA7-70719A786B8E}"/>
               </a:ext>
             </a:extLst>
           </p:cNvPr>
@@ -7221,7 +7636,7 @@
           <p:cNvPr id="9" name="">
             <a:extLst xmlns:a="http://schemas.openxmlformats.org/drawingml/2006/main">
               <a:ext uri="{FF2B5EF4-FFF2-40B4-BE49-F238E27FC236}">
-                <a16:creationId xmlns:a16="http://schemas.microsoft.com/office/drawing/2014/main" id="{2CABF1AA-F547-4C18-B61E-E1E4CAF11B66}"/>
+                <a16:creationId xmlns:a16="http://schemas.microsoft.com/office/drawing/2014/main" id="{8E1D9826-9D02-42F8-B6DB-E8C3F7833EC6}"/>
               </a:ext>
             </a:extLst>
           </p:cNvPr>
@@ -7342,7 +7757,7 @@
           <p:cNvPr id="10" name="">
             <a:extLst xmlns:a="http://schemas.openxmlformats.org/drawingml/2006/main">
               <a:ext uri="{FF2B5EF4-FFF2-40B4-BE49-F238E27FC236}">
-                <a16:creationId xmlns:a16="http://schemas.microsoft.com/office/drawing/2014/main" id="{86B9EB20-4C37-4678-9826-84FA0958D2E6}"/>
+                <a16:creationId xmlns:a16="http://schemas.microsoft.com/office/drawing/2014/main" id="{92D1446C-093E-484C-A68A-712880720B46}"/>
               </a:ext>
             </a:extLst>
           </p:cNvPr>
@@ -7375,7 +7790,7 @@
           <p:cNvPr id="11" name="">
             <a:extLst xmlns:a="http://schemas.openxmlformats.org/drawingml/2006/main">
               <a:ext uri="{FF2B5EF4-FFF2-40B4-BE49-F238E27FC236}">
-                <a16:creationId xmlns:a16="http://schemas.microsoft.com/office/drawing/2014/main" id="{63F4BF45-A6E5-4F1C-BED9-830A5C9FD067}"/>
+                <a16:creationId xmlns:a16="http://schemas.microsoft.com/office/drawing/2014/main" id="{AB408ACF-5A43-4945-B3F6-293351545977}"/>
               </a:ext>
             </a:extLst>
           </p:cNvPr>
@@ -7432,7 +7847,7 @@
           <p:cNvPr id="12" name="">
             <a:extLst xmlns:a="http://schemas.openxmlformats.org/drawingml/2006/main">
               <a:ext uri="{FF2B5EF4-FFF2-40B4-BE49-F238E27FC236}">
-                <a16:creationId xmlns:a16="http://schemas.microsoft.com/office/drawing/2014/main" id="{F62A50AA-C854-4CE5-95C9-DF21AD976587}"/>
+                <a16:creationId xmlns:a16="http://schemas.microsoft.com/office/drawing/2014/main" id="{8885F6F2-6B0C-44FC-BA74-16C14BD72952}"/>
               </a:ext>
             </a:extLst>
           </p:cNvPr>
@@ -7553,7 +7968,7 @@
           <p:cNvPr id="13" name="">
             <a:extLst xmlns:a="http://schemas.openxmlformats.org/drawingml/2006/main">
               <a:ext uri="{FF2B5EF4-FFF2-40B4-BE49-F238E27FC236}">
-                <a16:creationId xmlns:a16="http://schemas.microsoft.com/office/drawing/2014/main" id="{88E56CCE-320D-4929-8C41-9F9E9ED68269}"/>
+                <a16:creationId xmlns:a16="http://schemas.microsoft.com/office/drawing/2014/main" id="{86715519-5CBB-4518-BE7B-04371A593CEB}"/>
               </a:ext>
             </a:extLst>
           </p:cNvPr>
@@ -7608,7 +8023,7 @@
     </p:spTree>
     <p:extLst>
       <p:ext uri="{BB962C8B-B14F-4D97-AF65-F5344CB8AC3E}">
-        <p14:creationId xmlns:p14="http://schemas.microsoft.com/office/powerpoint/2010/main" val="1890861046"/>
+        <p14:creationId xmlns:p14="http://schemas.microsoft.com/office/powerpoint/2010/main" val="481826098"/>
       </p:ext>
     </p:extLst>
   </p:cSld>
@@ -7639,7 +8054,7 @@
           <p:cNvPr id="1" name="kicker-marker">
             <a:extLst xmlns:a="http://schemas.openxmlformats.org/drawingml/2006/main">
               <a:ext uri="{FF2B5EF4-FFF2-40B4-BE49-F238E27FC236}">
-                <a16:creationId xmlns:a16="http://schemas.microsoft.com/office/drawing/2014/main" id="{0C3E4E7B-6C07-4FCF-9215-3BDE22D8AC92}"/>
+                <a16:creationId xmlns:a16="http://schemas.microsoft.com/office/drawing/2014/main" id="{965DA922-3262-485D-8D27-AA04FF58EBF2}"/>
               </a:ext>
             </a:extLst>
           </p:cNvPr>
@@ -7674,7 +8089,7 @@
           <p:cNvPr id="2" name="kicker-label">
             <a:extLst xmlns:a="http://schemas.openxmlformats.org/drawingml/2006/main">
               <a:ext uri="{FF2B5EF4-FFF2-40B4-BE49-F238E27FC236}">
-                <a16:creationId xmlns:a16="http://schemas.microsoft.com/office/drawing/2014/main" id="{CAE88A90-B2B9-45F8-B30D-AF5F32208FD2}"/>
+                <a16:creationId xmlns:a16="http://schemas.microsoft.com/office/drawing/2014/main" id="{7DDA1347-2A87-4322-BCC2-0D1A17A33875}"/>
               </a:ext>
             </a:extLst>
           </p:cNvPr>
@@ -7731,7 +8146,7 @@
           <p:cNvPr id="3" name="">
             <a:extLst xmlns:a="http://schemas.openxmlformats.org/drawingml/2006/main">
               <a:ext uri="{FF2B5EF4-FFF2-40B4-BE49-F238E27FC236}">
-                <a16:creationId xmlns:a16="http://schemas.microsoft.com/office/drawing/2014/main" id="{AF1F5BE5-2FFC-4B67-8A82-5D8B42136B7C}"/>
+                <a16:creationId xmlns:a16="http://schemas.microsoft.com/office/drawing/2014/main" id="{8E8850A4-A83D-4694-BF39-586A2BA6BBB5}"/>
               </a:ext>
             </a:extLst>
           </p:cNvPr>
@@ -7788,7 +8203,7 @@
           <p:cNvPr id="4" name="">
             <a:extLst xmlns:a="http://schemas.openxmlformats.org/drawingml/2006/main">
               <a:ext uri="{FF2B5EF4-FFF2-40B4-BE49-F238E27FC236}">
-                <a16:creationId xmlns:a16="http://schemas.microsoft.com/office/drawing/2014/main" id="{47A6E6FB-C6AA-43AD-A016-F46BEFF5CA5F}"/>
+                <a16:creationId xmlns:a16="http://schemas.microsoft.com/office/drawing/2014/main" id="{00E90EDC-8F40-4562-BD6A-75A4F686CED2}"/>
               </a:ext>
             </a:extLst>
           </p:cNvPr>
@@ -7845,7 +8260,7 @@
           <p:cNvPr id="5" name="">
             <a:extLst xmlns:a="http://schemas.openxmlformats.org/drawingml/2006/main">
               <a:ext uri="{FF2B5EF4-FFF2-40B4-BE49-F238E27FC236}">
-                <a16:creationId xmlns:a16="http://schemas.microsoft.com/office/drawing/2014/main" id="{A5E81566-D1AE-4DE5-AB14-517FA1D3A0E3}"/>
+                <a16:creationId xmlns:a16="http://schemas.microsoft.com/office/drawing/2014/main" id="{A0E148B4-D6A5-4F0B-A5A1-87B11387E2B2}"/>
               </a:ext>
             </a:extLst>
           </p:cNvPr>
@@ -7880,7 +8295,7 @@
           <p:cNvPr id="6" name="">
             <a:extLst xmlns:a="http://schemas.openxmlformats.org/drawingml/2006/main">
               <a:ext uri="{FF2B5EF4-FFF2-40B4-BE49-F238E27FC236}">
-                <a16:creationId xmlns:a16="http://schemas.microsoft.com/office/drawing/2014/main" id="{5B3AF09E-09BA-4E9C-B893-60B4D3B66824}"/>
+                <a16:creationId xmlns:a16="http://schemas.microsoft.com/office/drawing/2014/main" id="{C5D06543-538C-40D7-8D20-77A7DD1A54B9}"/>
               </a:ext>
             </a:extLst>
           </p:cNvPr>
@@ -7937,7 +8352,7 @@
           <p:cNvPr id="7" name="">
             <a:extLst xmlns:a="http://schemas.openxmlformats.org/drawingml/2006/main">
               <a:ext uri="{FF2B5EF4-FFF2-40B4-BE49-F238E27FC236}">
-                <a16:creationId xmlns:a16="http://schemas.microsoft.com/office/drawing/2014/main" id="{9081D6DD-CDBA-4390-AA8A-6AF74C0A795A}"/>
+                <a16:creationId xmlns:a16="http://schemas.microsoft.com/office/drawing/2014/main" id="{F194CFC4-47C4-485E-930A-00583890DF58}"/>
               </a:ext>
             </a:extLst>
           </p:cNvPr>
@@ -7994,7 +8409,7 @@
           <p:cNvPr id="8" name="">
             <a:extLst xmlns:a="http://schemas.openxmlformats.org/drawingml/2006/main">
               <a:ext uri="{FF2B5EF4-FFF2-40B4-BE49-F238E27FC236}">
-                <a16:creationId xmlns:a16="http://schemas.microsoft.com/office/drawing/2014/main" id="{D755D521-9BFE-4542-BCFC-ABEB404153D6}"/>
+                <a16:creationId xmlns:a16="http://schemas.microsoft.com/office/drawing/2014/main" id="{CD617DE7-54C7-4C71-A252-6B5A23AA7EE1}"/>
               </a:ext>
             </a:extLst>
           </p:cNvPr>
@@ -8027,7 +8442,7 @@
           <p:cNvPr id="9" name="">
             <a:extLst xmlns:a="http://schemas.openxmlformats.org/drawingml/2006/main">
               <a:ext uri="{FF2B5EF4-FFF2-40B4-BE49-F238E27FC236}">
-                <a16:creationId xmlns:a16="http://schemas.microsoft.com/office/drawing/2014/main" id="{B92F804A-2397-4CBF-BB15-CB315C2B3248}"/>
+                <a16:creationId xmlns:a16="http://schemas.microsoft.com/office/drawing/2014/main" id="{B0017299-5324-44CA-807E-BEC004763BFA}"/>
               </a:ext>
             </a:extLst>
           </p:cNvPr>
@@ -8084,7 +8499,7 @@
           <p:cNvPr id="10" name="">
             <a:extLst xmlns:a="http://schemas.openxmlformats.org/drawingml/2006/main">
               <a:ext uri="{FF2B5EF4-FFF2-40B4-BE49-F238E27FC236}">
-                <a16:creationId xmlns:a16="http://schemas.microsoft.com/office/drawing/2014/main" id="{D0D4B4A9-89EB-4B78-B3F7-C664166D64AB}"/>
+                <a16:creationId xmlns:a16="http://schemas.microsoft.com/office/drawing/2014/main" id="{47B184CB-A18B-412C-BE86-D78D1F50EFCD}"/>
               </a:ext>
             </a:extLst>
           </p:cNvPr>
@@ -8168,7 +8583,7 @@
           <p:cNvPr id="11" name="">
             <a:extLst xmlns:a="http://schemas.openxmlformats.org/drawingml/2006/main">
               <a:ext uri="{FF2B5EF4-FFF2-40B4-BE49-F238E27FC236}">
-                <a16:creationId xmlns:a16="http://schemas.microsoft.com/office/drawing/2014/main" id="{71658213-CDBA-4EC3-A4A9-066059B604A3}"/>
+                <a16:creationId xmlns:a16="http://schemas.microsoft.com/office/drawing/2014/main" id="{CCE35BB6-16C9-4276-B4AF-F94BD69852C2}"/>
               </a:ext>
             </a:extLst>
           </p:cNvPr>
@@ -8203,7 +8618,7 @@
           <p:cNvPr id="12" name="">
             <a:extLst xmlns:a="http://schemas.openxmlformats.org/drawingml/2006/main">
               <a:ext uri="{FF2B5EF4-FFF2-40B4-BE49-F238E27FC236}">
-                <a16:creationId xmlns:a16="http://schemas.microsoft.com/office/drawing/2014/main" id="{898920FA-A30C-4B2C-AEA9-AF003052D4D2}"/>
+                <a16:creationId xmlns:a16="http://schemas.microsoft.com/office/drawing/2014/main" id="{2319307E-7D17-478C-82EE-1845FF19A134}"/>
               </a:ext>
             </a:extLst>
           </p:cNvPr>
@@ -8236,7 +8651,7 @@
           <p:cNvPr id="13" name="">
             <a:extLst xmlns:a="http://schemas.openxmlformats.org/drawingml/2006/main">
               <a:ext uri="{FF2B5EF4-FFF2-40B4-BE49-F238E27FC236}">
-                <a16:creationId xmlns:a16="http://schemas.microsoft.com/office/drawing/2014/main" id="{5199665C-7CDA-4DBD-9EEB-21439C500F4A}"/>
+                <a16:creationId xmlns:a16="http://schemas.microsoft.com/office/drawing/2014/main" id="{D533C7DB-504F-4D37-8C53-D4220304006F}"/>
               </a:ext>
             </a:extLst>
           </p:cNvPr>
@@ -8293,7 +8708,7 @@
           <p:cNvPr id="14" name="">
             <a:extLst xmlns:a="http://schemas.openxmlformats.org/drawingml/2006/main">
               <a:ext uri="{FF2B5EF4-FFF2-40B4-BE49-F238E27FC236}">
-                <a16:creationId xmlns:a16="http://schemas.microsoft.com/office/drawing/2014/main" id="{5D7BEB52-419C-4642-B5F7-7A885DB299F8}"/>
+                <a16:creationId xmlns:a16="http://schemas.microsoft.com/office/drawing/2014/main" id="{78E43A9E-5847-46A9-A6EC-991E766D219B}"/>
               </a:ext>
             </a:extLst>
           </p:cNvPr>
@@ -8377,7 +8792,7 @@
           <p:cNvPr id="15" name="">
             <a:extLst xmlns:a="http://schemas.openxmlformats.org/drawingml/2006/main">
               <a:ext uri="{FF2B5EF4-FFF2-40B4-BE49-F238E27FC236}">
-                <a16:creationId xmlns:a16="http://schemas.microsoft.com/office/drawing/2014/main" id="{2F853F79-AFE0-4F40-8565-B9004231CF0E}"/>
+                <a16:creationId xmlns:a16="http://schemas.microsoft.com/office/drawing/2014/main" id="{EE1F8CA1-8059-4626-9429-C445EF6D0719}"/>
               </a:ext>
             </a:extLst>
           </p:cNvPr>
@@ -8412,7 +8827,7 @@
           <p:cNvPr id="16" name="">
             <a:extLst xmlns:a="http://schemas.openxmlformats.org/drawingml/2006/main">
               <a:ext uri="{FF2B5EF4-FFF2-40B4-BE49-F238E27FC236}">
-                <a16:creationId xmlns:a16="http://schemas.microsoft.com/office/drawing/2014/main" id="{E48B7482-4641-4A45-961F-51CD75357A59}"/>
+                <a16:creationId xmlns:a16="http://schemas.microsoft.com/office/drawing/2014/main" id="{16BD5B3E-88D6-4348-926A-13772491E13B}"/>
               </a:ext>
             </a:extLst>
           </p:cNvPr>
@@ -8445,7 +8860,7 @@
           <p:cNvPr id="17" name="">
             <a:extLst xmlns:a="http://schemas.openxmlformats.org/drawingml/2006/main">
               <a:ext uri="{FF2B5EF4-FFF2-40B4-BE49-F238E27FC236}">
-                <a16:creationId xmlns:a16="http://schemas.microsoft.com/office/drawing/2014/main" id="{964CF577-3E9D-4451-9BBF-781223CDB592}"/>
+                <a16:creationId xmlns:a16="http://schemas.microsoft.com/office/drawing/2014/main" id="{96B598CD-25A1-4C4D-8A28-8317D12614A9}"/>
               </a:ext>
             </a:extLst>
           </p:cNvPr>
@@ -8502,7 +8917,7 @@
           <p:cNvPr id="18" name="">
             <a:extLst xmlns:a="http://schemas.openxmlformats.org/drawingml/2006/main">
               <a:ext uri="{FF2B5EF4-FFF2-40B4-BE49-F238E27FC236}">
-                <a16:creationId xmlns:a16="http://schemas.microsoft.com/office/drawing/2014/main" id="{85B91EFA-949A-4F3B-8D2E-CD5B52D97E5D}"/>
+                <a16:creationId xmlns:a16="http://schemas.microsoft.com/office/drawing/2014/main" id="{1EC9DE42-5509-4FC2-9271-A22BA320AC3B}"/>
               </a:ext>
             </a:extLst>
           </p:cNvPr>
@@ -8559,7 +8974,7 @@
           <p:cNvPr id="19" name="">
             <a:extLst xmlns:a="http://schemas.openxmlformats.org/drawingml/2006/main">
               <a:ext uri="{FF2B5EF4-FFF2-40B4-BE49-F238E27FC236}">
-                <a16:creationId xmlns:a16="http://schemas.microsoft.com/office/drawing/2014/main" id="{CBA0EACA-9A99-4CFA-B492-EB7E7D03D908}"/>
+                <a16:creationId xmlns:a16="http://schemas.microsoft.com/office/drawing/2014/main" id="{A2D96D15-3CB6-4F3B-BE4B-2417A5B51F4F}"/>
               </a:ext>
             </a:extLst>
           </p:cNvPr>
@@ -8614,7 +9029,7 @@
     </p:spTree>
     <p:extLst>
       <p:ext uri="{BB962C8B-B14F-4D97-AF65-F5344CB8AC3E}">
-        <p14:creationId xmlns:p14="http://schemas.microsoft.com/office/powerpoint/2010/main" val="2015351249"/>
+        <p14:creationId xmlns:p14="http://schemas.microsoft.com/office/powerpoint/2010/main" val="265501848"/>
       </p:ext>
     </p:extLst>
   </p:cSld>
@@ -8645,7 +9060,7 @@
           <p:cNvPr id="1" name="kicker-marker">
             <a:extLst xmlns:a="http://schemas.openxmlformats.org/drawingml/2006/main">
               <a:ext uri="{FF2B5EF4-FFF2-40B4-BE49-F238E27FC236}">
-                <a16:creationId xmlns:a16="http://schemas.microsoft.com/office/drawing/2014/main" id="{2DFC53BA-5AAB-4223-9026-866698816C70}"/>
+                <a16:creationId xmlns:a16="http://schemas.microsoft.com/office/drawing/2014/main" id="{3A952EAB-3CA5-4B60-B8F9-97E44CBE4429}"/>
               </a:ext>
             </a:extLst>
           </p:cNvPr>
@@ -8680,7 +9095,7 @@
           <p:cNvPr id="2" name="kicker-label">
             <a:extLst xmlns:a="http://schemas.openxmlformats.org/drawingml/2006/main">
               <a:ext uri="{FF2B5EF4-FFF2-40B4-BE49-F238E27FC236}">
-                <a16:creationId xmlns:a16="http://schemas.microsoft.com/office/drawing/2014/main" id="{383A957C-2972-4E3D-A1CE-A003CFFE5253}"/>
+                <a16:creationId xmlns:a16="http://schemas.microsoft.com/office/drawing/2014/main" id="{88467436-3A77-40F2-BE6B-93DFB6E31CB8}"/>
               </a:ext>
             </a:extLst>
           </p:cNvPr>
@@ -8737,7 +9152,7 @@
           <p:cNvPr id="3" name="">
             <a:extLst xmlns:a="http://schemas.openxmlformats.org/drawingml/2006/main">
               <a:ext uri="{FF2B5EF4-FFF2-40B4-BE49-F238E27FC236}">
-                <a16:creationId xmlns:a16="http://schemas.microsoft.com/office/drawing/2014/main" id="{8FF54BD8-CA05-410A-9A53-0F2E90BF9902}"/>
+                <a16:creationId xmlns:a16="http://schemas.microsoft.com/office/drawing/2014/main" id="{37FA5E88-9324-4D58-8584-AA9688C8F8C3}"/>
               </a:ext>
             </a:extLst>
           </p:cNvPr>
@@ -8794,7 +9209,7 @@
           <p:cNvPr id="4" name="">
             <a:extLst xmlns:a="http://schemas.openxmlformats.org/drawingml/2006/main">
               <a:ext uri="{FF2B5EF4-FFF2-40B4-BE49-F238E27FC236}">
-                <a16:creationId xmlns:a16="http://schemas.microsoft.com/office/drawing/2014/main" id="{CA4FB42F-5FFD-481B-A605-83F4C1772FD2}"/>
+                <a16:creationId xmlns:a16="http://schemas.microsoft.com/office/drawing/2014/main" id="{EC415799-95C8-4E15-AFD9-E2FB0696E4AB}"/>
               </a:ext>
             </a:extLst>
           </p:cNvPr>
@@ -8851,7 +9266,7 @@
           <p:cNvPr id="5" name="">
             <a:extLst xmlns:a="http://schemas.openxmlformats.org/drawingml/2006/main">
               <a:ext uri="{FF2B5EF4-FFF2-40B4-BE49-F238E27FC236}">
-                <a16:creationId xmlns:a16="http://schemas.microsoft.com/office/drawing/2014/main" id="{8FEBFEAC-1CF3-46DC-AE20-2CDF67AC3368}"/>
+                <a16:creationId xmlns:a16="http://schemas.microsoft.com/office/drawing/2014/main" id="{09D82AF7-2F49-4503-A50E-AB1C8BD69331}"/>
               </a:ext>
             </a:extLst>
           </p:cNvPr>
@@ -8886,7 +9301,7 @@
           <p:cNvPr id="6" name="">
             <a:extLst xmlns:a="http://schemas.openxmlformats.org/drawingml/2006/main">
               <a:ext uri="{FF2B5EF4-FFF2-40B4-BE49-F238E27FC236}">
-                <a16:creationId xmlns:a16="http://schemas.microsoft.com/office/drawing/2014/main" id="{A9CFCB55-9E8B-4018-92BD-7AD601B0E0C0}"/>
+                <a16:creationId xmlns:a16="http://schemas.microsoft.com/office/drawing/2014/main" id="{6EDAF45C-7725-421C-B59F-8F1066CF1D35}"/>
               </a:ext>
             </a:extLst>
           </p:cNvPr>
@@ -8943,7 +9358,7 @@
           <p:cNvPr id="7" name="">
             <a:extLst xmlns:a="http://schemas.openxmlformats.org/drawingml/2006/main">
               <a:ext uri="{FF2B5EF4-FFF2-40B4-BE49-F238E27FC236}">
-                <a16:creationId xmlns:a16="http://schemas.microsoft.com/office/drawing/2014/main" id="{5361C564-BA2B-41B6-8334-F67DEEBDB577}"/>
+                <a16:creationId xmlns:a16="http://schemas.microsoft.com/office/drawing/2014/main" id="{116A02F7-03E4-4739-8ED1-6598ECDCA422}"/>
               </a:ext>
             </a:extLst>
           </p:cNvPr>
@@ -9000,7 +9415,7 @@
           <p:cNvPr id="8" name="">
             <a:extLst xmlns:a="http://schemas.openxmlformats.org/drawingml/2006/main">
               <a:ext uri="{FF2B5EF4-FFF2-40B4-BE49-F238E27FC236}">
-                <a16:creationId xmlns:a16="http://schemas.microsoft.com/office/drawing/2014/main" id="{04800195-04EF-4AC8-97E3-7ADD793A2218}"/>
+                <a16:creationId xmlns:a16="http://schemas.microsoft.com/office/drawing/2014/main" id="{85193135-F10E-498D-9D2C-6CC5DA176F55}"/>
               </a:ext>
             </a:extLst>
           </p:cNvPr>
@@ -9057,7 +9472,7 @@
           <p:cNvPr id="9" name="">
             <a:extLst xmlns:a="http://schemas.openxmlformats.org/drawingml/2006/main">
               <a:ext uri="{FF2B5EF4-FFF2-40B4-BE49-F238E27FC236}">
-                <a16:creationId xmlns:a16="http://schemas.microsoft.com/office/drawing/2014/main" id="{6D5E8E24-A1F4-4954-896C-EFEBF3F00950}"/>
+                <a16:creationId xmlns:a16="http://schemas.microsoft.com/office/drawing/2014/main" id="{A6196EC6-3764-4EEF-A380-9A9962EE6815}"/>
               </a:ext>
             </a:extLst>
           </p:cNvPr>
@@ -9092,7 +9507,7 @@
           <p:cNvPr id="10" name="">
             <a:extLst xmlns:a="http://schemas.openxmlformats.org/drawingml/2006/main">
               <a:ext uri="{FF2B5EF4-FFF2-40B4-BE49-F238E27FC236}">
-                <a16:creationId xmlns:a16="http://schemas.microsoft.com/office/drawing/2014/main" id="{7A09089C-32CC-41E4-AA03-BA3F80104F6F}"/>
+                <a16:creationId xmlns:a16="http://schemas.microsoft.com/office/drawing/2014/main" id="{78FE46F6-F163-4CAD-8D85-6B5AABF6164F}"/>
               </a:ext>
             </a:extLst>
           </p:cNvPr>
@@ -9127,7 +9542,7 @@
           <p:cNvPr id="11" name="">
             <a:extLst xmlns:a="http://schemas.openxmlformats.org/drawingml/2006/main">
               <a:ext uri="{FF2B5EF4-FFF2-40B4-BE49-F238E27FC236}">
-                <a16:creationId xmlns:a16="http://schemas.microsoft.com/office/drawing/2014/main" id="{5DA9B373-5BEF-4758-9E63-4345B0736215}"/>
+                <a16:creationId xmlns:a16="http://schemas.microsoft.com/office/drawing/2014/main" id="{60E80144-B2C9-4B81-A9D8-FB48D08A5C60}"/>
               </a:ext>
             </a:extLst>
           </p:cNvPr>
@@ -9184,7 +9599,7 @@
           <p:cNvPr id="12" name="">
             <a:extLst xmlns:a="http://schemas.openxmlformats.org/drawingml/2006/main">
               <a:ext uri="{FF2B5EF4-FFF2-40B4-BE49-F238E27FC236}">
-                <a16:creationId xmlns:a16="http://schemas.microsoft.com/office/drawing/2014/main" id="{EE6E007D-1D05-4CD3-87F7-D83A6A6015AC}"/>
+                <a16:creationId xmlns:a16="http://schemas.microsoft.com/office/drawing/2014/main" id="{5101448E-8BB2-4D1B-BCF2-47DA4B01E325}"/>
               </a:ext>
             </a:extLst>
           </p:cNvPr>
@@ -9241,7 +9656,7 @@
           <p:cNvPr id="13" name="">
             <a:extLst xmlns:a="http://schemas.openxmlformats.org/drawingml/2006/main">
               <a:ext uri="{FF2B5EF4-FFF2-40B4-BE49-F238E27FC236}">
-                <a16:creationId xmlns:a16="http://schemas.microsoft.com/office/drawing/2014/main" id="{92DF742B-C112-4811-A9EC-821F64920131}"/>
+                <a16:creationId xmlns:a16="http://schemas.microsoft.com/office/drawing/2014/main" id="{E8AE3A40-9D38-4C7E-8CDF-F1B943C0B269}"/>
               </a:ext>
             </a:extLst>
           </p:cNvPr>
@@ -9276,7 +9691,7 @@
           <p:cNvPr id="14" name="">
             <a:extLst xmlns:a="http://schemas.openxmlformats.org/drawingml/2006/main">
               <a:ext uri="{FF2B5EF4-FFF2-40B4-BE49-F238E27FC236}">
-                <a16:creationId xmlns:a16="http://schemas.microsoft.com/office/drawing/2014/main" id="{77218D4E-D99D-4839-ACB9-B29A06F72685}"/>
+                <a16:creationId xmlns:a16="http://schemas.microsoft.com/office/drawing/2014/main" id="{18179C57-7F73-471D-A9F5-A501FF2B7596}"/>
               </a:ext>
             </a:extLst>
           </p:cNvPr>
@@ -9311,7 +9726,7 @@
           <p:cNvPr id="15" name="">
             <a:extLst xmlns:a="http://schemas.openxmlformats.org/drawingml/2006/main">
               <a:ext uri="{FF2B5EF4-FFF2-40B4-BE49-F238E27FC236}">
-                <a16:creationId xmlns:a16="http://schemas.microsoft.com/office/drawing/2014/main" id="{061138D0-ECDA-45D6-B074-D150920D8BA9}"/>
+                <a16:creationId xmlns:a16="http://schemas.microsoft.com/office/drawing/2014/main" id="{09644480-9517-46A6-AD54-EF3AEB88A059}"/>
               </a:ext>
             </a:extLst>
           </p:cNvPr>
@@ -9368,7 +9783,7 @@
           <p:cNvPr id="16" name="">
             <a:extLst xmlns:a="http://schemas.openxmlformats.org/drawingml/2006/main">
               <a:ext uri="{FF2B5EF4-FFF2-40B4-BE49-F238E27FC236}">
-                <a16:creationId xmlns:a16="http://schemas.microsoft.com/office/drawing/2014/main" id="{404DDB08-87B9-4FD1-AE63-4F40F2D6AEDF}"/>
+                <a16:creationId xmlns:a16="http://schemas.microsoft.com/office/drawing/2014/main" id="{B62FF67E-C655-45E1-A5D5-1E9065D04F3B}"/>
               </a:ext>
             </a:extLst>
           </p:cNvPr>
@@ -9425,7 +9840,7 @@
           <p:cNvPr id="17" name="">
             <a:extLst xmlns:a="http://schemas.openxmlformats.org/drawingml/2006/main">
               <a:ext uri="{FF2B5EF4-FFF2-40B4-BE49-F238E27FC236}">
-                <a16:creationId xmlns:a16="http://schemas.microsoft.com/office/drawing/2014/main" id="{40262A50-9F43-463F-BAA1-37449798E64D}"/>
+                <a16:creationId xmlns:a16="http://schemas.microsoft.com/office/drawing/2014/main" id="{55BB94FA-FF94-46B3-A3CB-1151E25C70AA}"/>
               </a:ext>
             </a:extLst>
           </p:cNvPr>
@@ -9460,7 +9875,7 @@
           <p:cNvPr id="18" name="">
             <a:extLst xmlns:a="http://schemas.openxmlformats.org/drawingml/2006/main">
               <a:ext uri="{FF2B5EF4-FFF2-40B4-BE49-F238E27FC236}">
-                <a16:creationId xmlns:a16="http://schemas.microsoft.com/office/drawing/2014/main" id="{0F6EF9C4-44E3-4D85-B5C7-00874C90DABC}"/>
+                <a16:creationId xmlns:a16="http://schemas.microsoft.com/office/drawing/2014/main" id="{541704D5-D029-4334-807E-7E810E5DBFEE}"/>
               </a:ext>
             </a:extLst>
           </p:cNvPr>
@@ -9495,7 +9910,7 @@
           <p:cNvPr id="19" name="">
             <a:extLst xmlns:a="http://schemas.openxmlformats.org/drawingml/2006/main">
               <a:ext uri="{FF2B5EF4-FFF2-40B4-BE49-F238E27FC236}">
-                <a16:creationId xmlns:a16="http://schemas.microsoft.com/office/drawing/2014/main" id="{980A7029-723E-4200-B61C-4B28992C73CD}"/>
+                <a16:creationId xmlns:a16="http://schemas.microsoft.com/office/drawing/2014/main" id="{89726776-B443-4E33-821B-0DEA804703F0}"/>
               </a:ext>
             </a:extLst>
           </p:cNvPr>
@@ -9552,7 +9967,7 @@
           <p:cNvPr id="20" name="">
             <a:extLst xmlns:a="http://schemas.openxmlformats.org/drawingml/2006/main">
               <a:ext uri="{FF2B5EF4-FFF2-40B4-BE49-F238E27FC236}">
-                <a16:creationId xmlns:a16="http://schemas.microsoft.com/office/drawing/2014/main" id="{0B1F8FE1-CE3B-4EE6-921D-6E97ADD560AA}"/>
+                <a16:creationId xmlns:a16="http://schemas.microsoft.com/office/drawing/2014/main" id="{B02FB511-A5C6-4795-A98C-D6EE77491573}"/>
               </a:ext>
             </a:extLst>
           </p:cNvPr>
@@ -9609,7 +10024,7 @@
           <p:cNvPr id="21" name="">
             <a:extLst xmlns:a="http://schemas.openxmlformats.org/drawingml/2006/main">
               <a:ext uri="{FF2B5EF4-FFF2-40B4-BE49-F238E27FC236}">
-                <a16:creationId xmlns:a16="http://schemas.microsoft.com/office/drawing/2014/main" id="{87C863C7-498E-48B3-A949-8C3F13EF6A42}"/>
+                <a16:creationId xmlns:a16="http://schemas.microsoft.com/office/drawing/2014/main" id="{223234F9-E6D0-4198-BC77-33F03A6019A8}"/>
               </a:ext>
             </a:extLst>
           </p:cNvPr>
@@ -9644,7 +10059,7 @@
           <p:cNvPr id="22" name="">
             <a:extLst xmlns:a="http://schemas.openxmlformats.org/drawingml/2006/main">
               <a:ext uri="{FF2B5EF4-FFF2-40B4-BE49-F238E27FC236}">
-                <a16:creationId xmlns:a16="http://schemas.microsoft.com/office/drawing/2014/main" id="{645AD368-ED43-4713-A05D-C94D821D01E1}"/>
+                <a16:creationId xmlns:a16="http://schemas.microsoft.com/office/drawing/2014/main" id="{A648510C-8F7C-4032-BC93-CBBFB424B823}"/>
               </a:ext>
             </a:extLst>
           </p:cNvPr>
@@ -9679,7 +10094,7 @@
           <p:cNvPr id="23" name="">
             <a:extLst xmlns:a="http://schemas.openxmlformats.org/drawingml/2006/main">
               <a:ext uri="{FF2B5EF4-FFF2-40B4-BE49-F238E27FC236}">
-                <a16:creationId xmlns:a16="http://schemas.microsoft.com/office/drawing/2014/main" id="{9A6155CD-8FBA-486D-BEFA-93C6AB1C759E}"/>
+                <a16:creationId xmlns:a16="http://schemas.microsoft.com/office/drawing/2014/main" id="{8959603A-4C84-4411-9325-FB2D07E76DDF}"/>
               </a:ext>
             </a:extLst>
           </p:cNvPr>
@@ -9736,7 +10151,7 @@
           <p:cNvPr id="24" name="">
             <a:extLst xmlns:a="http://schemas.openxmlformats.org/drawingml/2006/main">
               <a:ext uri="{FF2B5EF4-FFF2-40B4-BE49-F238E27FC236}">
-                <a16:creationId xmlns:a16="http://schemas.microsoft.com/office/drawing/2014/main" id="{A49E2061-0222-4983-978C-0438F7221443}"/>
+                <a16:creationId xmlns:a16="http://schemas.microsoft.com/office/drawing/2014/main" id="{5C7CA0F8-D298-48E8-B8E6-54209B407031}"/>
               </a:ext>
             </a:extLst>
           </p:cNvPr>
@@ -9793,7 +10208,7 @@
           <p:cNvPr id="25" name="">
             <a:extLst xmlns:a="http://schemas.openxmlformats.org/drawingml/2006/main">
               <a:ext uri="{FF2B5EF4-FFF2-40B4-BE49-F238E27FC236}">
-                <a16:creationId xmlns:a16="http://schemas.microsoft.com/office/drawing/2014/main" id="{D96CAFE3-0F9C-4D9C-874C-82E29732EABD}"/>
+                <a16:creationId xmlns:a16="http://schemas.microsoft.com/office/drawing/2014/main" id="{BC98E2D5-79B0-42A4-992A-5FDDB9FA9AA0}"/>
               </a:ext>
             </a:extLst>
           </p:cNvPr>
@@ -9828,7 +10243,7 @@
           <p:cNvPr id="26" name="">
             <a:extLst xmlns:a="http://schemas.openxmlformats.org/drawingml/2006/main">
               <a:ext uri="{FF2B5EF4-FFF2-40B4-BE49-F238E27FC236}">
-                <a16:creationId xmlns:a16="http://schemas.microsoft.com/office/drawing/2014/main" id="{BDCFA1B5-E2AE-4457-9D5F-F556513B2AFC}"/>
+                <a16:creationId xmlns:a16="http://schemas.microsoft.com/office/drawing/2014/main" id="{308413B4-A142-4D0B-AE0E-AA9D96444D80}"/>
               </a:ext>
             </a:extLst>
           </p:cNvPr>
@@ -9863,7 +10278,7 @@
           <p:cNvPr id="27" name="">
             <a:extLst xmlns:a="http://schemas.openxmlformats.org/drawingml/2006/main">
               <a:ext uri="{FF2B5EF4-FFF2-40B4-BE49-F238E27FC236}">
-                <a16:creationId xmlns:a16="http://schemas.microsoft.com/office/drawing/2014/main" id="{3C1121C4-8763-4F2E-8B72-BDD59A679DEC}"/>
+                <a16:creationId xmlns:a16="http://schemas.microsoft.com/office/drawing/2014/main" id="{7F50D511-CF95-4AF5-A866-655856BC2D51}"/>
               </a:ext>
             </a:extLst>
           </p:cNvPr>
@@ -9920,7 +10335,7 @@
           <p:cNvPr id="28" name="">
             <a:extLst xmlns:a="http://schemas.openxmlformats.org/drawingml/2006/main">
               <a:ext uri="{FF2B5EF4-FFF2-40B4-BE49-F238E27FC236}">
-                <a16:creationId xmlns:a16="http://schemas.microsoft.com/office/drawing/2014/main" id="{A6F284B6-D137-4A32-8894-CE6D4E8C1D6A}"/>
+                <a16:creationId xmlns:a16="http://schemas.microsoft.com/office/drawing/2014/main" id="{01D16DA1-BD52-4AA7-9F82-E59FC0938616}"/>
               </a:ext>
             </a:extLst>
           </p:cNvPr>
@@ -9955,7 +10370,7 @@
           <p:cNvPr id="29" name="">
             <a:extLst xmlns:a="http://schemas.openxmlformats.org/drawingml/2006/main">
               <a:ext uri="{FF2B5EF4-FFF2-40B4-BE49-F238E27FC236}">
-                <a16:creationId xmlns:a16="http://schemas.microsoft.com/office/drawing/2014/main" id="{F3AFC82D-DE3F-48B8-838A-A20B7672469E}"/>
+                <a16:creationId xmlns:a16="http://schemas.microsoft.com/office/drawing/2014/main" id="{2E6A3EB8-E8EE-4336-8011-11333FE347A3}"/>
               </a:ext>
             </a:extLst>
           </p:cNvPr>
@@ -10012,7 +10427,7 @@
           <p:cNvPr id="30" name="">
             <a:extLst xmlns:a="http://schemas.openxmlformats.org/drawingml/2006/main">
               <a:ext uri="{FF2B5EF4-FFF2-40B4-BE49-F238E27FC236}">
-                <a16:creationId xmlns:a16="http://schemas.microsoft.com/office/drawing/2014/main" id="{FC2FF683-752B-4D32-B07F-F12EE73BFBCE}"/>
+                <a16:creationId xmlns:a16="http://schemas.microsoft.com/office/drawing/2014/main" id="{AB1C24F5-7013-4FEC-AED1-706B0E9ECC06}"/>
               </a:ext>
             </a:extLst>
           </p:cNvPr>
@@ -10069,7 +10484,7 @@
           <p:cNvPr id="31" name="">
             <a:extLst xmlns:a="http://schemas.openxmlformats.org/drawingml/2006/main">
               <a:ext uri="{FF2B5EF4-FFF2-40B4-BE49-F238E27FC236}">
-                <a16:creationId xmlns:a16="http://schemas.microsoft.com/office/drawing/2014/main" id="{0A99E18A-760F-40BF-AB25-97E68A2FCFF4}"/>
+                <a16:creationId xmlns:a16="http://schemas.microsoft.com/office/drawing/2014/main" id="{A49E5932-C958-43FE-91EF-EF1EDFE006F8}"/>
               </a:ext>
             </a:extLst>
           </p:cNvPr>
@@ -10126,7 +10541,7 @@
           <p:cNvPr id="32" name="">
             <a:extLst xmlns:a="http://schemas.openxmlformats.org/drawingml/2006/main">
               <a:ext uri="{FF2B5EF4-FFF2-40B4-BE49-F238E27FC236}">
-                <a16:creationId xmlns:a16="http://schemas.microsoft.com/office/drawing/2014/main" id="{6AB641DE-3358-4DF7-8EB5-3C19FE23BA2D}"/>
+                <a16:creationId xmlns:a16="http://schemas.microsoft.com/office/drawing/2014/main" id="{6B18E821-AFD1-42A3-8127-8AA4AEC4CEB7}"/>
               </a:ext>
             </a:extLst>
           </p:cNvPr>
@@ -10161,7 +10576,7 @@
           <p:cNvPr id="33" name="">
             <a:extLst xmlns:a="http://schemas.openxmlformats.org/drawingml/2006/main">
               <a:ext uri="{FF2B5EF4-FFF2-40B4-BE49-F238E27FC236}">
-                <a16:creationId xmlns:a16="http://schemas.microsoft.com/office/drawing/2014/main" id="{6FC9A04A-DC07-44FB-A48C-BBAEA3373657}"/>
+                <a16:creationId xmlns:a16="http://schemas.microsoft.com/office/drawing/2014/main" id="{AD4DD001-562F-431B-A8F0-5B121DFC39EC}"/>
               </a:ext>
             </a:extLst>
           </p:cNvPr>
@@ -10245,7 +10660,7 @@
           <p:cNvPr id="34" name="">
             <a:extLst xmlns:a="http://schemas.openxmlformats.org/drawingml/2006/main">
               <a:ext uri="{FF2B5EF4-FFF2-40B4-BE49-F238E27FC236}">
-                <a16:creationId xmlns:a16="http://schemas.microsoft.com/office/drawing/2014/main" id="{10958B8D-E9E8-45A8-9E79-754B5703E412}"/>
+                <a16:creationId xmlns:a16="http://schemas.microsoft.com/office/drawing/2014/main" id="{F33725EE-31E1-4443-9233-6F9F09A50E88}"/>
               </a:ext>
             </a:extLst>
           </p:cNvPr>
@@ -10302,7 +10717,7 @@
           <p:cNvPr id="35" name="">
             <a:extLst xmlns:a="http://schemas.openxmlformats.org/drawingml/2006/main">
               <a:ext uri="{FF2B5EF4-FFF2-40B4-BE49-F238E27FC236}">
-                <a16:creationId xmlns:a16="http://schemas.microsoft.com/office/drawing/2014/main" id="{6DE8775B-EBF6-4079-8DA6-BC97358651F0}"/>
+                <a16:creationId xmlns:a16="http://schemas.microsoft.com/office/drawing/2014/main" id="{0F21C28F-4F80-4C51-958A-C1DF752CA1CF}"/>
               </a:ext>
             </a:extLst>
           </p:cNvPr>
@@ -10357,7 +10772,7 @@
     </p:spTree>
     <p:extLst>
       <p:ext uri="{BB962C8B-B14F-4D97-AF65-F5344CB8AC3E}">
-        <p14:creationId xmlns:p14="http://schemas.microsoft.com/office/powerpoint/2010/main" val="680111935"/>
+        <p14:creationId xmlns:p14="http://schemas.microsoft.com/office/powerpoint/2010/main" val="832597317"/>
       </p:ext>
     </p:extLst>
   </p:cSld>
@@ -10388,7 +10803,7 @@
           <p:cNvPr id="1" name="kicker-marker">
             <a:extLst xmlns:a="http://schemas.openxmlformats.org/drawingml/2006/main">
               <a:ext uri="{FF2B5EF4-FFF2-40B4-BE49-F238E27FC236}">
-                <a16:creationId xmlns:a16="http://schemas.microsoft.com/office/drawing/2014/main" id="{ECFEFFBD-76F2-4A35-889B-9000BC46A9FE}"/>
+                <a16:creationId xmlns:a16="http://schemas.microsoft.com/office/drawing/2014/main" id="{308FEC41-2E08-44FA-9A56-0524F1FA5A89}"/>
               </a:ext>
             </a:extLst>
           </p:cNvPr>
@@ -10423,7 +10838,7 @@
           <p:cNvPr id="2" name="kicker-label">
             <a:extLst xmlns:a="http://schemas.openxmlformats.org/drawingml/2006/main">
               <a:ext uri="{FF2B5EF4-FFF2-40B4-BE49-F238E27FC236}">
-                <a16:creationId xmlns:a16="http://schemas.microsoft.com/office/drawing/2014/main" id="{E4B6FD1C-71ED-4677-B1FA-84205797C93A}"/>
+                <a16:creationId xmlns:a16="http://schemas.microsoft.com/office/drawing/2014/main" id="{7DAF7AAC-8E0D-41EF-B83B-17E8CB600E28}"/>
               </a:ext>
             </a:extLst>
           </p:cNvPr>
@@ -10480,7 +10895,7 @@
           <p:cNvPr id="3" name="">
             <a:extLst xmlns:a="http://schemas.openxmlformats.org/drawingml/2006/main">
               <a:ext uri="{FF2B5EF4-FFF2-40B4-BE49-F238E27FC236}">
-                <a16:creationId xmlns:a16="http://schemas.microsoft.com/office/drawing/2014/main" id="{CCF66F80-89F7-4606-812B-65224B300C49}"/>
+                <a16:creationId xmlns:a16="http://schemas.microsoft.com/office/drawing/2014/main" id="{8AE4931B-180B-4503-A778-C54D08BD548B}"/>
               </a:ext>
             </a:extLst>
           </p:cNvPr>
@@ -10537,7 +10952,7 @@
           <p:cNvPr id="4" name="">
             <a:extLst xmlns:a="http://schemas.openxmlformats.org/drawingml/2006/main">
               <a:ext uri="{FF2B5EF4-FFF2-40B4-BE49-F238E27FC236}">
-                <a16:creationId xmlns:a16="http://schemas.microsoft.com/office/drawing/2014/main" id="{66FFE1B3-647C-4AD4-B935-ED0C805CA67B}"/>
+                <a16:creationId xmlns:a16="http://schemas.microsoft.com/office/drawing/2014/main" id="{912F35CE-199B-4A5E-B555-93EBAA1AEA2F}"/>
               </a:ext>
             </a:extLst>
           </p:cNvPr>
@@ -10572,7 +10987,7 @@
           <p:cNvPr id="5" name="">
             <a:extLst xmlns:a="http://schemas.openxmlformats.org/drawingml/2006/main">
               <a:ext uri="{FF2B5EF4-FFF2-40B4-BE49-F238E27FC236}">
-                <a16:creationId xmlns:a16="http://schemas.microsoft.com/office/drawing/2014/main" id="{029A01E9-F9FF-4E2C-98E0-31113AEEEFAB}"/>
+                <a16:creationId xmlns:a16="http://schemas.microsoft.com/office/drawing/2014/main" id="{B88DD6E7-86CB-4920-B669-5AE14D1B148A}"/>
               </a:ext>
             </a:extLst>
           </p:cNvPr>
@@ -10629,7 +11044,7 @@
           <p:cNvPr id="6" name="">
             <a:extLst xmlns:a="http://schemas.openxmlformats.org/drawingml/2006/main">
               <a:ext uri="{FF2B5EF4-FFF2-40B4-BE49-F238E27FC236}">
-                <a16:creationId xmlns:a16="http://schemas.microsoft.com/office/drawing/2014/main" id="{32F0FF88-4199-4FB8-A630-321879416FBC}"/>
+                <a16:creationId xmlns:a16="http://schemas.microsoft.com/office/drawing/2014/main" id="{A9F8AD37-457F-4753-97F7-8A7CE4835A4F}"/>
               </a:ext>
             </a:extLst>
           </p:cNvPr>
@@ -10686,7 +11101,7 @@
           <p:cNvPr id="7" name="">
             <a:extLst xmlns:a="http://schemas.openxmlformats.org/drawingml/2006/main">
               <a:ext uri="{FF2B5EF4-FFF2-40B4-BE49-F238E27FC236}">
-                <a16:creationId xmlns:a16="http://schemas.microsoft.com/office/drawing/2014/main" id="{AA1BD527-C4A6-4AB0-A802-FDCCEC04E781}"/>
+                <a16:creationId xmlns:a16="http://schemas.microsoft.com/office/drawing/2014/main" id="{44202D02-713E-48C0-AFA8-98327A404ED5}"/>
               </a:ext>
             </a:extLst>
           </p:cNvPr>
@@ -10719,7 +11134,7 @@
           <p:cNvPr id="8" name="">
             <a:extLst xmlns:a="http://schemas.openxmlformats.org/drawingml/2006/main">
               <a:ext uri="{FF2B5EF4-FFF2-40B4-BE49-F238E27FC236}">
-                <a16:creationId xmlns:a16="http://schemas.microsoft.com/office/drawing/2014/main" id="{D7413BA5-8BE1-4280-9D0C-EBB5AD611A03}"/>
+                <a16:creationId xmlns:a16="http://schemas.microsoft.com/office/drawing/2014/main" id="{739214C2-13D3-4439-B3F7-5B6BC6864B5E}"/>
               </a:ext>
             </a:extLst>
           </p:cNvPr>
@@ -10776,7 +11191,7 @@
           <p:cNvPr id="9" name="">
             <a:extLst xmlns:a="http://schemas.openxmlformats.org/drawingml/2006/main">
               <a:ext uri="{FF2B5EF4-FFF2-40B4-BE49-F238E27FC236}">
-                <a16:creationId xmlns:a16="http://schemas.microsoft.com/office/drawing/2014/main" id="{8CE0CB15-B468-426D-B0FE-E5C2BA4C3CFB}"/>
+                <a16:creationId xmlns:a16="http://schemas.microsoft.com/office/drawing/2014/main" id="{B31B7053-E534-4058-9E1A-5D8F7D1B73A7}"/>
               </a:ext>
             </a:extLst>
           </p:cNvPr>
@@ -10833,7 +11248,7 @@
           <p:cNvPr id="10" name="">
             <a:extLst xmlns:a="http://schemas.openxmlformats.org/drawingml/2006/main">
               <a:ext uri="{FF2B5EF4-FFF2-40B4-BE49-F238E27FC236}">
-                <a16:creationId xmlns:a16="http://schemas.microsoft.com/office/drawing/2014/main" id="{B4072A94-836C-4E0C-9868-D43CF56B8780}"/>
+                <a16:creationId xmlns:a16="http://schemas.microsoft.com/office/drawing/2014/main" id="{453E0731-D996-4EA7-B6D2-0E83012571DB}"/>
               </a:ext>
             </a:extLst>
           </p:cNvPr>
@@ -10868,7 +11283,7 @@
           <p:cNvPr id="11" name="">
             <a:extLst xmlns:a="http://schemas.openxmlformats.org/drawingml/2006/main">
               <a:ext uri="{FF2B5EF4-FFF2-40B4-BE49-F238E27FC236}">
-                <a16:creationId xmlns:a16="http://schemas.microsoft.com/office/drawing/2014/main" id="{0B9586F4-84F4-4432-8D20-A5D3F1BCF6AD}"/>
+                <a16:creationId xmlns:a16="http://schemas.microsoft.com/office/drawing/2014/main" id="{3E580836-A146-4779-A40A-EFCDD971BE67}"/>
               </a:ext>
             </a:extLst>
           </p:cNvPr>
@@ -10901,7 +11316,7 @@
           <p:cNvPr id="12" name="">
             <a:extLst xmlns:a="http://schemas.openxmlformats.org/drawingml/2006/main">
               <a:ext uri="{FF2B5EF4-FFF2-40B4-BE49-F238E27FC236}">
-                <a16:creationId xmlns:a16="http://schemas.microsoft.com/office/drawing/2014/main" id="{73FAAE10-7BA0-410C-88C9-5F2199539E90}"/>
+                <a16:creationId xmlns:a16="http://schemas.microsoft.com/office/drawing/2014/main" id="{126EE412-5D23-4F4B-B924-6B0BF7F166C1}"/>
               </a:ext>
             </a:extLst>
           </p:cNvPr>
@@ -10958,7 +11373,7 @@
           <p:cNvPr id="13" name="">
             <a:extLst xmlns:a="http://schemas.openxmlformats.org/drawingml/2006/main">
               <a:ext uri="{FF2B5EF4-FFF2-40B4-BE49-F238E27FC236}">
-                <a16:creationId xmlns:a16="http://schemas.microsoft.com/office/drawing/2014/main" id="{C7CC42D7-501F-474C-8B35-4D396E79BCC9}"/>
+                <a16:creationId xmlns:a16="http://schemas.microsoft.com/office/drawing/2014/main" id="{7BE32301-E5B7-45BC-9235-200196A1C14F}"/>
               </a:ext>
             </a:extLst>
           </p:cNvPr>
@@ -11096,7 +11511,7 @@
           <p:cNvPr id="14" name="">
             <a:extLst xmlns:a="http://schemas.openxmlformats.org/drawingml/2006/main">
               <a:ext uri="{FF2B5EF4-FFF2-40B4-BE49-F238E27FC236}">
-                <a16:creationId xmlns:a16="http://schemas.microsoft.com/office/drawing/2014/main" id="{D0D6B5BD-250E-4677-B1C0-C9CA6F5B90A0}"/>
+                <a16:creationId xmlns:a16="http://schemas.microsoft.com/office/drawing/2014/main" id="{3353B7B9-B9B4-4752-BB84-316B25914C7A}"/>
               </a:ext>
             </a:extLst>
           </p:cNvPr>
@@ -11131,7 +11546,7 @@
           <p:cNvPr id="15" name="">
             <a:extLst xmlns:a="http://schemas.openxmlformats.org/drawingml/2006/main">
               <a:ext uri="{FF2B5EF4-FFF2-40B4-BE49-F238E27FC236}">
-                <a16:creationId xmlns:a16="http://schemas.microsoft.com/office/drawing/2014/main" id="{2CAA2024-25E6-4826-9097-21BE20E59018}"/>
+                <a16:creationId xmlns:a16="http://schemas.microsoft.com/office/drawing/2014/main" id="{A5C3B6AE-8AA6-43D8-BE89-778DA347A2F7}"/>
               </a:ext>
             </a:extLst>
           </p:cNvPr>
@@ -11164,7 +11579,7 @@
           <p:cNvPr id="16" name="">
             <a:extLst xmlns:a="http://schemas.openxmlformats.org/drawingml/2006/main">
               <a:ext uri="{FF2B5EF4-FFF2-40B4-BE49-F238E27FC236}">
-                <a16:creationId xmlns:a16="http://schemas.microsoft.com/office/drawing/2014/main" id="{7F87195E-4B22-4AD4-A053-8B5D0971B5C2}"/>
+                <a16:creationId xmlns:a16="http://schemas.microsoft.com/office/drawing/2014/main" id="{0F59B48E-3661-4A05-9A2C-B5FB670FD3BA}"/>
               </a:ext>
             </a:extLst>
           </p:cNvPr>
@@ -11221,7 +11636,7 @@
           <p:cNvPr id="17" name="">
             <a:extLst xmlns:a="http://schemas.openxmlformats.org/drawingml/2006/main">
               <a:ext uri="{FF2B5EF4-FFF2-40B4-BE49-F238E27FC236}">
-                <a16:creationId xmlns:a16="http://schemas.microsoft.com/office/drawing/2014/main" id="{857EF978-3A01-45A7-A3A6-DCB7FDDA62D3}"/>
+                <a16:creationId xmlns:a16="http://schemas.microsoft.com/office/drawing/2014/main" id="{551BADF9-B409-4C46-A3D1-8D5B306EC1BB}"/>
               </a:ext>
             </a:extLst>
           </p:cNvPr>
@@ -11332,7 +11747,7 @@
           <p:cNvPr id="18" name="">
             <a:extLst xmlns:a="http://schemas.openxmlformats.org/drawingml/2006/main">
               <a:ext uri="{FF2B5EF4-FFF2-40B4-BE49-F238E27FC236}">
-                <a16:creationId xmlns:a16="http://schemas.microsoft.com/office/drawing/2014/main" id="{D57649FD-F240-41B5-848D-47EEEF3940EE}"/>
+                <a16:creationId xmlns:a16="http://schemas.microsoft.com/office/drawing/2014/main" id="{22036465-725D-489F-8E03-0F74606FC540}"/>
               </a:ext>
             </a:extLst>
           </p:cNvPr>
@@ -11387,7 +11802,7 @@
     </p:spTree>
     <p:extLst>
       <p:ext uri="{BB962C8B-B14F-4D97-AF65-F5344CB8AC3E}">
-        <p14:creationId xmlns:p14="http://schemas.microsoft.com/office/powerpoint/2010/main" val="1122780708"/>
+        <p14:creationId xmlns:p14="http://schemas.microsoft.com/office/powerpoint/2010/main" val="25675135"/>
       </p:ext>
     </p:extLst>
   </p:cSld>
@@ -11418,7 +11833,7 @@
           <p:cNvPr id="1" name="kicker-marker">
             <a:extLst xmlns:a="http://schemas.openxmlformats.org/drawingml/2006/main">
               <a:ext uri="{FF2B5EF4-FFF2-40B4-BE49-F238E27FC236}">
-                <a16:creationId xmlns:a16="http://schemas.microsoft.com/office/drawing/2014/main" id="{A879D66A-C219-4501-A5C8-BE7C84E99889}"/>
+                <a16:creationId xmlns:a16="http://schemas.microsoft.com/office/drawing/2014/main" id="{1F10C66A-245F-4072-8EBB-0E0DA8834504}"/>
               </a:ext>
             </a:extLst>
           </p:cNvPr>
@@ -11453,7 +11868,7 @@
           <p:cNvPr id="2" name="kicker-label">
             <a:extLst xmlns:a="http://schemas.openxmlformats.org/drawingml/2006/main">
               <a:ext uri="{FF2B5EF4-FFF2-40B4-BE49-F238E27FC236}">
-                <a16:creationId xmlns:a16="http://schemas.microsoft.com/office/drawing/2014/main" id="{3F801202-360D-4BBF-8CF0-6B8FF1E5E929}"/>
+                <a16:creationId xmlns:a16="http://schemas.microsoft.com/office/drawing/2014/main" id="{C8B9EB1C-0C9E-46D5-8E59-90BE9266B6D5}"/>
               </a:ext>
             </a:extLst>
           </p:cNvPr>
@@ -11510,7 +11925,7 @@
           <p:cNvPr id="3" name="">
             <a:extLst xmlns:a="http://schemas.openxmlformats.org/drawingml/2006/main">
               <a:ext uri="{FF2B5EF4-FFF2-40B4-BE49-F238E27FC236}">
-                <a16:creationId xmlns:a16="http://schemas.microsoft.com/office/drawing/2014/main" id="{2173993F-72D7-4F01-A7E6-A7D8011983D7}"/>
+                <a16:creationId xmlns:a16="http://schemas.microsoft.com/office/drawing/2014/main" id="{213FE7F9-F9E2-47CF-A8F3-7A8C19B27C99}"/>
               </a:ext>
             </a:extLst>
           </p:cNvPr>
@@ -11567,7 +11982,7 @@
           <p:cNvPr id="4" name="">
             <a:extLst xmlns:a="http://schemas.openxmlformats.org/drawingml/2006/main">
               <a:ext uri="{FF2B5EF4-FFF2-40B4-BE49-F238E27FC236}">
-                <a16:creationId xmlns:a16="http://schemas.microsoft.com/office/drawing/2014/main" id="{44ECB12F-7D71-44F1-89A6-FFA42652DE06}"/>
+                <a16:creationId xmlns:a16="http://schemas.microsoft.com/office/drawing/2014/main" id="{8FFDF328-D5C0-4F89-867C-CB2CDD48CB3B}"/>
               </a:ext>
             </a:extLst>
           </p:cNvPr>
@@ -11602,7 +12017,7 @@
           <p:cNvPr id="5" name="">
             <a:extLst xmlns:a="http://schemas.openxmlformats.org/drawingml/2006/main">
               <a:ext uri="{FF2B5EF4-FFF2-40B4-BE49-F238E27FC236}">
-                <a16:creationId xmlns:a16="http://schemas.microsoft.com/office/drawing/2014/main" id="{E16B4003-9DF1-4370-BF1B-71931155146E}"/>
+                <a16:creationId xmlns:a16="http://schemas.microsoft.com/office/drawing/2014/main" id="{BEA91F60-AC5A-4C7D-A275-05604F949081}"/>
               </a:ext>
             </a:extLst>
           </p:cNvPr>
@@ -11659,7 +12074,7 @@
           <p:cNvPr id="6" name="">
             <a:extLst xmlns:a="http://schemas.openxmlformats.org/drawingml/2006/main">
               <a:ext uri="{FF2B5EF4-FFF2-40B4-BE49-F238E27FC236}">
-                <a16:creationId xmlns:a16="http://schemas.microsoft.com/office/drawing/2014/main" id="{17FBF279-A310-4B44-B52C-20B8FAF418CA}"/>
+                <a16:creationId xmlns:a16="http://schemas.microsoft.com/office/drawing/2014/main" id="{AAC071D4-74D4-4C5C-8511-8125567EE4C9}"/>
               </a:ext>
             </a:extLst>
           </p:cNvPr>
@@ -11716,7 +12131,7 @@
           <p:cNvPr id="7" name="">
             <a:extLst xmlns:a="http://schemas.openxmlformats.org/drawingml/2006/main">
               <a:ext uri="{FF2B5EF4-FFF2-40B4-BE49-F238E27FC236}">
-                <a16:creationId xmlns:a16="http://schemas.microsoft.com/office/drawing/2014/main" id="{F27DC4F1-4DC3-4786-8BA8-BDC63D6102DB}"/>
+                <a16:creationId xmlns:a16="http://schemas.microsoft.com/office/drawing/2014/main" id="{B97164D4-2BE6-41ED-88A6-2E061B9024DD}"/>
               </a:ext>
             </a:extLst>
           </p:cNvPr>
@@ -11751,7 +12166,7 @@
           <p:cNvPr id="8" name="">
             <a:extLst xmlns:a="http://schemas.openxmlformats.org/drawingml/2006/main">
               <a:ext uri="{FF2B5EF4-FFF2-40B4-BE49-F238E27FC236}">
-                <a16:creationId xmlns:a16="http://schemas.microsoft.com/office/drawing/2014/main" id="{84622651-7E1A-4DD7-B337-040E65D136F6}"/>
+                <a16:creationId xmlns:a16="http://schemas.microsoft.com/office/drawing/2014/main" id="{FB05CAFC-47F1-4572-A2B6-13DCEF324400}"/>
               </a:ext>
             </a:extLst>
           </p:cNvPr>
@@ -11786,7 +12201,7 @@
           <p:cNvPr id="9" name="">
             <a:extLst xmlns:a="http://schemas.openxmlformats.org/drawingml/2006/main">
               <a:ext uri="{FF2B5EF4-FFF2-40B4-BE49-F238E27FC236}">
-                <a16:creationId xmlns:a16="http://schemas.microsoft.com/office/drawing/2014/main" id="{C5C0FE12-3832-4082-89B2-4F85B55FD060}"/>
+                <a16:creationId xmlns:a16="http://schemas.microsoft.com/office/drawing/2014/main" id="{8B3168E7-A2B6-4449-BE63-22C2B3EB974C}"/>
               </a:ext>
             </a:extLst>
           </p:cNvPr>
@@ -11843,7 +12258,7 @@
           <p:cNvPr id="10" name="">
             <a:extLst xmlns:a="http://schemas.openxmlformats.org/drawingml/2006/main">
               <a:ext uri="{FF2B5EF4-FFF2-40B4-BE49-F238E27FC236}">
-                <a16:creationId xmlns:a16="http://schemas.microsoft.com/office/drawing/2014/main" id="{B640A7B5-2163-42A4-9D81-54800BA0E8D9}"/>
+                <a16:creationId xmlns:a16="http://schemas.microsoft.com/office/drawing/2014/main" id="{75C51AEB-6931-488E-B590-E5A6C77C27E8}"/>
               </a:ext>
             </a:extLst>
           </p:cNvPr>
@@ -11878,7 +12293,7 @@
           <p:cNvPr id="11" name="">
             <a:extLst xmlns:a="http://schemas.openxmlformats.org/drawingml/2006/main">
               <a:ext uri="{FF2B5EF4-FFF2-40B4-BE49-F238E27FC236}">
-                <a16:creationId xmlns:a16="http://schemas.microsoft.com/office/drawing/2014/main" id="{24C15596-1560-4D1E-8D72-DE565F0C3C27}"/>
+                <a16:creationId xmlns:a16="http://schemas.microsoft.com/office/drawing/2014/main" id="{E30CEDDD-3431-4EDD-BA47-F22F24502AB7}"/>
               </a:ext>
             </a:extLst>
           </p:cNvPr>
@@ -11913,7 +12328,7 @@
           <p:cNvPr id="12" name="">
             <a:extLst xmlns:a="http://schemas.openxmlformats.org/drawingml/2006/main">
               <a:ext uri="{FF2B5EF4-FFF2-40B4-BE49-F238E27FC236}">
-                <a16:creationId xmlns:a16="http://schemas.microsoft.com/office/drawing/2014/main" id="{E8EE56FC-C5BA-4A26-B03C-2F16926E5E96}"/>
+                <a16:creationId xmlns:a16="http://schemas.microsoft.com/office/drawing/2014/main" id="{84100A9A-AEF3-41FA-9D98-20AB8DC1CA00}"/>
               </a:ext>
             </a:extLst>
           </p:cNvPr>
@@ -11948,7 +12363,7 @@
           <p:cNvPr id="13" name="">
             <a:extLst xmlns:a="http://schemas.openxmlformats.org/drawingml/2006/main">
               <a:ext uri="{FF2B5EF4-FFF2-40B4-BE49-F238E27FC236}">
-                <a16:creationId xmlns:a16="http://schemas.microsoft.com/office/drawing/2014/main" id="{46CB9D37-579B-446B-B112-36130616A70A}"/>
+                <a16:creationId xmlns:a16="http://schemas.microsoft.com/office/drawing/2014/main" id="{1E0330FD-041D-438C-B2C1-B76AEAD998BA}"/>
               </a:ext>
             </a:extLst>
           </p:cNvPr>
@@ -11983,7 +12398,7 @@
           <p:cNvPr id="14" name="">
             <a:extLst xmlns:a="http://schemas.openxmlformats.org/drawingml/2006/main">
               <a:ext uri="{FF2B5EF4-FFF2-40B4-BE49-F238E27FC236}">
-                <a16:creationId xmlns:a16="http://schemas.microsoft.com/office/drawing/2014/main" id="{05E33097-94DA-48E7-8684-A8905D03D64D}"/>
+                <a16:creationId xmlns:a16="http://schemas.microsoft.com/office/drawing/2014/main" id="{756BDA89-92EE-4A63-A5CF-254A52D0741B}"/>
               </a:ext>
             </a:extLst>
           </p:cNvPr>
@@ -12018,7 +12433,7 @@
           <p:cNvPr id="15" name="">
             <a:extLst xmlns:a="http://schemas.openxmlformats.org/drawingml/2006/main">
               <a:ext uri="{FF2B5EF4-FFF2-40B4-BE49-F238E27FC236}">
-                <a16:creationId xmlns:a16="http://schemas.microsoft.com/office/drawing/2014/main" id="{069FA901-B912-4E2E-9E74-E97B1747242F}"/>
+                <a16:creationId xmlns:a16="http://schemas.microsoft.com/office/drawing/2014/main" id="{583E09BD-50E2-4C45-BB11-C44288C47776}"/>
               </a:ext>
             </a:extLst>
           </p:cNvPr>
@@ -12053,7 +12468,7 @@
           <p:cNvPr id="16" name="">
             <a:extLst xmlns:a="http://schemas.openxmlformats.org/drawingml/2006/main">
               <a:ext uri="{FF2B5EF4-FFF2-40B4-BE49-F238E27FC236}">
-                <a16:creationId xmlns:a16="http://schemas.microsoft.com/office/drawing/2014/main" id="{E1D37762-58E8-432C-A468-64E3BCD948DE}"/>
+                <a16:creationId xmlns:a16="http://schemas.microsoft.com/office/drawing/2014/main" id="{FFB06FEB-9B7B-4649-8D07-7E85ABD43A19}"/>
               </a:ext>
             </a:extLst>
           </p:cNvPr>
@@ -12110,7 +12525,7 @@
           <p:cNvPr id="17" name="">
             <a:extLst xmlns:a="http://schemas.openxmlformats.org/drawingml/2006/main">
               <a:ext uri="{FF2B5EF4-FFF2-40B4-BE49-F238E27FC236}">
-                <a16:creationId xmlns:a16="http://schemas.microsoft.com/office/drawing/2014/main" id="{8E1BF622-57BD-4EB7-B802-CE953E86037F}"/>
+                <a16:creationId xmlns:a16="http://schemas.microsoft.com/office/drawing/2014/main" id="{4DC1EB11-6048-4112-8D2B-E8C6D82481A9}"/>
               </a:ext>
             </a:extLst>
           </p:cNvPr>
@@ -12145,7 +12560,7 @@
           <p:cNvPr id="18" name="">
             <a:extLst xmlns:a="http://schemas.openxmlformats.org/drawingml/2006/main">
               <a:ext uri="{FF2B5EF4-FFF2-40B4-BE49-F238E27FC236}">
-                <a16:creationId xmlns:a16="http://schemas.microsoft.com/office/drawing/2014/main" id="{C85A749A-8E6A-41AF-A812-4A655EB369CB}"/>
+                <a16:creationId xmlns:a16="http://schemas.microsoft.com/office/drawing/2014/main" id="{A47B84E1-07F9-484C-9517-C845E3D39EEC}"/>
               </a:ext>
             </a:extLst>
           </p:cNvPr>
@@ -12202,7 +12617,7 @@
           <p:cNvPr id="19" name="">
             <a:extLst xmlns:a="http://schemas.openxmlformats.org/drawingml/2006/main">
               <a:ext uri="{FF2B5EF4-FFF2-40B4-BE49-F238E27FC236}">
-                <a16:creationId xmlns:a16="http://schemas.microsoft.com/office/drawing/2014/main" id="{FF159D2E-1AF0-4625-9A7F-FA7002E0BC34}"/>
+                <a16:creationId xmlns:a16="http://schemas.microsoft.com/office/drawing/2014/main" id="{976C53EC-F9AB-4301-9195-5323302C3F75}"/>
               </a:ext>
             </a:extLst>
           </p:cNvPr>
@@ -12237,7 +12652,7 @@
           <p:cNvPr id="20" name="">
             <a:extLst xmlns:a="http://schemas.openxmlformats.org/drawingml/2006/main">
               <a:ext uri="{FF2B5EF4-FFF2-40B4-BE49-F238E27FC236}">
-                <a16:creationId xmlns:a16="http://schemas.microsoft.com/office/drawing/2014/main" id="{23EA3A2C-9BD5-4235-8E19-EAFDFFC81426}"/>
+                <a16:creationId xmlns:a16="http://schemas.microsoft.com/office/drawing/2014/main" id="{00FED22A-EDFC-41FC-B763-C8EACFBA5F8E}"/>
               </a:ext>
             </a:extLst>
           </p:cNvPr>
@@ -12294,7 +12709,7 @@
           <p:cNvPr id="21" name="">
             <a:extLst xmlns:a="http://schemas.openxmlformats.org/drawingml/2006/main">
               <a:ext uri="{FF2B5EF4-FFF2-40B4-BE49-F238E27FC236}">
-                <a16:creationId xmlns:a16="http://schemas.microsoft.com/office/drawing/2014/main" id="{1C5375B2-7008-472B-BE28-2832B2D14DD6}"/>
+                <a16:creationId xmlns:a16="http://schemas.microsoft.com/office/drawing/2014/main" id="{1D126529-CC25-4DF2-94AC-95E074F772E6}"/>
               </a:ext>
             </a:extLst>
           </p:cNvPr>
@@ -12329,7 +12744,7 @@
           <p:cNvPr id="22" name="">
             <a:extLst xmlns:a="http://schemas.openxmlformats.org/drawingml/2006/main">
               <a:ext uri="{FF2B5EF4-FFF2-40B4-BE49-F238E27FC236}">
-                <a16:creationId xmlns:a16="http://schemas.microsoft.com/office/drawing/2014/main" id="{50DF33ED-A708-43D0-96A1-606F815CA238}"/>
+                <a16:creationId xmlns:a16="http://schemas.microsoft.com/office/drawing/2014/main" id="{04060AFB-A8A0-4E89-B988-25EA8D0030F7}"/>
               </a:ext>
             </a:extLst>
           </p:cNvPr>
@@ -12386,7 +12801,7 @@
           <p:cNvPr id="23" name="">
             <a:extLst xmlns:a="http://schemas.openxmlformats.org/drawingml/2006/main">
               <a:ext uri="{FF2B5EF4-FFF2-40B4-BE49-F238E27FC236}">
-                <a16:creationId xmlns:a16="http://schemas.microsoft.com/office/drawing/2014/main" id="{A418F22D-FBB6-4C7E-B7C8-B3984B1D7F51}"/>
+                <a16:creationId xmlns:a16="http://schemas.microsoft.com/office/drawing/2014/main" id="{CC70046D-BE59-408D-AFD9-4FA9DDAC4120}"/>
               </a:ext>
             </a:extLst>
           </p:cNvPr>
@@ -12421,7 +12836,7 @@
           <p:cNvPr id="24" name="">
             <a:extLst xmlns:a="http://schemas.openxmlformats.org/drawingml/2006/main">
               <a:ext uri="{FF2B5EF4-FFF2-40B4-BE49-F238E27FC236}">
-                <a16:creationId xmlns:a16="http://schemas.microsoft.com/office/drawing/2014/main" id="{00C3C533-76C4-40C8-BC37-A170C010BDF8}"/>
+                <a16:creationId xmlns:a16="http://schemas.microsoft.com/office/drawing/2014/main" id="{01D568A1-81AD-4121-98DA-6FBCB54B00F6}"/>
               </a:ext>
             </a:extLst>
           </p:cNvPr>
@@ -12478,7 +12893,7 @@
           <p:cNvPr id="25" name="">
             <a:extLst xmlns:a="http://schemas.openxmlformats.org/drawingml/2006/main">
               <a:ext uri="{FF2B5EF4-FFF2-40B4-BE49-F238E27FC236}">
-                <a16:creationId xmlns:a16="http://schemas.microsoft.com/office/drawing/2014/main" id="{FF35AF1B-734E-4833-A623-4A2A52EBDF50}"/>
+                <a16:creationId xmlns:a16="http://schemas.microsoft.com/office/drawing/2014/main" id="{B985CD05-0C61-4C82-9209-96CF513626DE}"/>
               </a:ext>
             </a:extLst>
           </p:cNvPr>
@@ -12533,7 +12948,7 @@
     </p:spTree>
     <p:extLst>
       <p:ext uri="{BB962C8B-B14F-4D97-AF65-F5344CB8AC3E}">
-        <p14:creationId xmlns:p14="http://schemas.microsoft.com/office/powerpoint/2010/main" val="457478370"/>
+        <p14:creationId xmlns:p14="http://schemas.microsoft.com/office/powerpoint/2010/main" val="748176441"/>
       </p:ext>
     </p:extLst>
   </p:cSld>
@@ -12564,7 +12979,7 @@
           <p:cNvPr id="1" name="kicker-marker">
             <a:extLst xmlns:a="http://schemas.openxmlformats.org/drawingml/2006/main">
               <a:ext uri="{FF2B5EF4-FFF2-40B4-BE49-F238E27FC236}">
-                <a16:creationId xmlns:a16="http://schemas.microsoft.com/office/drawing/2014/main" id="{0724E11D-05A3-4D49-AAA7-C0B9DE68BA0D}"/>
+                <a16:creationId xmlns:a16="http://schemas.microsoft.com/office/drawing/2014/main" id="{1FC3558C-CC8E-4F92-83EF-5E34B84E43DD}"/>
               </a:ext>
             </a:extLst>
           </p:cNvPr>
@@ -12599,7 +13014,7 @@
           <p:cNvPr id="2" name="kicker-label">
             <a:extLst xmlns:a="http://schemas.openxmlformats.org/drawingml/2006/main">
               <a:ext uri="{FF2B5EF4-FFF2-40B4-BE49-F238E27FC236}">
-                <a16:creationId xmlns:a16="http://schemas.microsoft.com/office/drawing/2014/main" id="{8C31DB25-8623-4FC0-AE2C-A22D13F8C43A}"/>
+                <a16:creationId xmlns:a16="http://schemas.microsoft.com/office/drawing/2014/main" id="{8698BBB2-1C48-405D-90E8-A11A065E702F}"/>
               </a:ext>
             </a:extLst>
           </p:cNvPr>
@@ -12656,7 +13071,7 @@
           <p:cNvPr id="3" name="">
             <a:extLst xmlns:a="http://schemas.openxmlformats.org/drawingml/2006/main">
               <a:ext uri="{FF2B5EF4-FFF2-40B4-BE49-F238E27FC236}">
-                <a16:creationId xmlns:a16="http://schemas.microsoft.com/office/drawing/2014/main" id="{622BB40E-3C9E-410D-BE0E-E3258052C4D2}"/>
+                <a16:creationId xmlns:a16="http://schemas.microsoft.com/office/drawing/2014/main" id="{A2B51EBE-3C89-440A-B0FA-1DC0AF13C2B9}"/>
               </a:ext>
             </a:extLst>
           </p:cNvPr>
@@ -12713,7 +13128,7 @@
           <p:cNvPr id="4" name="">
             <a:extLst xmlns:a="http://schemas.openxmlformats.org/drawingml/2006/main">
               <a:ext uri="{FF2B5EF4-FFF2-40B4-BE49-F238E27FC236}">
-                <a16:creationId xmlns:a16="http://schemas.microsoft.com/office/drawing/2014/main" id="{C3DA2661-4F86-4913-A00A-C09342EB9E42}"/>
+                <a16:creationId xmlns:a16="http://schemas.microsoft.com/office/drawing/2014/main" id="{C6636472-8427-44AD-A3F0-94F3F6E1B1E0}"/>
               </a:ext>
             </a:extLst>
           </p:cNvPr>
@@ -12770,7 +13185,7 @@
           <p:cNvPr id="5" name="">
             <a:extLst xmlns:a="http://schemas.openxmlformats.org/drawingml/2006/main">
               <a:ext uri="{FF2B5EF4-FFF2-40B4-BE49-F238E27FC236}">
-                <a16:creationId xmlns:a16="http://schemas.microsoft.com/office/drawing/2014/main" id="{8164D85F-6FFA-4AB7-A5D5-F55D9653A4CD}"/>
+                <a16:creationId xmlns:a16="http://schemas.microsoft.com/office/drawing/2014/main" id="{CD800231-C1BC-418A-81D3-DB3D5AE11584}"/>
               </a:ext>
             </a:extLst>
           </p:cNvPr>
@@ -12805,7 +13220,7 @@
           <p:cNvPr id="6" name="">
             <a:extLst xmlns:a="http://schemas.openxmlformats.org/drawingml/2006/main">
               <a:ext uri="{FF2B5EF4-FFF2-40B4-BE49-F238E27FC236}">
-                <a16:creationId xmlns:a16="http://schemas.microsoft.com/office/drawing/2014/main" id="{7F49C819-138F-403B-A0A6-27443E33EE5C}"/>
+                <a16:creationId xmlns:a16="http://schemas.microsoft.com/office/drawing/2014/main" id="{0AEC9DAD-58CA-4E3E-98E9-95A97BDB0E3E}"/>
               </a:ext>
             </a:extLst>
           </p:cNvPr>
@@ -12862,7 +13277,7 @@
           <p:cNvPr id="7" name="">
             <a:extLst xmlns:a="http://schemas.openxmlformats.org/drawingml/2006/main">
               <a:ext uri="{FF2B5EF4-FFF2-40B4-BE49-F238E27FC236}">
-                <a16:creationId xmlns:a16="http://schemas.microsoft.com/office/drawing/2014/main" id="{03842C29-017C-4C25-802A-27C70F94A1B1}"/>
+                <a16:creationId xmlns:a16="http://schemas.microsoft.com/office/drawing/2014/main" id="{E6F5B184-F570-4958-8EC8-A2A3B56CB826}"/>
               </a:ext>
             </a:extLst>
           </p:cNvPr>
@@ -12919,7 +13334,7 @@
           <p:cNvPr id="8" name="">
             <a:extLst xmlns:a="http://schemas.openxmlformats.org/drawingml/2006/main">
               <a:ext uri="{FF2B5EF4-FFF2-40B4-BE49-F238E27FC236}">
-                <a16:creationId xmlns:a16="http://schemas.microsoft.com/office/drawing/2014/main" id="{401F06D3-2F41-47C2-A301-4F000F9FA150}"/>
+                <a16:creationId xmlns:a16="http://schemas.microsoft.com/office/drawing/2014/main" id="{EE0E25E2-5272-4D76-A864-DCF4F909E0E0}"/>
               </a:ext>
             </a:extLst>
           </p:cNvPr>
@@ -12976,7 +13391,7 @@
           <p:cNvPr id="9" name="">
             <a:extLst xmlns:a="http://schemas.openxmlformats.org/drawingml/2006/main">
               <a:ext uri="{FF2B5EF4-FFF2-40B4-BE49-F238E27FC236}">
-                <a16:creationId xmlns:a16="http://schemas.microsoft.com/office/drawing/2014/main" id="{FC1E5667-0F59-47F2-8A65-D713C47FB65F}"/>
+                <a16:creationId xmlns:a16="http://schemas.microsoft.com/office/drawing/2014/main" id="{E90FF92F-001C-4D7D-B872-3612AEB23289}"/>
               </a:ext>
             </a:extLst>
           </p:cNvPr>
@@ -13011,7 +13426,7 @@
           <p:cNvPr id="10" name="">
             <a:extLst xmlns:a="http://schemas.openxmlformats.org/drawingml/2006/main">
               <a:ext uri="{FF2B5EF4-FFF2-40B4-BE49-F238E27FC236}">
-                <a16:creationId xmlns:a16="http://schemas.microsoft.com/office/drawing/2014/main" id="{175C16E0-5DDA-4F62-948C-D556BE3F9EB7}"/>
+                <a16:creationId xmlns:a16="http://schemas.microsoft.com/office/drawing/2014/main" id="{A034ABA8-1CBF-42DA-9BB6-921DEAE5C4B8}"/>
               </a:ext>
             </a:extLst>
           </p:cNvPr>
@@ -13046,7 +13461,7 @@
           <p:cNvPr id="11" name="">
             <a:extLst xmlns:a="http://schemas.openxmlformats.org/drawingml/2006/main">
               <a:ext uri="{FF2B5EF4-FFF2-40B4-BE49-F238E27FC236}">
-                <a16:creationId xmlns:a16="http://schemas.microsoft.com/office/drawing/2014/main" id="{FF2F5A16-1FFB-4808-BE85-127ABCFCB3E2}"/>
+                <a16:creationId xmlns:a16="http://schemas.microsoft.com/office/drawing/2014/main" id="{88FC57E9-DD6A-4755-9167-315F2292EF84}"/>
               </a:ext>
             </a:extLst>
           </p:cNvPr>
@@ -13081,7 +13496,7 @@
           <p:cNvPr id="12" name="">
             <a:extLst xmlns:a="http://schemas.openxmlformats.org/drawingml/2006/main">
               <a:ext uri="{FF2B5EF4-FFF2-40B4-BE49-F238E27FC236}">
-                <a16:creationId xmlns:a16="http://schemas.microsoft.com/office/drawing/2014/main" id="{D8F3FF02-30D3-4491-B177-591E7707AD6C}"/>
+                <a16:creationId xmlns:a16="http://schemas.microsoft.com/office/drawing/2014/main" id="{01711CEA-C2AB-41F9-9E39-4784C3B3B2EB}"/>
               </a:ext>
             </a:extLst>
           </p:cNvPr>
@@ -13138,7 +13553,7 @@
           <p:cNvPr id="13" name="">
             <a:extLst xmlns:a="http://schemas.openxmlformats.org/drawingml/2006/main">
               <a:ext uri="{FF2B5EF4-FFF2-40B4-BE49-F238E27FC236}">
-                <a16:creationId xmlns:a16="http://schemas.microsoft.com/office/drawing/2014/main" id="{075728B4-C773-4F98-B348-0A4DD00C2DD0}"/>
+                <a16:creationId xmlns:a16="http://schemas.microsoft.com/office/drawing/2014/main" id="{8C15E9DB-B0DA-4F56-8051-899144CC3C18}"/>
               </a:ext>
             </a:extLst>
           </p:cNvPr>
@@ -13195,7 +13610,7 @@
           <p:cNvPr id="14" name="">
             <a:extLst xmlns:a="http://schemas.openxmlformats.org/drawingml/2006/main">
               <a:ext uri="{FF2B5EF4-FFF2-40B4-BE49-F238E27FC236}">
-                <a16:creationId xmlns:a16="http://schemas.microsoft.com/office/drawing/2014/main" id="{E201A325-0446-429C-87D4-CC89A9738A47}"/>
+                <a16:creationId xmlns:a16="http://schemas.microsoft.com/office/drawing/2014/main" id="{D12D2FB7-2CEC-4CE1-8CC3-99DC64463723}"/>
               </a:ext>
             </a:extLst>
           </p:cNvPr>
@@ -13252,7 +13667,7 @@
           <p:cNvPr id="15" name="">
             <a:extLst xmlns:a="http://schemas.openxmlformats.org/drawingml/2006/main">
               <a:ext uri="{FF2B5EF4-FFF2-40B4-BE49-F238E27FC236}">
-                <a16:creationId xmlns:a16="http://schemas.microsoft.com/office/drawing/2014/main" id="{ED579B21-33CC-40AE-A44D-FA5F2E665EAC}"/>
+                <a16:creationId xmlns:a16="http://schemas.microsoft.com/office/drawing/2014/main" id="{D6A0358F-61EB-49D2-B03A-622BA0B52F04}"/>
               </a:ext>
             </a:extLst>
           </p:cNvPr>
@@ -13287,7 +13702,7 @@
           <p:cNvPr id="16" name="">
             <a:extLst xmlns:a="http://schemas.openxmlformats.org/drawingml/2006/main">
               <a:ext uri="{FF2B5EF4-FFF2-40B4-BE49-F238E27FC236}">
-                <a16:creationId xmlns:a16="http://schemas.microsoft.com/office/drawing/2014/main" id="{045AC413-87B8-4949-AC19-777422614F0D}"/>
+                <a16:creationId xmlns:a16="http://schemas.microsoft.com/office/drawing/2014/main" id="{45850CC0-616C-4379-B478-9883646961F0}"/>
               </a:ext>
             </a:extLst>
           </p:cNvPr>
@@ -13322,7 +13737,7 @@
           <p:cNvPr id="17" name="">
             <a:extLst xmlns:a="http://schemas.openxmlformats.org/drawingml/2006/main">
               <a:ext uri="{FF2B5EF4-FFF2-40B4-BE49-F238E27FC236}">
-                <a16:creationId xmlns:a16="http://schemas.microsoft.com/office/drawing/2014/main" id="{F496BC31-94A6-4EFD-85A5-21E40A0B7C8D}"/>
+                <a16:creationId xmlns:a16="http://schemas.microsoft.com/office/drawing/2014/main" id="{18A70E90-7FB9-4692-A14E-147EA94EEB6E}"/>
               </a:ext>
             </a:extLst>
           </p:cNvPr>
@@ -13357,7 +13772,7 @@
           <p:cNvPr id="18" name="">
             <a:extLst xmlns:a="http://schemas.openxmlformats.org/drawingml/2006/main">
               <a:ext uri="{FF2B5EF4-FFF2-40B4-BE49-F238E27FC236}">
-                <a16:creationId xmlns:a16="http://schemas.microsoft.com/office/drawing/2014/main" id="{9CDD4DA5-7481-4863-8736-BF6EE66CA676}"/>
+                <a16:creationId xmlns:a16="http://schemas.microsoft.com/office/drawing/2014/main" id="{8C7C0E3E-886B-4D26-9255-63B305157949}"/>
               </a:ext>
             </a:extLst>
           </p:cNvPr>
@@ -13414,7 +13829,7 @@
           <p:cNvPr id="19" name="">
             <a:extLst xmlns:a="http://schemas.openxmlformats.org/drawingml/2006/main">
               <a:ext uri="{FF2B5EF4-FFF2-40B4-BE49-F238E27FC236}">
-                <a16:creationId xmlns:a16="http://schemas.microsoft.com/office/drawing/2014/main" id="{AB7FDA15-DDD1-457D-A416-DDB4D3174552}"/>
+                <a16:creationId xmlns:a16="http://schemas.microsoft.com/office/drawing/2014/main" id="{0FA40D79-1F0C-4F4F-B83B-DA312E82632A}"/>
               </a:ext>
             </a:extLst>
           </p:cNvPr>
@@ -13471,7 +13886,7 @@
           <p:cNvPr id="20" name="">
             <a:extLst xmlns:a="http://schemas.openxmlformats.org/drawingml/2006/main">
               <a:ext uri="{FF2B5EF4-FFF2-40B4-BE49-F238E27FC236}">
-                <a16:creationId xmlns:a16="http://schemas.microsoft.com/office/drawing/2014/main" id="{F3AA4664-7A5A-45E8-A28F-2DCD99BD9BE5}"/>
+                <a16:creationId xmlns:a16="http://schemas.microsoft.com/office/drawing/2014/main" id="{189718E7-AA85-4E00-B0C9-6A62DEE64307}"/>
               </a:ext>
             </a:extLst>
           </p:cNvPr>
@@ -13528,7 +13943,7 @@
           <p:cNvPr id="21" name="">
             <a:extLst xmlns:a="http://schemas.openxmlformats.org/drawingml/2006/main">
               <a:ext uri="{FF2B5EF4-FFF2-40B4-BE49-F238E27FC236}">
-                <a16:creationId xmlns:a16="http://schemas.microsoft.com/office/drawing/2014/main" id="{002AFE7B-3B28-4C97-A62C-C760248B8D7D}"/>
+                <a16:creationId xmlns:a16="http://schemas.microsoft.com/office/drawing/2014/main" id="{E3C524EF-293D-4401-935A-E42CA2CD8D71}"/>
               </a:ext>
             </a:extLst>
           </p:cNvPr>
@@ -13563,7 +13978,7 @@
           <p:cNvPr id="22" name="">
             <a:extLst xmlns:a="http://schemas.openxmlformats.org/drawingml/2006/main">
               <a:ext uri="{FF2B5EF4-FFF2-40B4-BE49-F238E27FC236}">
-                <a16:creationId xmlns:a16="http://schemas.microsoft.com/office/drawing/2014/main" id="{67E6C76C-B505-456A-B146-486FF49C62D7}"/>
+                <a16:creationId xmlns:a16="http://schemas.microsoft.com/office/drawing/2014/main" id="{AC3B26B7-EE27-4F48-92C3-99EB6045C0E8}"/>
               </a:ext>
             </a:extLst>
           </p:cNvPr>
@@ -13598,7 +14013,7 @@
           <p:cNvPr id="23" name="">
             <a:extLst xmlns:a="http://schemas.openxmlformats.org/drawingml/2006/main">
               <a:ext uri="{FF2B5EF4-FFF2-40B4-BE49-F238E27FC236}">
-                <a16:creationId xmlns:a16="http://schemas.microsoft.com/office/drawing/2014/main" id="{3A614B08-8FB1-463C-9810-1AFD96976849}"/>
+                <a16:creationId xmlns:a16="http://schemas.microsoft.com/office/drawing/2014/main" id="{70F248C4-7118-4953-A66D-1DA6274EBC80}"/>
               </a:ext>
             </a:extLst>
           </p:cNvPr>
@@ -13633,7 +14048,7 @@
           <p:cNvPr id="24" name="">
             <a:extLst xmlns:a="http://schemas.openxmlformats.org/drawingml/2006/main">
               <a:ext uri="{FF2B5EF4-FFF2-40B4-BE49-F238E27FC236}">
-                <a16:creationId xmlns:a16="http://schemas.microsoft.com/office/drawing/2014/main" id="{BEF182CF-E5A4-45FB-B9FD-143C0DBDB2F0}"/>
+                <a16:creationId xmlns:a16="http://schemas.microsoft.com/office/drawing/2014/main" id="{36383491-C224-4D78-A6B3-229D1D77103B}"/>
               </a:ext>
             </a:extLst>
           </p:cNvPr>
@@ -13690,7 +14105,7 @@
           <p:cNvPr id="25" name="">
             <a:extLst xmlns:a="http://schemas.openxmlformats.org/drawingml/2006/main">
               <a:ext uri="{FF2B5EF4-FFF2-40B4-BE49-F238E27FC236}">
-                <a16:creationId xmlns:a16="http://schemas.microsoft.com/office/drawing/2014/main" id="{669AD8D3-E6DD-499E-B92C-1FFF6D9DD051}"/>
+                <a16:creationId xmlns:a16="http://schemas.microsoft.com/office/drawing/2014/main" id="{F6664426-B85B-406C-B38E-DFD656731FF0}"/>
               </a:ext>
             </a:extLst>
           </p:cNvPr>
@@ -13747,7 +14162,7 @@
           <p:cNvPr id="26" name="">
             <a:extLst xmlns:a="http://schemas.openxmlformats.org/drawingml/2006/main">
               <a:ext uri="{FF2B5EF4-FFF2-40B4-BE49-F238E27FC236}">
-                <a16:creationId xmlns:a16="http://schemas.microsoft.com/office/drawing/2014/main" id="{CAD0194E-42AE-4698-A91C-31CBC7FCC4A3}"/>
+                <a16:creationId xmlns:a16="http://schemas.microsoft.com/office/drawing/2014/main" id="{CE19C442-8370-4211-8E22-7989B84B7CC6}"/>
               </a:ext>
             </a:extLst>
           </p:cNvPr>
@@ -13804,7 +14219,7 @@
           <p:cNvPr id="27" name="">
             <a:extLst xmlns:a="http://schemas.openxmlformats.org/drawingml/2006/main">
               <a:ext uri="{FF2B5EF4-FFF2-40B4-BE49-F238E27FC236}">
-                <a16:creationId xmlns:a16="http://schemas.microsoft.com/office/drawing/2014/main" id="{28BFE789-F3EA-4D8F-AB46-4E4987210A33}"/>
+                <a16:creationId xmlns:a16="http://schemas.microsoft.com/office/drawing/2014/main" id="{E3AD43B5-10E3-460E-AB34-BA21108AC5AD}"/>
               </a:ext>
             </a:extLst>
           </p:cNvPr>
@@ -13839,7 +14254,7 @@
           <p:cNvPr id="28" name="">
             <a:extLst xmlns:a="http://schemas.openxmlformats.org/drawingml/2006/main">
               <a:ext uri="{FF2B5EF4-FFF2-40B4-BE49-F238E27FC236}">
-                <a16:creationId xmlns:a16="http://schemas.microsoft.com/office/drawing/2014/main" id="{B8B93B59-005F-4E89-9A01-48AA16FA0656}"/>
+                <a16:creationId xmlns:a16="http://schemas.microsoft.com/office/drawing/2014/main" id="{F0017A7F-EF39-430F-A4E5-818F3BF0744D}"/>
               </a:ext>
             </a:extLst>
           </p:cNvPr>
@@ -13874,7 +14289,7 @@
           <p:cNvPr id="29" name="">
             <a:extLst xmlns:a="http://schemas.openxmlformats.org/drawingml/2006/main">
               <a:ext uri="{FF2B5EF4-FFF2-40B4-BE49-F238E27FC236}">
-                <a16:creationId xmlns:a16="http://schemas.microsoft.com/office/drawing/2014/main" id="{B0A27065-FA6E-458D-9FDC-32506D72ED0C}"/>
+                <a16:creationId xmlns:a16="http://schemas.microsoft.com/office/drawing/2014/main" id="{49B5767C-5CEB-4491-AF8A-7B48B96CB53B}"/>
               </a:ext>
             </a:extLst>
           </p:cNvPr>
@@ -13909,7 +14324,7 @@
           <p:cNvPr id="30" name="">
             <a:extLst xmlns:a="http://schemas.openxmlformats.org/drawingml/2006/main">
               <a:ext uri="{FF2B5EF4-FFF2-40B4-BE49-F238E27FC236}">
-                <a16:creationId xmlns:a16="http://schemas.microsoft.com/office/drawing/2014/main" id="{B7B553B8-28CB-4178-8F92-0267B832622E}"/>
+                <a16:creationId xmlns:a16="http://schemas.microsoft.com/office/drawing/2014/main" id="{31BCD6F2-AC27-40AE-91EE-6FDA39B565A7}"/>
               </a:ext>
             </a:extLst>
           </p:cNvPr>
@@ -13966,7 +14381,7 @@
           <p:cNvPr id="31" name="">
             <a:extLst xmlns:a="http://schemas.openxmlformats.org/drawingml/2006/main">
               <a:ext uri="{FF2B5EF4-FFF2-40B4-BE49-F238E27FC236}">
-                <a16:creationId xmlns:a16="http://schemas.microsoft.com/office/drawing/2014/main" id="{C008DE13-FB34-4A0B-B53D-56E152E73EF1}"/>
+                <a16:creationId xmlns:a16="http://schemas.microsoft.com/office/drawing/2014/main" id="{7F9FA883-C676-4B35-8AC4-08674F068308}"/>
               </a:ext>
             </a:extLst>
           </p:cNvPr>
@@ -14023,7 +14438,7 @@
           <p:cNvPr id="32" name="">
             <a:extLst xmlns:a="http://schemas.openxmlformats.org/drawingml/2006/main">
               <a:ext uri="{FF2B5EF4-FFF2-40B4-BE49-F238E27FC236}">
-                <a16:creationId xmlns:a16="http://schemas.microsoft.com/office/drawing/2014/main" id="{4CD94E1B-F730-4122-9B29-C697D23A8B3B}"/>
+                <a16:creationId xmlns:a16="http://schemas.microsoft.com/office/drawing/2014/main" id="{47DB070C-8EC6-43B9-8F51-87252286C720}"/>
               </a:ext>
             </a:extLst>
           </p:cNvPr>
@@ -14080,7 +14495,7 @@
           <p:cNvPr id="33" name="">
             <a:extLst xmlns:a="http://schemas.openxmlformats.org/drawingml/2006/main">
               <a:ext uri="{FF2B5EF4-FFF2-40B4-BE49-F238E27FC236}">
-                <a16:creationId xmlns:a16="http://schemas.microsoft.com/office/drawing/2014/main" id="{933DBE73-56E5-4CEE-BDB0-D4D50F9C4260}"/>
+                <a16:creationId xmlns:a16="http://schemas.microsoft.com/office/drawing/2014/main" id="{0611CA34-F4AC-4C86-B917-CE969DF0094D}"/>
               </a:ext>
             </a:extLst>
           </p:cNvPr>
@@ -14115,7 +14530,7 @@
           <p:cNvPr id="34" name="">
             <a:extLst xmlns:a="http://schemas.openxmlformats.org/drawingml/2006/main">
               <a:ext uri="{FF2B5EF4-FFF2-40B4-BE49-F238E27FC236}">
-                <a16:creationId xmlns:a16="http://schemas.microsoft.com/office/drawing/2014/main" id="{A574B410-C452-4E73-9954-4FEA7CF26804}"/>
+                <a16:creationId xmlns:a16="http://schemas.microsoft.com/office/drawing/2014/main" id="{7FE5532A-D3AE-4EB2-9A77-2C7823E88C06}"/>
               </a:ext>
             </a:extLst>
           </p:cNvPr>
@@ -14150,7 +14565,7 @@
           <p:cNvPr id="35" name="">
             <a:extLst xmlns:a="http://schemas.openxmlformats.org/drawingml/2006/main">
               <a:ext uri="{FF2B5EF4-FFF2-40B4-BE49-F238E27FC236}">
-                <a16:creationId xmlns:a16="http://schemas.microsoft.com/office/drawing/2014/main" id="{7C79090F-1215-4230-AC61-EBCCFA3EA79B}"/>
+                <a16:creationId xmlns:a16="http://schemas.microsoft.com/office/drawing/2014/main" id="{6C8FBAD2-158D-4D85-886C-24789054B07C}"/>
               </a:ext>
             </a:extLst>
           </p:cNvPr>
@@ -14185,7 +14600,7 @@
           <p:cNvPr id="36" name="">
             <a:extLst xmlns:a="http://schemas.openxmlformats.org/drawingml/2006/main">
               <a:ext uri="{FF2B5EF4-FFF2-40B4-BE49-F238E27FC236}">
-                <a16:creationId xmlns:a16="http://schemas.microsoft.com/office/drawing/2014/main" id="{34A74B7F-41C1-44B0-BA57-0B65CAB70447}"/>
+                <a16:creationId xmlns:a16="http://schemas.microsoft.com/office/drawing/2014/main" id="{446D6CAC-805B-4B67-8334-5B8CCA2A3721}"/>
               </a:ext>
             </a:extLst>
           </p:cNvPr>
@@ -14242,7 +14657,7 @@
           <p:cNvPr id="37" name="">
             <a:extLst xmlns:a="http://schemas.openxmlformats.org/drawingml/2006/main">
               <a:ext uri="{FF2B5EF4-FFF2-40B4-BE49-F238E27FC236}">
-                <a16:creationId xmlns:a16="http://schemas.microsoft.com/office/drawing/2014/main" id="{D5753302-94D0-4F68-B9BE-A3C55098ED47}"/>
+                <a16:creationId xmlns:a16="http://schemas.microsoft.com/office/drawing/2014/main" id="{9D4D408B-3B4A-408F-8841-0F770F403387}"/>
               </a:ext>
             </a:extLst>
           </p:cNvPr>
@@ -14299,7 +14714,7 @@
           <p:cNvPr id="38" name="">
             <a:extLst xmlns:a="http://schemas.openxmlformats.org/drawingml/2006/main">
               <a:ext uri="{FF2B5EF4-FFF2-40B4-BE49-F238E27FC236}">
-                <a16:creationId xmlns:a16="http://schemas.microsoft.com/office/drawing/2014/main" id="{F5C16DC3-F04E-423D-954F-522D5213B8A7}"/>
+                <a16:creationId xmlns:a16="http://schemas.microsoft.com/office/drawing/2014/main" id="{08E20902-48A4-4664-B4F2-86C115032923}"/>
               </a:ext>
             </a:extLst>
           </p:cNvPr>
@@ -14354,7 +14769,7 @@
     </p:spTree>
     <p:extLst>
       <p:ext uri="{BB962C8B-B14F-4D97-AF65-F5344CB8AC3E}">
-        <p14:creationId xmlns:p14="http://schemas.microsoft.com/office/powerpoint/2010/main" val="1998164316"/>
+        <p14:creationId xmlns:p14="http://schemas.microsoft.com/office/powerpoint/2010/main" val="51318876"/>
       </p:ext>
     </p:extLst>
   </p:cSld>
@@ -14385,7 +14800,7 @@
           <p:cNvPr id="1" name="kicker-marker">
             <a:extLst xmlns:a="http://schemas.openxmlformats.org/drawingml/2006/main">
               <a:ext uri="{FF2B5EF4-FFF2-40B4-BE49-F238E27FC236}">
-                <a16:creationId xmlns:a16="http://schemas.microsoft.com/office/drawing/2014/main" id="{A97D208D-FA6D-4F30-9F19-0A6F357E4F21}"/>
+                <a16:creationId xmlns:a16="http://schemas.microsoft.com/office/drawing/2014/main" id="{B330DB40-42FA-437B-8A9C-96DCDAEA9CD1}"/>
               </a:ext>
             </a:extLst>
           </p:cNvPr>
@@ -14420,7 +14835,7 @@
           <p:cNvPr id="2" name="kicker-label">
             <a:extLst xmlns:a="http://schemas.openxmlformats.org/drawingml/2006/main">
               <a:ext uri="{FF2B5EF4-FFF2-40B4-BE49-F238E27FC236}">
-                <a16:creationId xmlns:a16="http://schemas.microsoft.com/office/drawing/2014/main" id="{7A8B8868-5AFF-4237-8288-E642D5A978B4}"/>
+                <a16:creationId xmlns:a16="http://schemas.microsoft.com/office/drawing/2014/main" id="{2982BD62-6E0D-4E3B-B683-671D4EDCF4C1}"/>
               </a:ext>
             </a:extLst>
           </p:cNvPr>
@@ -14477,7 +14892,7 @@
           <p:cNvPr id="3" name="">
             <a:extLst xmlns:a="http://schemas.openxmlformats.org/drawingml/2006/main">
               <a:ext uri="{FF2B5EF4-FFF2-40B4-BE49-F238E27FC236}">
-                <a16:creationId xmlns:a16="http://schemas.microsoft.com/office/drawing/2014/main" id="{3476E3E6-2D6F-4151-BB91-85E68AEC95D1}"/>
+                <a16:creationId xmlns:a16="http://schemas.microsoft.com/office/drawing/2014/main" id="{D7149AC6-C8E6-4704-9AD7-7FF56BA64D2C}"/>
               </a:ext>
             </a:extLst>
           </p:cNvPr>
@@ -14534,7 +14949,7 @@
           <p:cNvPr id="4" name="">
             <a:extLst xmlns:a="http://schemas.openxmlformats.org/drawingml/2006/main">
               <a:ext uri="{FF2B5EF4-FFF2-40B4-BE49-F238E27FC236}">
-                <a16:creationId xmlns:a16="http://schemas.microsoft.com/office/drawing/2014/main" id="{A691D33C-6B2F-4B5A-8747-D4D0A32424F9}"/>
+                <a16:creationId xmlns:a16="http://schemas.microsoft.com/office/drawing/2014/main" id="{B6C19CC4-B079-4F44-A24B-0C11C3DBCB24}"/>
               </a:ext>
             </a:extLst>
           </p:cNvPr>
@@ -14569,7 +14984,7 @@
           <p:cNvPr id="5" name="">
             <a:extLst xmlns:a="http://schemas.openxmlformats.org/drawingml/2006/main">
               <a:ext uri="{FF2B5EF4-FFF2-40B4-BE49-F238E27FC236}">
-                <a16:creationId xmlns:a16="http://schemas.microsoft.com/office/drawing/2014/main" id="{BDDCC4A6-3374-42FF-9130-189DBEF0D8F3}"/>
+                <a16:creationId xmlns:a16="http://schemas.microsoft.com/office/drawing/2014/main" id="{3B54682A-0557-4A44-AF15-3B944A610B84}"/>
               </a:ext>
             </a:extLst>
           </p:cNvPr>
@@ -14626,7 +15041,7 @@
           <p:cNvPr id="6" name="">
             <a:extLst xmlns:a="http://schemas.openxmlformats.org/drawingml/2006/main">
               <a:ext uri="{FF2B5EF4-FFF2-40B4-BE49-F238E27FC236}">
-                <a16:creationId xmlns:a16="http://schemas.microsoft.com/office/drawing/2014/main" id="{D53299D2-A390-4902-8D18-59D1E0C9F4F3}"/>
+                <a16:creationId xmlns:a16="http://schemas.microsoft.com/office/drawing/2014/main" id="{6954CB5B-D61D-48B5-A906-8E2A320C9B4F}"/>
               </a:ext>
             </a:extLst>
           </p:cNvPr>
@@ -14683,7 +15098,7 @@
           <p:cNvPr id="7" name="">
             <a:extLst xmlns:a="http://schemas.openxmlformats.org/drawingml/2006/main">
               <a:ext uri="{FF2B5EF4-FFF2-40B4-BE49-F238E27FC236}">
-                <a16:creationId xmlns:a16="http://schemas.microsoft.com/office/drawing/2014/main" id="{373F3C85-1D29-4699-B96B-B1015787037D}"/>
+                <a16:creationId xmlns:a16="http://schemas.microsoft.com/office/drawing/2014/main" id="{F6270C39-3B43-429A-BE5F-02822BD966EB}"/>
               </a:ext>
             </a:extLst>
           </p:cNvPr>
@@ -14718,7 +15133,7 @@
           <p:cNvPr id="8" name="">
             <a:extLst xmlns:a="http://schemas.openxmlformats.org/drawingml/2006/main">
               <a:ext uri="{FF2B5EF4-FFF2-40B4-BE49-F238E27FC236}">
-                <a16:creationId xmlns:a16="http://schemas.microsoft.com/office/drawing/2014/main" id="{3B01FF8C-898F-4F06-B888-8B5B4CC25D77}"/>
+                <a16:creationId xmlns:a16="http://schemas.microsoft.com/office/drawing/2014/main" id="{C11B1482-A4A8-4D20-A75F-4C41E477B2B3}"/>
               </a:ext>
             </a:extLst>
           </p:cNvPr>
@@ -14775,7 +15190,7 @@
           <p:cNvPr id="9" name="">
             <a:extLst xmlns:a="http://schemas.openxmlformats.org/drawingml/2006/main">
               <a:ext uri="{FF2B5EF4-FFF2-40B4-BE49-F238E27FC236}">
-                <a16:creationId xmlns:a16="http://schemas.microsoft.com/office/drawing/2014/main" id="{2ED262A8-FED2-4864-96A6-0C6E9AE99ABD}"/>
+                <a16:creationId xmlns:a16="http://schemas.microsoft.com/office/drawing/2014/main" id="{D10F2424-DF40-4470-A25C-06F474D89BAE}"/>
               </a:ext>
             </a:extLst>
           </p:cNvPr>
@@ -14832,7 +15247,7 @@
           <p:cNvPr id="10" name="">
             <a:extLst xmlns:a="http://schemas.openxmlformats.org/drawingml/2006/main">
               <a:ext uri="{FF2B5EF4-FFF2-40B4-BE49-F238E27FC236}">
-                <a16:creationId xmlns:a16="http://schemas.microsoft.com/office/drawing/2014/main" id="{DD0227AF-466C-4EF4-99B8-F2707233B8A5}"/>
+                <a16:creationId xmlns:a16="http://schemas.microsoft.com/office/drawing/2014/main" id="{1FF4B613-F870-4134-B627-E17398B93FAD}"/>
               </a:ext>
             </a:extLst>
           </p:cNvPr>
@@ -14867,7 +15282,7 @@
           <p:cNvPr id="11" name="">
             <a:extLst xmlns:a="http://schemas.openxmlformats.org/drawingml/2006/main">
               <a:ext uri="{FF2B5EF4-FFF2-40B4-BE49-F238E27FC236}">
-                <a16:creationId xmlns:a16="http://schemas.microsoft.com/office/drawing/2014/main" id="{5458409C-1D2A-4E34-97D4-2BB583ED07A6}"/>
+                <a16:creationId xmlns:a16="http://schemas.microsoft.com/office/drawing/2014/main" id="{F47B69BC-CFFB-4A3C-A272-3FCF2972B780}"/>
               </a:ext>
             </a:extLst>
           </p:cNvPr>
@@ -14924,7 +15339,7 @@
           <p:cNvPr id="12" name="">
             <a:extLst xmlns:a="http://schemas.openxmlformats.org/drawingml/2006/main">
               <a:ext uri="{FF2B5EF4-FFF2-40B4-BE49-F238E27FC236}">
-                <a16:creationId xmlns:a16="http://schemas.microsoft.com/office/drawing/2014/main" id="{30C6E69B-9806-4146-BA31-E749900C0865}"/>
+                <a16:creationId xmlns:a16="http://schemas.microsoft.com/office/drawing/2014/main" id="{6B0891FB-4D12-4BCF-A60C-29529D29E3C5}"/>
               </a:ext>
             </a:extLst>
           </p:cNvPr>
@@ -14981,7 +15396,7 @@
           <p:cNvPr id="13" name="">
             <a:extLst xmlns:a="http://schemas.openxmlformats.org/drawingml/2006/main">
               <a:ext uri="{FF2B5EF4-FFF2-40B4-BE49-F238E27FC236}">
-                <a16:creationId xmlns:a16="http://schemas.microsoft.com/office/drawing/2014/main" id="{6023D5E9-1D32-4097-A977-DAA1D1551836}"/>
+                <a16:creationId xmlns:a16="http://schemas.microsoft.com/office/drawing/2014/main" id="{6BEA0C36-442E-44DE-97B8-0A980C32E427}"/>
               </a:ext>
             </a:extLst>
           </p:cNvPr>
@@ -15016,7 +15431,7 @@
           <p:cNvPr id="14" name="">
             <a:extLst xmlns:a="http://schemas.openxmlformats.org/drawingml/2006/main">
               <a:ext uri="{FF2B5EF4-FFF2-40B4-BE49-F238E27FC236}">
-                <a16:creationId xmlns:a16="http://schemas.microsoft.com/office/drawing/2014/main" id="{42A8B9C3-57C2-47B6-B089-C89844B1A02C}"/>
+                <a16:creationId xmlns:a16="http://schemas.microsoft.com/office/drawing/2014/main" id="{A1B49A86-1426-4C11-B5C1-B9FC500EFC63}"/>
               </a:ext>
             </a:extLst>
           </p:cNvPr>
@@ -15073,7 +15488,7 @@
           <p:cNvPr id="15" name="">
             <a:extLst xmlns:a="http://schemas.openxmlformats.org/drawingml/2006/main">
               <a:ext uri="{FF2B5EF4-FFF2-40B4-BE49-F238E27FC236}">
-                <a16:creationId xmlns:a16="http://schemas.microsoft.com/office/drawing/2014/main" id="{2235ABE4-0197-4E0C-89FD-2CEB591C81E8}"/>
+                <a16:creationId xmlns:a16="http://schemas.microsoft.com/office/drawing/2014/main" id="{6B35E8F2-E622-4486-A1C6-634143480B1F}"/>
               </a:ext>
             </a:extLst>
           </p:cNvPr>
@@ -15130,7 +15545,7 @@
           <p:cNvPr id="16" name="">
             <a:extLst xmlns:a="http://schemas.openxmlformats.org/drawingml/2006/main">
               <a:ext uri="{FF2B5EF4-FFF2-40B4-BE49-F238E27FC236}">
-                <a16:creationId xmlns:a16="http://schemas.microsoft.com/office/drawing/2014/main" id="{86A4F0C7-37F6-4A00-8A5F-06E5CDF09690}"/>
+                <a16:creationId xmlns:a16="http://schemas.microsoft.com/office/drawing/2014/main" id="{5807062B-3295-4499-9292-8DF23EA32303}"/>
               </a:ext>
             </a:extLst>
           </p:cNvPr>
@@ -15165,7 +15580,7 @@
           <p:cNvPr id="17" name="">
             <a:extLst xmlns:a="http://schemas.openxmlformats.org/drawingml/2006/main">
               <a:ext uri="{FF2B5EF4-FFF2-40B4-BE49-F238E27FC236}">
-                <a16:creationId xmlns:a16="http://schemas.microsoft.com/office/drawing/2014/main" id="{69792559-9FA2-47C0-977A-EA238B542210}"/>
+                <a16:creationId xmlns:a16="http://schemas.microsoft.com/office/drawing/2014/main" id="{9A4ACE3B-B9DC-4FE0-9520-AC49228065BC}"/>
               </a:ext>
             </a:extLst>
           </p:cNvPr>
@@ -15222,7 +15637,7 @@
           <p:cNvPr id="18" name="">
             <a:extLst xmlns:a="http://schemas.openxmlformats.org/drawingml/2006/main">
               <a:ext uri="{FF2B5EF4-FFF2-40B4-BE49-F238E27FC236}">
-                <a16:creationId xmlns:a16="http://schemas.microsoft.com/office/drawing/2014/main" id="{2AC1517F-9B03-4CED-9D74-4ECCCDB5CD17}"/>
+                <a16:creationId xmlns:a16="http://schemas.microsoft.com/office/drawing/2014/main" id="{CC4B7955-3EC4-42EC-B51F-25351B30FF51}"/>
               </a:ext>
             </a:extLst>
           </p:cNvPr>
@@ -15279,7 +15694,7 @@
           <p:cNvPr id="19" name="">
             <a:extLst xmlns:a="http://schemas.openxmlformats.org/drawingml/2006/main">
               <a:ext uri="{FF2B5EF4-FFF2-40B4-BE49-F238E27FC236}">
-                <a16:creationId xmlns:a16="http://schemas.microsoft.com/office/drawing/2014/main" id="{817CC679-C914-41A7-8DC0-30E41F79413A}"/>
+                <a16:creationId xmlns:a16="http://schemas.microsoft.com/office/drawing/2014/main" id="{FACB19C4-6E06-4B0B-91E4-D855A95D976C}"/>
               </a:ext>
             </a:extLst>
           </p:cNvPr>
@@ -15314,7 +15729,7 @@
           <p:cNvPr id="20" name="">
             <a:extLst xmlns:a="http://schemas.openxmlformats.org/drawingml/2006/main">
               <a:ext uri="{FF2B5EF4-FFF2-40B4-BE49-F238E27FC236}">
-                <a16:creationId xmlns:a16="http://schemas.microsoft.com/office/drawing/2014/main" id="{5A39AD36-5F91-478D-B903-61C4435A1F4D}"/>
+                <a16:creationId xmlns:a16="http://schemas.microsoft.com/office/drawing/2014/main" id="{2694B827-7F72-44C4-83C6-8CEC93E3776E}"/>
               </a:ext>
             </a:extLst>
           </p:cNvPr>
@@ -15398,7 +15813,7 @@
           <p:cNvPr id="21" name="">
             <a:extLst xmlns:a="http://schemas.openxmlformats.org/drawingml/2006/main">
               <a:ext uri="{FF2B5EF4-FFF2-40B4-BE49-F238E27FC236}">
-                <a16:creationId xmlns:a16="http://schemas.microsoft.com/office/drawing/2014/main" id="{8BF8233D-529E-4AD3-B22C-731965CFC92B}"/>
+                <a16:creationId xmlns:a16="http://schemas.microsoft.com/office/drawing/2014/main" id="{8F265578-D2F8-430A-9FCB-D859A95CCC88}"/>
               </a:ext>
             </a:extLst>
           </p:cNvPr>
@@ -15482,7 +15897,7 @@
           <p:cNvPr id="22" name="">
             <a:extLst xmlns:a="http://schemas.openxmlformats.org/drawingml/2006/main">
               <a:ext uri="{FF2B5EF4-FFF2-40B4-BE49-F238E27FC236}">
-                <a16:creationId xmlns:a16="http://schemas.microsoft.com/office/drawing/2014/main" id="{9079F705-8E7E-433F-AA11-7507B8A04485}"/>
+                <a16:creationId xmlns:a16="http://schemas.microsoft.com/office/drawing/2014/main" id="{2C560490-D20D-496C-A7E8-4CC66A0D72C0}"/>
               </a:ext>
             </a:extLst>
           </p:cNvPr>
@@ -15539,7 +15954,7 @@
           <p:cNvPr id="23" name="">
             <a:extLst xmlns:a="http://schemas.openxmlformats.org/drawingml/2006/main">
               <a:ext uri="{FF2B5EF4-FFF2-40B4-BE49-F238E27FC236}">
-                <a16:creationId xmlns:a16="http://schemas.microsoft.com/office/drawing/2014/main" id="{D54B08AA-3AEB-4080-9B32-5243E6E8AAFC}"/>
+                <a16:creationId xmlns:a16="http://schemas.microsoft.com/office/drawing/2014/main" id="{876A345A-B3FA-4C28-BC25-AEB62518E4CE}"/>
               </a:ext>
             </a:extLst>
           </p:cNvPr>
@@ -15594,7 +16009,7 @@
     </p:spTree>
     <p:extLst>
       <p:ext uri="{BB962C8B-B14F-4D97-AF65-F5344CB8AC3E}">
-        <p14:creationId xmlns:p14="http://schemas.microsoft.com/office/powerpoint/2010/main" val="1189601620"/>
+        <p14:creationId xmlns:p14="http://schemas.microsoft.com/office/powerpoint/2010/main" val="2107931043"/>
       </p:ext>
     </p:extLst>
   </p:cSld>

</xml_diff>